<commit_message>
CLI: `python -m lightup` with no arguments opens the game
The play command's puzzle file is now optional (omitted -> a fresh random
10x10 medium board), and a bare `python -m lightup` defaults to play.
README updated.

Co-Authored-By: Claude Fable 5 <noreply@anthropic.com>
</commit_message>
<xml_diff>
--- a/presentation.pptx
+++ b/presentation.pptx
@@ -4,6 +4,9 @@
   <p:sldMasterIdLst>
     <p:sldMasterId id="2147483648" r:id="rId1"/>
   </p:sldMasterIdLst>
+  <p:notesMasterIdLst>
+    <p:notesMasterId r:id="rId14"/>
+  </p:notesMasterIdLst>
   <p:sldIdLst>
     <p:sldId id="256" r:id="rId2"/>
     <p:sldId id="257" r:id="rId3"/>
@@ -18,9 +21,6 @@
     <p:sldId id="266" r:id="rId12"/>
     <p:sldId id="267" r:id="rId13"/>
   </p:sldIdLst>
-  <p:notesMasterIdLst>
-    <p:notesMasterId r:id="rId14"/>
-  </p:notesMasterIdLst>
   <p:sldSz cx="12192000" cy="6858000"/>
   <p:notesSz cx="6858000" cy="12192000"/>
   <p:defaultTextStyle>
@@ -115,6 +115,11 @@
       </a:defRPr>
     </a:lvl9pPr>
   </p:defaultTextStyle>
+  <p:extLst>
+    <p:ext uri="{EFAFB233-063F-42B5-8137-9DF3F51BA10A}">
+      <p15:sldGuideLst xmlns:p15="http://schemas.microsoft.com/office/powerpoint/2012/main"/>
+    </p:ext>
+  </p:extLst>
 </p:presentation>
 </file>
 
@@ -140,234 +145,10 @@
           <a:chExt cx="0" cy="0"/>
         </a:xfrm>
       </p:grpSpPr>
-      <p:sp>
-        <p:nvSpPr>
-          <p:cNvPr id="2" name="Header Placeholder 1"/>
-          <p:cNvSpPr>
-            <a:spLocks noGrp="1"/>
-          </p:cNvSpPr>
-          <p:nvPr>
-            <p:ph type="hdr" sz="quarter"/>
-          </p:nvPr>
-        </p:nvSpPr>
-        <p:spPr>
-          <a:xfrm>
-            <a:off x="0" y="0"/>
-            <a:ext cx="2971800" cy="458788"/>
-          </a:xfrm>
-          <a:prstGeom prst="rect">
-            <a:avLst/>
-          </a:prstGeom>
-        </p:spPr>
-        <p:txBody>
-          <a:bodyPr vert="horz" lIns="91440" tIns="45720" rIns="91440" bIns="45720" rtlCol="0"/>
-          <a:lstStyle>
-            <a:lvl1pPr algn="l">
-              <a:defRPr sz="1200"/>
-            </a:lvl1pPr>
-          </a:lstStyle>
-          <a:p>
-            <a:endParaRPr lang="en-US"/>
-          </a:p>
-        </p:txBody>
-      </p:sp>
-      <p:sp>
-        <p:nvSpPr>
-          <p:cNvPr id="3" name="Date Placeholder 2"/>
-          <p:cNvSpPr>
-            <a:spLocks noGrp="1"/>
-          </p:cNvSpPr>
-          <p:nvPr>
-            <p:ph type="dt" idx="1"/>
-          </p:nvPr>
-        </p:nvSpPr>
-        <p:spPr>
-          <a:xfrm>
-            <a:off x="3884613" y="0"/>
-            <a:ext cx="2971800" cy="458788"/>
-          </a:xfrm>
-          <a:prstGeom prst="rect">
-            <a:avLst/>
-          </a:prstGeom>
-        </p:spPr>
-        <p:txBody>
-          <a:bodyPr vert="horz" lIns="91440" tIns="45720" rIns="91440" bIns="45720" rtlCol="0"/>
-          <a:lstStyle>
-            <a:lvl1pPr algn="r">
-              <a:defRPr sz="1200"/>
-            </a:lvl1pPr>
-          </a:lstStyle>
-          <a:p>
-            <a:fld id="{5282F153-3F37-0F45-9E97-73ACFA13230C}" type="datetimeFigureOut">
-              <a:rPr lang="en-US"/>
-              <a:t>7/23/19</a:t>
-            </a:fld>
-            <a:endParaRPr lang="en-US"/>
-          </a:p>
-        </p:txBody>
-      </p:sp>
-      <p:sp>
-        <p:nvSpPr>
-          <p:cNvPr id="4" name="Slide Image Placeholder 3"/>
-          <p:cNvSpPr>
-            <a:spLocks noGrp="1" noRot="1" noChangeAspect="1"/>
-          </p:cNvSpPr>
-          <p:nvPr>
-            <p:ph type="sldImg" idx="2"/>
-          </p:nvPr>
-        </p:nvSpPr>
-        <p:spPr>
-          <a:xfrm>
-            <a:off x="685800" y="1143000"/>
-            <a:ext cx="5486400" cy="3086100"/>
-          </a:xfrm>
-          <a:prstGeom prst="rect">
-            <a:avLst/>
-          </a:prstGeom>
-          <a:noFill/>
-          <a:ln w="12700">
-            <a:solidFill>
-              <a:prstClr val="black"/>
-            </a:solidFill>
-          </a:ln>
-        </p:spPr>
-        <p:txBody>
-          <a:bodyPr vert="horz" lIns="91440" tIns="45720" rIns="91440" bIns="45720" rtlCol="0" anchor="ctr"/>
-          <a:lstStyle/>
-          <a:p>
-            <a:endParaRPr lang="en-US"/>
-          </a:p>
-        </p:txBody>
-      </p:sp>
-      <p:sp>
-        <p:nvSpPr>
-          <p:cNvPr id="5" name="Notes Placeholder 4"/>
-          <p:cNvSpPr>
-            <a:spLocks noGrp="1"/>
-          </p:cNvSpPr>
-          <p:nvPr>
-            <p:ph type="body" sz="quarter" idx="3"/>
-          </p:nvPr>
-        </p:nvSpPr>
-        <p:spPr>
-          <a:xfrm>
-            <a:off x="685800" y="4400550"/>
-            <a:ext cx="5486400" cy="3600450"/>
-          </a:xfrm>
-          <a:prstGeom prst="rect">
-            <a:avLst/>
-          </a:prstGeom>
-        </p:spPr>
-        <p:txBody>
-          <a:bodyPr vert="horz" lIns="91440" tIns="45720" rIns="91440" bIns="45720" rtlCol="0"/>
-          <a:lstStyle/>
-          <a:p>
-            <a:pPr lvl="0"/>
-            <a:r>
-              <a:rPr lang="en-US"/>
-              <a:t>Click to edit Master text styles</a:t>
-            </a:r>
-          </a:p>
-          <a:p>
-            <a:pPr lvl="1"/>
-            <a:r>
-              <a:rPr lang="en-US"/>
-              <a:t>Second level</a:t>
-            </a:r>
-          </a:p>
-          <a:p>
-            <a:pPr lvl="2"/>
-            <a:r>
-              <a:rPr lang="en-US"/>
-              <a:t>Third level</a:t>
-            </a:r>
-          </a:p>
-          <a:p>
-            <a:pPr lvl="3"/>
-            <a:r>
-              <a:rPr lang="en-US"/>
-              <a:t>Fourth level</a:t>
-            </a:r>
-          </a:p>
-          <a:p>
-            <a:pPr lvl="4"/>
-            <a:r>
-              <a:rPr lang="en-US"/>
-              <a:t>Fifth level</a:t>
-            </a:r>
-          </a:p>
-        </p:txBody>
-      </p:sp>
-      <p:sp>
-        <p:nvSpPr>
-          <p:cNvPr id="6" name="Footer Placeholder 5"/>
-          <p:cNvSpPr>
-            <a:spLocks noGrp="1"/>
-          </p:cNvSpPr>
-          <p:nvPr>
-            <p:ph type="ftr" sz="quarter" idx="4"/>
-          </p:nvPr>
-        </p:nvSpPr>
-        <p:spPr>
-          <a:xfrm>
-            <a:off x="0" y="8685213"/>
-            <a:ext cx="2971800" cy="458787"/>
-          </a:xfrm>
-          <a:prstGeom prst="rect">
-            <a:avLst/>
-          </a:prstGeom>
-        </p:spPr>
-        <p:txBody>
-          <a:bodyPr vert="horz" lIns="91440" tIns="45720" rIns="91440" bIns="45720" rtlCol="0" anchor="b"/>
-          <a:lstStyle>
-            <a:lvl1pPr algn="l">
-              <a:defRPr sz="1200"/>
-            </a:lvl1pPr>
-          </a:lstStyle>
-          <a:p>
-            <a:endParaRPr lang="en-US"/>
-          </a:p>
-        </p:txBody>
-      </p:sp>
-      <p:sp>
-        <p:nvSpPr>
-          <p:cNvPr id="7" name="Slide Number Placeholder 6"/>
-          <p:cNvSpPr>
-            <a:spLocks noGrp="1"/>
-          </p:cNvSpPr>
-          <p:nvPr>
-            <p:ph type="sldNum" sz="quarter" idx="5"/>
-          </p:nvPr>
-        </p:nvSpPr>
-        <p:spPr>
-          <a:xfrm>
-            <a:off x="3884613" y="8685213"/>
-            <a:ext cx="2971800" cy="458787"/>
-          </a:xfrm>
-          <a:prstGeom prst="rect">
-            <a:avLst/>
-          </a:prstGeom>
-        </p:spPr>
-        <p:txBody>
-          <a:bodyPr vert="horz" lIns="91440" tIns="45720" rIns="91440" bIns="45720" rtlCol="0" anchor="b"/>
-          <a:lstStyle>
-            <a:lvl1pPr algn="r">
-              <a:defRPr sz="1200"/>
-            </a:lvl1pPr>
-          </a:lstStyle>
-          <a:p>
-            <a:fld id="{CE5E9CC1-C706-0F49-92D6-E571CC5EEA8F}" type="slidenum">
-              <a:rPr lang="en-US"/>
-              <a:t>‹#›</a:t>
-            </a:fld>
-            <a:endParaRPr lang="en-US"/>
-          </a:p>
-        </p:txBody>
-      </p:sp>
     </p:spTree>
     <p:extLst>
       <p:ext uri="{BB962C8B-B14F-4D97-AF65-F5344CB8AC3E}">
-        <p14:creationId xmlns:p14="http://schemas.microsoft.com/office/powerpoint/2010/main" val="1024086991"/>
+        <p14:creationId xmlns:p14="http://schemas.microsoft.com/office/powerpoint/2010/main" val="3776377255"/>
       </p:ext>
     </p:extLst>
   </p:cSld>
@@ -515,7 +296,6 @@
               <a:rPr lang="en-US" dirty="0"/>
               <a:t>~30s. One presenter opens. Replace member placeholders with real names. The board on the right is the Pulles (2021) example puzzle with its unique solution, drawn by our own renderer's conventions.</a:t>
             </a:r>
-            <a:endParaRPr lang="en-US" dirty="0"/>
           </a:p>
         </p:txBody>
       </p:sp>
@@ -603,7 +383,6 @@
               <a:rPr lang="en-US" dirty="0"/>
               <a:t>~1 min. The beyond-the-obvious slide. The headline: our density presets predict difficulty for HUMANS (deduction chains), not for solvers - sparse boards have many solutions and finding any one is easy. Tie back to the uniqueness discussion. Calibrating difficulty by measured effort is named future work.</a:t>
             </a:r>
-            <a:endParaRPr lang="en-US" dirty="0"/>
           </a:p>
         </p:txBody>
       </p:sp>
@@ -691,7 +470,6 @@
               <a:rPr lang="en-US" dirty="0"/>
               <a:t>~45s. Every claim here is a measured number from experiments/results/results.csv (overall: SA 45/75 = 60%, HC 21/75 = 28%; hard-only: 19/25 vs 11/25). All four members should have spoken by now (equal input is graded).</a:t>
             </a:r>
-            <a:endParaRPr lang="en-US" dirty="0"/>
           </a:p>
         </p:txBody>
       </p:sp>
@@ -779,7 +557,6 @@
               <a:rPr lang="en-US" dirty="0"/>
               <a:t>Not spoken — present for completeness and Q&amp;A.</a:t>
             </a:r>
-            <a:endParaRPr lang="en-US" dirty="0"/>
           </a:p>
         </p:txBody>
       </p:sp>
@@ -867,7 +644,6 @@
               <a:rPr lang="en-US" dirty="0"/>
               <a:t>~1 min. State the rules quickly with the example. Do NOT dwell — the course requires only a brief problem statement. Mention the uniqueness note; it returns in the analysis.</a:t>
             </a:r>
-            <a:endParaRPr lang="en-US" dirty="0"/>
           </a:p>
         </p:txBody>
       </p:sp>
@@ -955,7 +731,6 @@
               <a:rPr lang="en-US" dirty="0"/>
               <a:t>~1 min. The three cards are the topic-choice justification. Keep the prior-work strip to two sentences — the course explicitly says existing approaches should be mentioned only very briefly.</a:t>
             </a:r>
-            <a:endParaRPr lang="en-US" dirty="0"/>
           </a:p>
         </p:txBody>
       </p:sp>
@@ -1043,7 +818,6 @@
               <a:rPr lang="en-US" dirty="0"/>
               <a:t>~45s. One slide of formalism, no more. Do NOT explain what a CSP or backtracking is — covered in the course. The 'lit is derived' line preempts a common Q&amp;A question about the domain.</a:t>
             </a:r>
-            <a:endParaRPr lang="en-US" dirty="0"/>
           </a:p>
         </p:txBody>
       </p:sp>
@@ -1131,7 +905,6 @@
               <a:rPr lang="en-US" dirty="0"/>
               <a:t>~1 min. The experiment design in one picture: each arrow on the left changes exactly one thing, so differences in the stats are attributable. Right column is the cross-paradigm comparison.</a:t>
             </a:r>
-            <a:endParaRPr lang="en-US" dirty="0"/>
           </a:p>
         </p:txBody>
       </p:sp>
@@ -1219,7 +992,6 @@
               <a:rPr lang="en-US" dirty="0"/>
               <a:t>~45s. The screenshot is the naive solver mid-replay on a 10x10: red frame = conflict at (9,7), green digits = satisfied clues, status bar streams the event counter and search stats. Demo bait: if time allows in Q&amp;A, a 20-second live solve in the GUI is worth more than this slide. Do not show code.</a:t>
             </a:r>
-            <a:endParaRPr lang="en-US" dirty="0"/>
           </a:p>
         </p:txBody>
       </p:sp>
@@ -1307,7 +1079,6 @@
               <a:rPr lang="en-US" dirty="0"/>
               <a:t>~45s. Fill the two [CONFIRM] blanks once the experiment harness is final. The bottom principle matters in Q&amp;A: multi-solution instances make answer-comparison invalid as a correctness test.</a:t>
             </a:r>
-            <a:endParaRPr lang="en-US" dirty="0"/>
           </a:p>
         </p:txBody>
       </p:sp>
@@ -1395,7 +1166,6 @@
               <a:rPr lang="en-US" dirty="0"/>
               <a:t>~1.5 min. THE core slide. Say the numbers out loud: naive 308 nodes on the 7x7, forward checking 12, full inference ZERO - the published puzzle is solved by deduction alone, which is exactly what publishers curate for. Then the scaling panels: 1-2 orders of magnitude between naive and the smart variants. Close with the nodes-vs-time nuance - fewer nodes is not automatically less time.</a:t>
             </a:r>
-            <a:endParaRPr lang="en-US" dirty="0"/>
           </a:p>
         </p:txBody>
       </p:sp>
@@ -1483,7 +1253,6 @@
               <a:rPr lang="en-US" dirty="0"/>
               <a:t>~1.5 min. Cross-paradigm comparison. Lead with SA vs HC (the Perera reproduction), then the one-violation-away story - it is the local-optimum concept made concrete. End on the honest framing: on these sizes complete search wins; incompleteness is the structural caveat.</a:t>
             </a:r>
-            <a:endParaRPr lang="en-US" dirty="0"/>
           </a:p>
         </p:txBody>
       </p:sp>
@@ -1556,6 +1325,11 @@
 <file path=ppt/slideMasters/slideMaster1.xml><?xml version="1.0" encoding="utf-8"?>
 <p:sldMaster xmlns:a="http://schemas.openxmlformats.org/drawingml/2006/main" xmlns:r="http://schemas.openxmlformats.org/officeDocument/2006/relationships" xmlns:p="http://schemas.openxmlformats.org/presentationml/2006/main">
   <p:cSld>
+    <p:bg>
+      <p:bgRef idx="1001">
+        <a:schemeClr val="bg1"/>
+      </p:bgRef>
+    </p:bg>
     <p:spTree>
       <p:nvGrpSpPr>
         <p:cNvPr id="1" name=""/>
@@ -1838,6 +1612,7 @@
         <a:solidFill>
           <a:srgbClr val="17171D"/>
         </a:solidFill>
+        <a:effectLst/>
       </p:bgPr>
     </p:bg>
     <p:spTree>
@@ -2142,7 +1917,7 @@
           <a:bodyPr wrap="square" lIns="0" tIns="0" rIns="0" bIns="0" rtlCol="0" anchor="ctr"/>
           <a:lstStyle/>
           <a:p>
-            <a:pPr algn="ctr" indent="0" marL="0">
+            <a:pPr marL="0" indent="0" algn="ctr">
               <a:buNone/>
             </a:pPr>
             <a:r>
@@ -2231,7 +2006,7 @@
           <a:bodyPr wrap="square" lIns="0" tIns="0" rIns="0" bIns="0" rtlCol="0" anchor="ctr"/>
           <a:lstStyle/>
           <a:p>
-            <a:pPr algn="ctr" indent="0" marL="0">
+            <a:pPr marL="0" indent="0" algn="ctr">
               <a:buNone/>
             </a:pPr>
             <a:r>
@@ -2487,7 +2262,7 @@
           <a:bodyPr wrap="square" lIns="0" tIns="0" rIns="0" bIns="0" rtlCol="0" anchor="ctr"/>
           <a:lstStyle/>
           <a:p>
-            <a:pPr algn="ctr" indent="0" marL="0">
+            <a:pPr marL="0" indent="0" algn="ctr">
               <a:buNone/>
             </a:pPr>
             <a:r>
@@ -3978,7 +3753,7 @@
           <a:bodyPr wrap="square" lIns="0" tIns="0" rIns="0" bIns="0" rtlCol="0" anchor="ctr"/>
           <a:lstStyle/>
           <a:p>
-            <a:pPr algn="ctr" indent="0" marL="0">
+            <a:pPr marL="0" indent="0" algn="ctr">
               <a:buNone/>
             </a:pPr>
             <a:r>
@@ -4184,7 +3959,7 @@
           <a:bodyPr wrap="square" lIns="0" tIns="0" rIns="0" bIns="0" rtlCol="0" anchor="ctr"/>
           <a:lstStyle/>
           <a:p>
-            <a:pPr algn="ctr" indent="0" marL="0">
+            <a:pPr marL="0" indent="0" algn="ctr">
               <a:buNone/>
             </a:pPr>
             <a:r>
@@ -4465,7 +4240,7 @@
           <a:bodyPr wrap="square" lIns="0" tIns="0" rIns="0" bIns="0" rtlCol="0" anchor="ctr"/>
           <a:lstStyle/>
           <a:p>
-            <a:pPr indent="0" marL="0">
+            <a:pPr marL="0" indent="0">
               <a:buNone/>
             </a:pPr>
             <a:r>
@@ -4477,7 +4252,45 @@
                 <a:ea typeface="Arial" pitchFamily="34" charset="-122"/>
                 <a:cs typeface="Arial" pitchFamily="34" charset="-120"/>
               </a:rPr>
-              <a:t>Lighting Up Akari with AI Search</a:t>
+              <a:t>Lighting Up </a:t>
+            </a:r>
+            <a:r>
+              <a:rPr lang="en-US" sz="4000" b="1" dirty="0" err="1">
+                <a:solidFill>
+                  <a:srgbClr val="F2EFE7"/>
+                </a:solidFill>
+                <a:latin typeface="Arial" pitchFamily="34" charset="0"/>
+                <a:ea typeface="Arial" pitchFamily="34" charset="-122"/>
+                <a:cs typeface="Arial" pitchFamily="34" charset="-120"/>
+              </a:rPr>
+              <a:t>Akari</a:t>
+            </a:r>
+            <a:r>
+              <a:rPr lang="en-US" sz="4000" b="1" dirty="0">
+                <a:solidFill>
+                  <a:srgbClr val="F2EFE7"/>
+                </a:solidFill>
+                <a:latin typeface="Arial" pitchFamily="34" charset="0"/>
+                <a:ea typeface="Arial" pitchFamily="34" charset="-122"/>
+                <a:cs typeface="Arial" pitchFamily="34" charset="-120"/>
+              </a:rPr>
+              <a:t> with </a:t>
+            </a:r>
+          </a:p>
+          <a:p>
+            <a:pPr marL="0" indent="0">
+              <a:buNone/>
+            </a:pPr>
+            <a:r>
+              <a:rPr lang="en-US" sz="4000" b="1" dirty="0">
+                <a:solidFill>
+                  <a:srgbClr val="F2EFE7"/>
+                </a:solidFill>
+                <a:latin typeface="Arial" pitchFamily="34" charset="0"/>
+                <a:ea typeface="Arial" pitchFamily="34" charset="-122"/>
+                <a:cs typeface="Arial" pitchFamily="34" charset="-120"/>
+              </a:rPr>
+              <a:t>AI Search</a:t>
             </a:r>
             <a:endParaRPr lang="en-US" sz="4000" dirty="0"/>
           </a:p>
@@ -4504,7 +4317,7 @@
           <a:bodyPr wrap="square" lIns="0" tIns="0" rIns="0" bIns="0" rtlCol="0" anchor="ctr"/>
           <a:lstStyle/>
           <a:p>
-            <a:pPr indent="0" marL="0">
+            <a:pPr marL="0" indent="0">
               <a:buNone/>
             </a:pPr>
             <a:r>
@@ -4521,7 +4334,7 @@
             <a:endParaRPr lang="en-US" sz="1700" dirty="0"/>
           </a:p>
           <a:p>
-            <a:pPr indent="0" marL="0">
+            <a:pPr marL="0" indent="0">
               <a:buNone/>
             </a:pPr>
             <a:r>
@@ -4560,7 +4373,7 @@
           <a:bodyPr wrap="square" lIns="0" tIns="0" rIns="0" bIns="0" rtlCol="0" anchor="ctr"/>
           <a:lstStyle/>
           <a:p>
-            <a:pPr indent="0" marL="0">
+            <a:pPr marL="0" indent="0">
               <a:buNone/>
             </a:pPr>
             <a:r>
@@ -4599,7 +4412,7 @@
           <a:bodyPr wrap="square" lIns="0" tIns="0" rIns="0" bIns="0" rtlCol="0" anchor="ctr"/>
           <a:lstStyle/>
           <a:p>
-            <a:pPr indent="0" marL="0">
+            <a:pPr marL="0" indent="0">
               <a:buNone/>
             </a:pPr>
             <a:r>
@@ -4633,6 +4446,7 @@
         <a:solidFill>
           <a:srgbClr val="17171D"/>
         </a:solidFill>
+        <a:effectLst/>
       </p:bgPr>
     </p:bg>
     <p:spTree>
@@ -4670,7 +4484,7 @@
           <a:bodyPr wrap="square" lIns="0" tIns="0" rIns="0" bIns="0" rtlCol="0" anchor="ctr"/>
           <a:lstStyle/>
           <a:p>
-            <a:pPr indent="0" marL="0">
+            <a:pPr marL="0" indent="0">
               <a:buNone/>
             </a:pPr>
             <a:r>
@@ -4690,15 +4504,15 @@
       </p:sp>
       <p:pic>
         <p:nvPicPr>
-          <p:cNvPr id="3" name="Image 0" descr="C:\Users\Annie\Desktop\AUA\Artificial Intelligence\GroupProject\LightUp\experiments\results\fig3_difficulty.png">    </p:cNvPr>
+          <p:cNvPr id="3" name="Image 0" descr="C:\Users\Annie\Desktop\AUA\Artificial Intelligence\GroupProject\LightUp\experiments\results\fig3_difficulty.png"/>
           <p:cNvPicPr>
             <a:picLocks noChangeAspect="1"/>
           </p:cNvPicPr>
           <p:nvPr/>
         </p:nvPicPr>
         <p:blipFill>
-          <a:blip r:embed="rId1"/>
-          <a:srcRect l="0" r="0" t="0" b="0"/>
+          <a:blip r:embed="rId3"/>
+          <a:srcRect/>
           <a:stretch/>
         </p:blipFill>
         <p:spPr>
@@ -4732,7 +4546,7 @@
           <a:bodyPr wrap="square" lIns="0" tIns="0" rIns="0" bIns="0" rtlCol="0" anchor="t"/>
           <a:lstStyle/>
           <a:p>
-            <a:pPr indent="0" marL="0">
+            <a:pPr marL="0" indent="0">
               <a:spcAft>
                 <a:spcPts val="800"/>
               </a:spcAft>
@@ -4807,7 +4621,7 @@
                 <a:ea typeface="Calibri" pitchFamily="34" charset="-122"/>
                 <a:cs typeface="Calibri" pitchFamily="34" charset="-120"/>
               </a:rPr>
-              <a:t>Full inference is the most stable across densities: 1–4 ms medians everywhere.</a:t>
+              <a:t>Full inference is the most stable across densities:  1–4 ms medians everywhere.</a:t>
             </a:r>
             <a:endParaRPr lang="en-US" sz="1400" dirty="0"/>
           </a:p>
@@ -4834,7 +4648,7 @@
           <a:bodyPr wrap="square" lIns="0" tIns="0" rIns="0" bIns="0" rtlCol="0" anchor="ctr"/>
           <a:lstStyle/>
           <a:p>
-            <a:pPr algn="r" indent="0" marL="0">
+            <a:pPr marL="0" indent="0" algn="r">
               <a:buNone/>
             </a:pPr>
             <a:r>
@@ -4868,6 +4682,7 @@
         <a:solidFill>
           <a:srgbClr val="17171D"/>
         </a:solidFill>
+        <a:effectLst/>
       </p:bgPr>
     </p:bg>
     <p:spTree>
@@ -4905,7 +4720,7 @@
           <a:bodyPr wrap="square" lIns="0" tIns="0" rIns="0" bIns="0" rtlCol="0" anchor="ctr"/>
           <a:lstStyle/>
           <a:p>
-            <a:pPr indent="0" marL="0">
+            <a:pPr marL="0" indent="0">
               <a:buNone/>
             </a:pPr>
             <a:r>
@@ -5090,7 +4905,7 @@
           <a:bodyPr wrap="square" lIns="0" tIns="0" rIns="0" bIns="0" rtlCol="0" anchor="ctr"/>
           <a:lstStyle/>
           <a:p>
-            <a:pPr algn="ctr" indent="0" marL="0">
+            <a:pPr marL="0" indent="0" algn="ctr">
               <a:buNone/>
             </a:pPr>
             <a:r>
@@ -5129,7 +4944,7 @@
           <a:bodyPr wrap="square" lIns="0" tIns="0" rIns="0" bIns="0" rtlCol="0" anchor="ctr"/>
           <a:lstStyle/>
           <a:p>
-            <a:pPr algn="r" indent="0" marL="0">
+            <a:pPr marL="0" indent="0" algn="r">
               <a:buNone/>
             </a:pPr>
             <a:r>
@@ -5163,6 +4978,7 @@
         <a:solidFill>
           <a:srgbClr val="17171D"/>
         </a:solidFill>
+        <a:effectLst/>
       </p:bgPr>
     </p:bg>
     <p:spTree>
@@ -5200,7 +5016,7 @@
           <a:bodyPr wrap="square" lIns="0" tIns="0" rIns="0" bIns="0" rtlCol="0" anchor="ctr"/>
           <a:lstStyle/>
           <a:p>
-            <a:pPr indent="0" marL="0">
+            <a:pPr marL="0" indent="0">
               <a:buNone/>
             </a:pPr>
             <a:r>
@@ -5387,7 +5203,7 @@
           <a:bodyPr wrap="square" lIns="0" tIns="0" rIns="0" bIns="0" rtlCol="0" anchor="ctr"/>
           <a:lstStyle/>
           <a:p>
-            <a:pPr algn="r" indent="0" marL="0">
+            <a:pPr marL="0" indent="0" algn="r">
               <a:buNone/>
             </a:pPr>
             <a:r>
@@ -5421,6 +5237,7 @@
         <a:solidFill>
           <a:srgbClr val="17171D"/>
         </a:solidFill>
+        <a:effectLst/>
       </p:bgPr>
     </p:bg>
     <p:spTree>
@@ -5458,7 +5275,7 @@
           <a:bodyPr wrap="square" lIns="0" tIns="0" rIns="0" bIns="0" rtlCol="0" anchor="ctr"/>
           <a:lstStyle/>
           <a:p>
-            <a:pPr indent="0" marL="0">
+            <a:pPr marL="0" indent="0">
               <a:buNone/>
             </a:pPr>
             <a:r>
@@ -5497,7 +5314,7 @@
           <a:bodyPr wrap="square" lIns="0" tIns="0" rIns="0" bIns="0" rtlCol="0" anchor="t"/>
           <a:lstStyle/>
           <a:p>
-            <a:pPr indent="0" marL="0">
+            <a:pPr marL="0" indent="0">
               <a:buNone/>
             </a:pPr>
             <a:r>
@@ -5514,7 +5331,7 @@
             <a:endParaRPr lang="en-US" sz="1800" dirty="0"/>
           </a:p>
           <a:p>
-            <a:pPr indent="0" marL="0">
+            <a:pPr marL="0" indent="0">
               <a:buNone/>
             </a:pPr>
             <a:r>
@@ -5553,7 +5370,7 @@
           <a:bodyPr wrap="square" lIns="0" tIns="0" rIns="0" bIns="0" rtlCol="0" anchor="t"/>
           <a:lstStyle/>
           <a:p>
-            <a:pPr indent="0" marL="0">
+            <a:pPr marL="0" indent="0">
               <a:buNone/>
             </a:pPr>
             <a:r>
@@ -5570,7 +5387,7 @@
             <a:endParaRPr lang="en-US" sz="1800" dirty="0"/>
           </a:p>
           <a:p>
-            <a:pPr indent="0" marL="0">
+            <a:pPr marL="0" indent="0">
               <a:buNone/>
             </a:pPr>
             <a:r>
@@ -5609,7 +5426,7 @@
           <a:bodyPr wrap="square" lIns="0" tIns="0" rIns="0" bIns="0" rtlCol="0" anchor="t"/>
           <a:lstStyle/>
           <a:p>
-            <a:pPr indent="0" marL="0">
+            <a:pPr marL="0" indent="0">
               <a:buNone/>
             </a:pPr>
             <a:r>
@@ -5626,7 +5443,7 @@
             <a:endParaRPr lang="en-US" sz="1800" dirty="0"/>
           </a:p>
           <a:p>
-            <a:pPr indent="0" marL="0">
+            <a:pPr marL="0" indent="0">
               <a:buNone/>
             </a:pPr>
             <a:r>
@@ -5665,7 +5482,7 @@
           <a:bodyPr wrap="square" lIns="0" tIns="0" rIns="0" bIns="0" rtlCol="0" anchor="ctr"/>
           <a:lstStyle/>
           <a:p>
-            <a:pPr indent="0" marL="0">
+            <a:pPr marL="0" indent="0">
               <a:buNone/>
             </a:pPr>
             <a:r>
@@ -5729,7 +5546,7 @@
           <a:bodyPr wrap="square" lIns="0" tIns="0" rIns="0" bIns="0" rtlCol="0" anchor="ctr"/>
           <a:lstStyle/>
           <a:p>
-            <a:pPr algn="ctr" indent="0" marL="0">
+            <a:pPr marL="0" indent="0" algn="ctr">
               <a:buNone/>
             </a:pPr>
             <a:r>
@@ -6319,7 +6136,7 @@
           <a:bodyPr wrap="square" lIns="0" tIns="0" rIns="0" bIns="0" rtlCol="0" anchor="ctr"/>
           <a:lstStyle/>
           <a:p>
-            <a:pPr algn="ctr" indent="0" marL="0">
+            <a:pPr marL="0" indent="0" algn="ctr">
               <a:buNone/>
             </a:pPr>
             <a:r>
@@ -6358,7 +6175,7 @@
           <a:bodyPr wrap="square" lIns="0" tIns="0" rIns="0" bIns="0" rtlCol="0" anchor="ctr"/>
           <a:lstStyle/>
           <a:p>
-            <a:pPr algn="r" indent="0" marL="0">
+            <a:pPr marL="0" indent="0" algn="r">
               <a:buNone/>
             </a:pPr>
             <a:r>
@@ -6392,6 +6209,7 @@
         <a:solidFill>
           <a:srgbClr val="17171D"/>
         </a:solidFill>
+        <a:effectLst/>
       </p:bgPr>
     </p:bg>
     <p:spTree>
@@ -6429,7 +6247,7 @@
           <a:bodyPr wrap="square" lIns="0" tIns="0" rIns="0" bIns="0" rtlCol="0" anchor="ctr"/>
           <a:lstStyle/>
           <a:p>
-            <a:pPr indent="0" marL="0">
+            <a:pPr marL="0" indent="0">
               <a:buNone/>
             </a:pPr>
             <a:r>
@@ -6490,7 +6308,7 @@
           <a:bodyPr wrap="square" lIns="0" tIns="0" rIns="0" bIns="0" rtlCol="0" anchor="t"/>
           <a:lstStyle/>
           <a:p>
-            <a:pPr indent="0" marL="0">
+            <a:pPr marL="0" indent="0">
               <a:buNone/>
             </a:pPr>
             <a:r>
@@ -6507,7 +6325,7 @@
             <a:endParaRPr lang="en-US" sz="1900" dirty="0"/>
           </a:p>
           <a:p>
-            <a:pPr indent="0" marL="0">
+            <a:pPr marL="0" indent="0">
               <a:buNone/>
             </a:pPr>
             <a:r>
@@ -6568,7 +6386,7 @@
           <a:bodyPr wrap="square" lIns="0" tIns="0" rIns="0" bIns="0" rtlCol="0" anchor="t"/>
           <a:lstStyle/>
           <a:p>
-            <a:pPr indent="0" marL="0">
+            <a:pPr marL="0" indent="0">
               <a:buNone/>
             </a:pPr>
             <a:r>
@@ -6585,7 +6403,7 @@
             <a:endParaRPr lang="en-US" sz="1900" dirty="0"/>
           </a:p>
           <a:p>
-            <a:pPr indent="0" marL="0">
+            <a:pPr marL="0" indent="0">
               <a:buNone/>
             </a:pPr>
             <a:r>
@@ -6646,7 +6464,7 @@
           <a:bodyPr wrap="square" lIns="0" tIns="0" rIns="0" bIns="0" rtlCol="0" anchor="t"/>
           <a:lstStyle/>
           <a:p>
-            <a:pPr indent="0" marL="0">
+            <a:pPr marL="0" indent="0">
               <a:buNone/>
             </a:pPr>
             <a:r>
@@ -6663,7 +6481,7 @@
             <a:endParaRPr lang="en-US" sz="1900" dirty="0"/>
           </a:p>
           <a:p>
-            <a:pPr indent="0" marL="0">
+            <a:pPr marL="0" indent="0">
               <a:buNone/>
             </a:pPr>
             <a:r>
@@ -6702,7 +6520,7 @@
           <a:bodyPr wrap="square" lIns="0" tIns="0" rIns="0" bIns="0" rtlCol="0" anchor="ctr"/>
           <a:lstStyle/>
           <a:p>
-            <a:pPr indent="0" marL="0">
+            <a:pPr marL="0" indent="0">
               <a:buNone/>
             </a:pPr>
             <a:r>
@@ -6716,9 +6534,6 @@
               </a:rPr>
               <a:t>Existing approaches (briefly): </a:t>
             </a:r>
-            <a:pPr indent="0" marL="0">
-              <a:buNone/>
-            </a:pPr>
             <a:r>
               <a:rPr lang="en-US" sz="1400" dirty="0">
                 <a:solidFill>
@@ -6755,7 +6570,7 @@
           <a:bodyPr wrap="square" lIns="0" tIns="0" rIns="0" bIns="0" rtlCol="0" anchor="ctr"/>
           <a:lstStyle/>
           <a:p>
-            <a:pPr algn="r" indent="0" marL="0">
+            <a:pPr marL="0" indent="0" algn="r">
               <a:buNone/>
             </a:pPr>
             <a:r>
@@ -6789,6 +6604,7 @@
         <a:solidFill>
           <a:srgbClr val="17171D"/>
         </a:solidFill>
+        <a:effectLst/>
       </p:bgPr>
     </p:bg>
     <p:spTree>
@@ -6826,7 +6642,7 @@
           <a:bodyPr wrap="square" lIns="0" tIns="0" rIns="0" bIns="0" rtlCol="0" anchor="ctr"/>
           <a:lstStyle/>
           <a:p>
-            <a:pPr indent="0" marL="0">
+            <a:pPr marL="0" indent="0">
               <a:buNone/>
             </a:pPr>
             <a:r>
@@ -6860,15 +6676,27 @@
         </p:nvGraphicFramePr>
         <p:xfrm>
           <a:off x="640080" y="1463040"/>
-          <a:ext cx="10881360" cy="914400"/>
+          <a:ext cx="10881360" cy="2834640"/>
         </p:xfrm>
         <a:graphic>
           <a:graphicData uri="http://schemas.openxmlformats.org/drawingml/2006/table">
             <a:tbl>
               <a:tblPr/>
               <a:tblGrid>
-                <a:gridCol w="2377440"/>
-                <a:gridCol w="8503920"/>
+                <a:gridCol w="2377440">
+                  <a:extLst>
+                    <a:ext uri="{9D8B030D-6E8A-4147-A177-3AD203B41FA5}">
+                      <a16:colId xmlns:a16="http://schemas.microsoft.com/office/drawing/2014/main" val="20000"/>
+                    </a:ext>
+                  </a:extLst>
+                </a:gridCol>
+                <a:gridCol w="8503920">
+                  <a:extLst>
+                    <a:ext uri="{9D8B030D-6E8A-4147-A177-3AD203B41FA5}">
+                      <a16:colId xmlns:a16="http://schemas.microsoft.com/office/drawing/2014/main" val="20001"/>
+                    </a:ext>
+                  </a:extLst>
+                </a:gridCol>
               </a:tblGrid>
               <a:tr h="566928">
                 <a:tc>
@@ -6876,7 +6704,7 @@
                     <a:bodyPr/>
                     <a:lstStyle/>
                     <a:p>
-                      <a:pPr indent="0" marL="0">
+                      <a:pPr marL="0" indent="0">
                         <a:buNone/>
                       </a:pPr>
                       <a:r>
@@ -6944,7 +6772,7 @@
                     <a:bodyPr/>
                     <a:lstStyle/>
                     <a:p>
-                      <a:pPr indent="0" marL="0">
+                      <a:pPr marL="0" indent="0">
                         <a:buNone/>
                       </a:pPr>
                       <a:r>
@@ -7007,6 +6835,11 @@
                     </a:solidFill>
                   </a:tcPr>
                 </a:tc>
+                <a:extLst>
+                  <a:ext uri="{0D108BD9-81ED-4DB2-BD59-A6C34878D82A}">
+                    <a16:rowId xmlns:a16="http://schemas.microsoft.com/office/drawing/2014/main" val="10000"/>
+                  </a:ext>
+                </a:extLst>
               </a:tr>
               <a:tr h="566928">
                 <a:tc>
@@ -7014,7 +6847,7 @@
                     <a:bodyPr/>
                     <a:lstStyle/>
                     <a:p>
-                      <a:pPr indent="0" marL="0">
+                      <a:pPr marL="0" indent="0">
                         <a:buNone/>
                       </a:pPr>
                       <a:r>
@@ -7082,7 +6915,7 @@
                     <a:bodyPr/>
                     <a:lstStyle/>
                     <a:p>
-                      <a:pPr indent="0" marL="0">
+                      <a:pPr marL="0" indent="0">
                         <a:buNone/>
                       </a:pPr>
                       <a:r>
@@ -7145,6 +6978,11 @@
                     </a:solidFill>
                   </a:tcPr>
                 </a:tc>
+                <a:extLst>
+                  <a:ext uri="{0D108BD9-81ED-4DB2-BD59-A6C34878D82A}">
+                    <a16:rowId xmlns:a16="http://schemas.microsoft.com/office/drawing/2014/main" val="10001"/>
+                  </a:ext>
+                </a:extLst>
               </a:tr>
               <a:tr h="566928">
                 <a:tc>
@@ -7152,7 +6990,7 @@
                     <a:bodyPr/>
                     <a:lstStyle/>
                     <a:p>
-                      <a:pPr indent="0" marL="0">
+                      <a:pPr marL="0" indent="0">
                         <a:buNone/>
                       </a:pPr>
                       <a:r>
@@ -7220,7 +7058,7 @@
                     <a:bodyPr/>
                     <a:lstStyle/>
                     <a:p>
-                      <a:pPr indent="0" marL="0">
+                      <a:pPr marL="0" indent="0">
                         <a:buNone/>
                       </a:pPr>
                       <a:r>
@@ -7283,6 +7121,11 @@
                     </a:solidFill>
                   </a:tcPr>
                 </a:tc>
+                <a:extLst>
+                  <a:ext uri="{0D108BD9-81ED-4DB2-BD59-A6C34878D82A}">
+                    <a16:rowId xmlns:a16="http://schemas.microsoft.com/office/drawing/2014/main" val="10002"/>
+                  </a:ext>
+                </a:extLst>
               </a:tr>
               <a:tr h="566928">
                 <a:tc>
@@ -7290,7 +7133,7 @@
                     <a:bodyPr/>
                     <a:lstStyle/>
                     <a:p>
-                      <a:pPr indent="0" marL="0">
+                      <a:pPr marL="0" indent="0">
                         <a:buNone/>
                       </a:pPr>
                       <a:r>
@@ -7358,7 +7201,7 @@
                     <a:bodyPr/>
                     <a:lstStyle/>
                     <a:p>
-                      <a:pPr indent="0" marL="0">
+                      <a:pPr marL="0" indent="0">
                         <a:buNone/>
                       </a:pPr>
                       <a:r>
@@ -7421,6 +7264,11 @@
                     </a:solidFill>
                   </a:tcPr>
                 </a:tc>
+                <a:extLst>
+                  <a:ext uri="{0D108BD9-81ED-4DB2-BD59-A6C34878D82A}">
+                    <a16:rowId xmlns:a16="http://schemas.microsoft.com/office/drawing/2014/main" val="10003"/>
+                  </a:ext>
+                </a:extLst>
               </a:tr>
               <a:tr h="566928">
                 <a:tc>
@@ -7428,7 +7276,7 @@
                     <a:bodyPr/>
                     <a:lstStyle/>
                     <a:p>
-                      <a:pPr indent="0" marL="0">
+                      <a:pPr marL="0" indent="0">
                         <a:buNone/>
                       </a:pPr>
                       <a:r>
@@ -7496,7 +7344,7 @@
                     <a:bodyPr/>
                     <a:lstStyle/>
                     <a:p>
-                      <a:pPr indent="0" marL="0">
+                      <a:pPr marL="0" indent="0">
                         <a:buNone/>
                       </a:pPr>
                       <a:r>
@@ -7559,6 +7407,11 @@
                     </a:solidFill>
                   </a:tcPr>
                 </a:tc>
+                <a:extLst>
+                  <a:ext uri="{0D108BD9-81ED-4DB2-BD59-A6C34878D82A}">
+                    <a16:rowId xmlns:a16="http://schemas.microsoft.com/office/drawing/2014/main" val="10004"/>
+                  </a:ext>
+                </a:extLst>
               </a:tr>
             </a:tbl>
           </a:graphicData>
@@ -7585,7 +7438,7 @@
           <a:bodyPr wrap="square" lIns="0" tIns="0" rIns="0" bIns="0" rtlCol="0" anchor="ctr"/>
           <a:lstStyle/>
           <a:p>
-            <a:pPr indent="0" marL="0">
+            <a:pPr marL="0" indent="0">
               <a:buNone/>
             </a:pPr>
             <a:r>
@@ -7624,7 +7477,7 @@
           <a:bodyPr wrap="square" lIns="0" tIns="0" rIns="0" bIns="0" rtlCol="0" anchor="ctr"/>
           <a:lstStyle/>
           <a:p>
-            <a:pPr algn="r" indent="0" marL="0">
+            <a:pPr marL="0" indent="0" algn="r">
               <a:buNone/>
             </a:pPr>
             <a:r>
@@ -7658,6 +7511,7 @@
         <a:solidFill>
           <a:srgbClr val="17171D"/>
         </a:solidFill>
+        <a:effectLst/>
       </p:bgPr>
     </p:bg>
     <p:spTree>
@@ -7695,7 +7549,7 @@
           <a:bodyPr wrap="square" lIns="0" tIns="0" rIns="0" bIns="0" rtlCol="0" anchor="ctr"/>
           <a:lstStyle/>
           <a:p>
-            <a:pPr indent="0" marL="0">
+            <a:pPr marL="0" indent="0">
               <a:buNone/>
             </a:pPr>
             <a:r>
@@ -7756,7 +7610,7 @@
           <a:bodyPr wrap="square" lIns="0" tIns="0" rIns="0" bIns="0" rtlCol="0" anchor="ctr"/>
           <a:lstStyle/>
           <a:p>
-            <a:pPr indent="0" marL="0">
+            <a:pPr marL="0" indent="0">
               <a:buNone/>
             </a:pPr>
             <a:r>
@@ -7770,9 +7624,6 @@
               </a:rPr>
               <a:t>Backtracking — naive  </a:t>
             </a:r>
-            <a:pPr indent="0" marL="0">
-              <a:buNone/>
-            </a:pPr>
             <a:r>
               <a:rPr lang="en-US" sz="1250" dirty="0">
                 <a:solidFill>
@@ -7855,7 +7706,7 @@
           <a:bodyPr wrap="square" lIns="0" tIns="0" rIns="0" bIns="0" rtlCol="0" anchor="ctr"/>
           <a:lstStyle/>
           <a:p>
-            <a:pPr indent="0" marL="0">
+            <a:pPr marL="0" indent="0">
               <a:buNone/>
             </a:pPr>
             <a:r>
@@ -7869,9 +7720,6 @@
               </a:rPr>
               <a:t>+ ordering heuristics  </a:t>
             </a:r>
-            <a:pPr indent="0" marL="0">
-              <a:buNone/>
-            </a:pPr>
             <a:r>
               <a:rPr lang="en-US" sz="1250" dirty="0">
                 <a:solidFill>
@@ -7954,7 +7802,7 @@
           <a:bodyPr wrap="square" lIns="0" tIns="0" rIns="0" bIns="0" rtlCol="0" anchor="ctr"/>
           <a:lstStyle/>
           <a:p>
-            <a:pPr indent="0" marL="0">
+            <a:pPr marL="0" indent="0">
               <a:buNone/>
             </a:pPr>
             <a:r>
@@ -7968,9 +7816,6 @@
               </a:rPr>
               <a:t>+ inference  </a:t>
             </a:r>
-            <a:pPr indent="0" marL="0">
-              <a:buNone/>
-            </a:pPr>
             <a:r>
               <a:rPr lang="en-US" sz="1250" dirty="0">
                 <a:solidFill>
@@ -8029,7 +7874,7 @@
           <a:bodyPr wrap="square" lIns="0" tIns="0" rIns="0" bIns="0" rtlCol="0" anchor="ctr"/>
           <a:lstStyle/>
           <a:p>
-            <a:pPr indent="0" marL="0">
+            <a:pPr marL="0" indent="0">
               <a:buNone/>
             </a:pPr>
             <a:r>
@@ -8043,9 +7888,6 @@
               </a:rPr>
               <a:t>Hill climbing  </a:t>
             </a:r>
-            <a:pPr indent="0" marL="0">
-              <a:buNone/>
-            </a:pPr>
             <a:r>
               <a:rPr lang="en-US" sz="1250" dirty="0">
                 <a:solidFill>
@@ -8104,7 +7946,7 @@
           <a:bodyPr wrap="square" lIns="0" tIns="0" rIns="0" bIns="0" rtlCol="0" anchor="ctr"/>
           <a:lstStyle/>
           <a:p>
-            <a:pPr indent="0" marL="0">
+            <a:pPr marL="0" indent="0">
               <a:buNone/>
             </a:pPr>
             <a:r>
@@ -8118,9 +7960,6 @@
               </a:rPr>
               <a:t>Simulated annealing  </a:t>
             </a:r>
-            <a:pPr indent="0" marL="0">
-              <a:buNone/>
-            </a:pPr>
             <a:r>
               <a:rPr lang="en-US" sz="1250" dirty="0">
                 <a:solidFill>
@@ -8157,7 +7996,7 @@
           <a:bodyPr wrap="square" lIns="0" tIns="0" rIns="0" bIns="0" rtlCol="0" anchor="ctr"/>
           <a:lstStyle/>
           <a:p>
-            <a:pPr indent="0" marL="0">
+            <a:pPr marL="0" indent="0">
               <a:buNone/>
             </a:pPr>
             <a:r>
@@ -8196,7 +8035,7 @@
           <a:bodyPr wrap="square" lIns="0" tIns="0" rIns="0" bIns="0" rtlCol="0" anchor="ctr"/>
           <a:lstStyle/>
           <a:p>
-            <a:pPr algn="r" indent="0" marL="0">
+            <a:pPr marL="0" indent="0" algn="r">
               <a:buNone/>
             </a:pPr>
             <a:r>
@@ -8230,6 +8069,7 @@
         <a:solidFill>
           <a:srgbClr val="17171D"/>
         </a:solidFill>
+        <a:effectLst/>
       </p:bgPr>
     </p:bg>
     <p:spTree>
@@ -8267,7 +8107,7 @@
           <a:bodyPr wrap="square" lIns="0" tIns="0" rIns="0" bIns="0" rtlCol="0" anchor="ctr"/>
           <a:lstStyle/>
           <a:p>
-            <a:pPr indent="0" marL="0">
+            <a:pPr marL="0" indent="0">
               <a:buNone/>
             </a:pPr>
             <a:r>
@@ -8306,7 +8146,7 @@
           <a:bodyPr wrap="square" lIns="0" tIns="0" rIns="0" bIns="0" rtlCol="0" anchor="t"/>
           <a:lstStyle/>
           <a:p>
-            <a:pPr indent="0" marL="0">
+            <a:pPr marL="0" indent="0">
               <a:buNone/>
             </a:pPr>
             <a:r>
@@ -8323,7 +8163,7 @@
             <a:endParaRPr lang="en-US" sz="1600" dirty="0"/>
           </a:p>
           <a:p>
-            <a:pPr indent="0" marL="0">
+            <a:pPr marL="0" indent="0">
               <a:buNone/>
             </a:pPr>
             <a:r>
@@ -8362,7 +8202,7 @@
           <a:bodyPr wrap="square" lIns="0" tIns="0" rIns="0" bIns="0" rtlCol="0" anchor="t"/>
           <a:lstStyle/>
           <a:p>
-            <a:pPr indent="0" marL="0">
+            <a:pPr marL="0" indent="0">
               <a:buNone/>
             </a:pPr>
             <a:r>
@@ -8379,7 +8219,7 @@
             <a:endParaRPr lang="en-US" sz="1600" dirty="0"/>
           </a:p>
           <a:p>
-            <a:pPr indent="0" marL="0">
+            <a:pPr marL="0" indent="0">
               <a:buNone/>
             </a:pPr>
             <a:r>
@@ -8418,7 +8258,7 @@
           <a:bodyPr wrap="square" lIns="0" tIns="0" rIns="0" bIns="0" rtlCol="0" anchor="t"/>
           <a:lstStyle/>
           <a:p>
-            <a:pPr indent="0" marL="0">
+            <a:pPr marL="0" indent="0">
               <a:buNone/>
             </a:pPr>
             <a:r>
@@ -8435,7 +8275,7 @@
             <a:endParaRPr lang="en-US" sz="1600" dirty="0"/>
           </a:p>
           <a:p>
-            <a:pPr indent="0" marL="0">
+            <a:pPr marL="0" indent="0">
               <a:buNone/>
             </a:pPr>
             <a:r>
@@ -8455,15 +8295,15 @@
       </p:sp>
       <p:pic>
         <p:nvPicPr>
-          <p:cNvPr id="6" name="Image 0" descr="C:\Users\Annie\AppData\Local\Temp\claude\C--Users-Annie-Desktop-AUA-Artificial-Intelligence-GroupProject\3713b754-8c0d-4788-ba37-4fc6479a5014\scratchpad\gui_screenshot.png">    </p:cNvPr>
+          <p:cNvPr id="6" name="Image 0" descr="C:\Users\Annie\AppData\Local\Temp\claude\C--Users-Annie-Desktop-AUA-Artificial-Intelligence-GroupProject\3713b754-8c0d-4788-ba37-4fc6479a5014\scratchpad\gui_screenshot.png"/>
           <p:cNvPicPr>
             <a:picLocks noChangeAspect="1"/>
           </p:cNvPicPr>
           <p:nvPr/>
         </p:nvPicPr>
         <p:blipFill>
-          <a:blip r:embed="rId1"/>
-          <a:srcRect l="0" r="0" t="0" b="0"/>
+          <a:blip r:embed="rId3"/>
+          <a:srcRect/>
           <a:stretch/>
         </p:blipFill>
         <p:spPr>
@@ -8497,7 +8337,7 @@
           <a:bodyPr wrap="square" lIns="0" tIns="0" rIns="0" bIns="0" rtlCol="0" anchor="ctr"/>
           <a:lstStyle/>
           <a:p>
-            <a:pPr algn="r" indent="0" marL="0">
+            <a:pPr marL="0" indent="0" algn="r">
               <a:buNone/>
             </a:pPr>
             <a:r>
@@ -8531,6 +8371,7 @@
         <a:solidFill>
           <a:srgbClr val="17171D"/>
         </a:solidFill>
+        <a:effectLst/>
       </p:bgPr>
     </p:bg>
     <p:spTree>
@@ -8568,7 +8409,7 @@
           <a:bodyPr wrap="square" lIns="0" tIns="0" rIns="0" bIns="0" rtlCol="0" anchor="ctr"/>
           <a:lstStyle/>
           <a:p>
-            <a:pPr indent="0" marL="0">
+            <a:pPr marL="0" indent="0">
               <a:buNone/>
             </a:pPr>
             <a:r>
@@ -8607,7 +8448,7 @@
           <a:bodyPr wrap="square" lIns="0" tIns="0" rIns="0" bIns="0" rtlCol="0" anchor="t"/>
           <a:lstStyle/>
           <a:p>
-            <a:pPr indent="0" marL="0">
+            <a:pPr marL="0" indent="0">
               <a:buNone/>
             </a:pPr>
             <a:r>
@@ -8706,7 +8547,7 @@
           <a:bodyPr wrap="square" lIns="0" tIns="0" rIns="0" bIns="0" rtlCol="0" anchor="t"/>
           <a:lstStyle/>
           <a:p>
-            <a:pPr indent="0" marL="0">
+            <a:pPr marL="0" indent="0">
               <a:buNone/>
             </a:pPr>
             <a:r>
@@ -8827,7 +8668,7 @@
           <a:bodyPr wrap="square" lIns="0" tIns="0" rIns="0" bIns="0" rtlCol="0" anchor="ctr"/>
           <a:lstStyle/>
           <a:p>
-            <a:pPr indent="0" marL="0">
+            <a:pPr marL="0" indent="0">
               <a:buNone/>
             </a:pPr>
             <a:r>
@@ -8866,7 +8707,7 @@
           <a:bodyPr wrap="square" lIns="0" tIns="0" rIns="0" bIns="0" rtlCol="0" anchor="ctr"/>
           <a:lstStyle/>
           <a:p>
-            <a:pPr algn="r" indent="0" marL="0">
+            <a:pPr marL="0" indent="0" algn="r">
               <a:buNone/>
             </a:pPr>
             <a:r>
@@ -8900,6 +8741,7 @@
         <a:solidFill>
           <a:srgbClr val="17171D"/>
         </a:solidFill>
+        <a:effectLst/>
       </p:bgPr>
     </p:bg>
     <p:spTree>
@@ -8937,7 +8779,7 @@
           <a:bodyPr wrap="square" lIns="0" tIns="0" rIns="0" bIns="0" rtlCol="0" anchor="ctr"/>
           <a:lstStyle/>
           <a:p>
-            <a:pPr indent="0" marL="0">
+            <a:pPr marL="0" indent="0">
               <a:buNone/>
             </a:pPr>
             <a:r>
@@ -8976,7 +8818,7 @@
           <a:bodyPr wrap="square" lIns="0" tIns="0" rIns="0" bIns="0" rtlCol="0" anchor="ctr"/>
           <a:lstStyle/>
           <a:p>
-            <a:pPr indent="0" marL="0">
+            <a:pPr marL="0" indent="0">
               <a:buNone/>
             </a:pPr>
             <a:r>
@@ -9015,7 +8857,7 @@
           <a:bodyPr wrap="square" lIns="0" tIns="0" rIns="0" bIns="0" rtlCol="0" anchor="ctr"/>
           <a:lstStyle/>
           <a:p>
-            <a:pPr indent="0" marL="0">
+            <a:pPr marL="0" indent="0">
               <a:buNone/>
             </a:pPr>
             <a:r>
@@ -9032,7 +8874,7 @@
             <a:endParaRPr lang="en-US" sz="1200" dirty="0"/>
           </a:p>
           <a:p>
-            <a:pPr indent="0" marL="0">
+            <a:pPr marL="0" indent="0">
               <a:buNone/>
             </a:pPr>
             <a:r>
@@ -9071,7 +8913,7 @@
           <a:bodyPr wrap="square" lIns="0" tIns="0" rIns="0" bIns="0" rtlCol="0" anchor="ctr"/>
           <a:lstStyle/>
           <a:p>
-            <a:pPr indent="0" marL="0">
+            <a:pPr marL="0" indent="0">
               <a:buNone/>
             </a:pPr>
             <a:r>
@@ -9110,7 +8952,7 @@
           <a:bodyPr wrap="square" lIns="0" tIns="0" rIns="0" bIns="0" rtlCol="0" anchor="ctr"/>
           <a:lstStyle/>
           <a:p>
-            <a:pPr indent="0" marL="0">
+            <a:pPr marL="0" indent="0">
               <a:buNone/>
             </a:pPr>
             <a:r>
@@ -9127,7 +8969,7 @@
             <a:endParaRPr lang="en-US" sz="1200" dirty="0"/>
           </a:p>
           <a:p>
-            <a:pPr indent="0" marL="0">
+            <a:pPr marL="0" indent="0">
               <a:buNone/>
             </a:pPr>
             <a:r>
@@ -9147,14 +8989,14 @@
       </p:sp>
       <p:pic>
         <p:nvPicPr>
-          <p:cNvPr id="7" name="Image 0" descr="C:\Users\Annie\Desktop\AUA\Artificial Intelligence\GroupProject\LightUp\experiments\results\fig1_bt_scaling.png">    </p:cNvPr>
+          <p:cNvPr id="7" name="Image 0" descr="C:\Users\Annie\Desktop\AUA\Artificial Intelligence\GroupProject\LightUp\experiments\results\fig1_bt_scaling.png"/>
           <p:cNvPicPr>
             <a:picLocks noChangeAspect="1"/>
           </p:cNvPicPr>
           <p:nvPr/>
         </p:nvPicPr>
         <p:blipFill>
-          <a:blip r:embed="rId1"/>
+          <a:blip r:embed="rId3"/>
           <a:stretch>
             <a:fillRect/>
           </a:stretch>
@@ -9190,7 +9032,7 @@
           <a:bodyPr wrap="square" lIns="0" tIns="0" rIns="0" bIns="0" rtlCol="0" anchor="ctr"/>
           <a:lstStyle/>
           <a:p>
-            <a:pPr indent="0" marL="0">
+            <a:pPr marL="0" indent="0">
               <a:buNone/>
             </a:pPr>
             <a:r>
@@ -9229,7 +9071,7 @@
           <a:bodyPr wrap="square" lIns="0" tIns="0" rIns="0" bIns="0" rtlCol="0" anchor="ctr"/>
           <a:lstStyle/>
           <a:p>
-            <a:pPr algn="r" indent="0" marL="0">
+            <a:pPr marL="0" indent="0" algn="r">
               <a:buNone/>
             </a:pPr>
             <a:r>
@@ -9263,6 +9105,7 @@
         <a:solidFill>
           <a:srgbClr val="17171D"/>
         </a:solidFill>
+        <a:effectLst/>
       </p:bgPr>
     </p:bg>
     <p:spTree>
@@ -9300,7 +9143,7 @@
           <a:bodyPr wrap="square" lIns="0" tIns="0" rIns="0" bIns="0" rtlCol="0" anchor="ctr"/>
           <a:lstStyle/>
           <a:p>
-            <a:pPr indent="0" marL="0">
+            <a:pPr marL="0" indent="0">
               <a:buNone/>
             </a:pPr>
             <a:r>
@@ -9320,15 +9163,15 @@
       </p:sp>
       <p:pic>
         <p:nvPicPr>
-          <p:cNvPr id="3" name="Image 0" descr="C:\Users\Annie\Desktop\AUA\Artificial Intelligence\GroupProject\LightUp\experiments\results\fig2_paradigms.png">    </p:cNvPr>
+          <p:cNvPr id="3" name="Image 0" descr="C:\Users\Annie\Desktop\AUA\Artificial Intelligence\GroupProject\LightUp\experiments\results\fig2_paradigms.png"/>
           <p:cNvPicPr>
             <a:picLocks noChangeAspect="1"/>
           </p:cNvPicPr>
           <p:nvPr/>
         </p:nvPicPr>
         <p:blipFill>
-          <a:blip r:embed="rId1"/>
-          <a:srcRect l="0" r="0" t="0" b="0"/>
+          <a:blip r:embed="rId3"/>
+          <a:srcRect/>
           <a:stretch/>
         </p:blipFill>
         <p:spPr>
@@ -9362,7 +9205,7 @@
           <a:bodyPr wrap="square" lIns="0" tIns="0" rIns="0" bIns="0" rtlCol="0" anchor="t"/>
           <a:lstStyle/>
           <a:p>
-            <a:pPr indent="0" marL="0">
+            <a:pPr marL="0" indent="0">
               <a:spcAft>
                 <a:spcPts val="800"/>
               </a:spcAft>
@@ -9485,7 +9328,7 @@
           <a:bodyPr wrap="square" lIns="0" tIns="0" rIns="0" bIns="0" rtlCol="0" anchor="ctr"/>
           <a:lstStyle/>
           <a:p>
-            <a:pPr algn="r" indent="0" marL="0">
+            <a:pPr marL="0" indent="0" algn="r">
               <a:buNone/>
             </a:pPr>
             <a:r>
@@ -9804,4 +9647,319 @@
     </a:ext>
   </a:extLst>
 </a:theme>
+</file>
+
+<file path=ppt/theme/theme2.xml><?xml version="1.0" encoding="utf-8"?>
+<a:theme xmlns:a="http://schemas.openxmlformats.org/drawingml/2006/main" name="Office Theme">
+  <a:themeElements>
+    <a:clrScheme name="Office">
+      <a:dk1>
+        <a:sysClr val="windowText" lastClr="000000"/>
+      </a:dk1>
+      <a:lt1>
+        <a:sysClr val="window" lastClr="FFFFFF"/>
+      </a:lt1>
+      <a:dk2>
+        <a:srgbClr val="0E2841"/>
+      </a:dk2>
+      <a:lt2>
+        <a:srgbClr val="E8E8E8"/>
+      </a:lt2>
+      <a:accent1>
+        <a:srgbClr val="156082"/>
+      </a:accent1>
+      <a:accent2>
+        <a:srgbClr val="E97132"/>
+      </a:accent2>
+      <a:accent3>
+        <a:srgbClr val="196B24"/>
+      </a:accent3>
+      <a:accent4>
+        <a:srgbClr val="0F9ED5"/>
+      </a:accent4>
+      <a:accent5>
+        <a:srgbClr val="A02B93"/>
+      </a:accent5>
+      <a:accent6>
+        <a:srgbClr val="4EA72E"/>
+      </a:accent6>
+      <a:hlink>
+        <a:srgbClr val="467886"/>
+      </a:hlink>
+      <a:folHlink>
+        <a:srgbClr val="96607D"/>
+      </a:folHlink>
+    </a:clrScheme>
+    <a:fontScheme name="Office">
+      <a:majorFont>
+        <a:latin typeface="Aptos Display" panose="02110004020202020204"/>
+        <a:ea typeface=""/>
+        <a:cs typeface=""/>
+        <a:font script="Jpan" typeface="游ゴシック Light"/>
+        <a:font script="Hang" typeface="맑은 고딕"/>
+        <a:font script="Hans" typeface="等线 Light"/>
+        <a:font script="Hant" typeface="新細明體"/>
+        <a:font script="Arab" typeface="Times New Roman"/>
+        <a:font script="Hebr" typeface="Times New Roman"/>
+        <a:font script="Thai" typeface="Angsana New"/>
+        <a:font script="Ethi" typeface="Nyala"/>
+        <a:font script="Beng" typeface="Vrinda"/>
+        <a:font script="Gujr" typeface="Shruti"/>
+        <a:font script="Khmr" typeface="MoolBoran"/>
+        <a:font script="Knda" typeface="Tunga"/>
+        <a:font script="Guru" typeface="Raavi"/>
+        <a:font script="Cans" typeface="Euphemia"/>
+        <a:font script="Cher" typeface="Plantagenet Cherokee"/>
+        <a:font script="Yiii" typeface="Microsoft Yi Baiti"/>
+        <a:font script="Tibt" typeface="Microsoft Himalaya"/>
+        <a:font script="Thaa" typeface="MV Boli"/>
+        <a:font script="Deva" typeface="Mangal"/>
+        <a:font script="Telu" typeface="Gautami"/>
+        <a:font script="Taml" typeface="Latha"/>
+        <a:font script="Syrc" typeface="Estrangelo Edessa"/>
+        <a:font script="Orya" typeface="Kalinga"/>
+        <a:font script="Mlym" typeface="Kartika"/>
+        <a:font script="Laoo" typeface="DokChampa"/>
+        <a:font script="Sinh" typeface="Iskoola Pota"/>
+        <a:font script="Mong" typeface="Mongolian Baiti"/>
+        <a:font script="Viet" typeface="Times New Roman"/>
+        <a:font script="Uigh" typeface="Microsoft Uighur"/>
+        <a:font script="Geor" typeface="Sylfaen"/>
+        <a:font script="Armn" typeface="Arial"/>
+        <a:font script="Bugi" typeface="Leelawadee UI"/>
+        <a:font script="Bopo" typeface="Microsoft JhengHei"/>
+        <a:font script="Java" typeface="Javanese Text"/>
+        <a:font script="Lisu" typeface="Segoe UI"/>
+        <a:font script="Mymr" typeface="Myanmar Text"/>
+        <a:font script="Nkoo" typeface="Ebrima"/>
+        <a:font script="Olck" typeface="Nirmala UI"/>
+        <a:font script="Osma" typeface="Ebrima"/>
+        <a:font script="Phag" typeface="Phagspa"/>
+        <a:font script="Syrn" typeface="Estrangelo Edessa"/>
+        <a:font script="Syrj" typeface="Estrangelo Edessa"/>
+        <a:font script="Syre" typeface="Estrangelo Edessa"/>
+        <a:font script="Sora" typeface="Nirmala UI"/>
+        <a:font script="Tale" typeface="Microsoft Tai Le"/>
+        <a:font script="Talu" typeface="Microsoft New Tai Lue"/>
+        <a:font script="Tfng" typeface="Ebrima"/>
+      </a:majorFont>
+      <a:minorFont>
+        <a:latin typeface="Aptos" panose="02110004020202020204"/>
+        <a:ea typeface=""/>
+        <a:cs typeface=""/>
+        <a:font script="Jpan" typeface="游ゴシック"/>
+        <a:font script="Hang" typeface="맑은 고딕"/>
+        <a:font script="Hans" typeface="等线"/>
+        <a:font script="Hant" typeface="新細明體"/>
+        <a:font script="Arab" typeface="Arial"/>
+        <a:font script="Hebr" typeface="Arial"/>
+        <a:font script="Thai" typeface="Cordia New"/>
+        <a:font script="Ethi" typeface="Nyala"/>
+        <a:font script="Beng" typeface="Vrinda"/>
+        <a:font script="Gujr" typeface="Shruti"/>
+        <a:font script="Khmr" typeface="DaunPenh"/>
+        <a:font script="Knda" typeface="Tunga"/>
+        <a:font script="Guru" typeface="Raavi"/>
+        <a:font script="Cans" typeface="Euphemia"/>
+        <a:font script="Cher" typeface="Plantagenet Cherokee"/>
+        <a:font script="Yiii" typeface="Microsoft Yi Baiti"/>
+        <a:font script="Tibt" typeface="Microsoft Himalaya"/>
+        <a:font script="Thaa" typeface="MV Boli"/>
+        <a:font script="Deva" typeface="Mangal"/>
+        <a:font script="Telu" typeface="Gautami"/>
+        <a:font script="Taml" typeface="Latha"/>
+        <a:font script="Syrc" typeface="Estrangelo Edessa"/>
+        <a:font script="Orya" typeface="Kalinga"/>
+        <a:font script="Mlym" typeface="Kartika"/>
+        <a:font script="Laoo" typeface="DokChampa"/>
+        <a:font script="Sinh" typeface="Iskoola Pota"/>
+        <a:font script="Mong" typeface="Mongolian Baiti"/>
+        <a:font script="Viet" typeface="Arial"/>
+        <a:font script="Uigh" typeface="Microsoft Uighur"/>
+        <a:font script="Geor" typeface="Sylfaen"/>
+        <a:font script="Armn" typeface="Arial"/>
+        <a:font script="Bugi" typeface="Leelawadee UI"/>
+        <a:font script="Bopo" typeface="Microsoft JhengHei"/>
+        <a:font script="Java" typeface="Javanese Text"/>
+        <a:font script="Lisu" typeface="Segoe UI"/>
+        <a:font script="Mymr" typeface="Myanmar Text"/>
+        <a:font script="Nkoo" typeface="Ebrima"/>
+        <a:font script="Olck" typeface="Nirmala UI"/>
+        <a:font script="Osma" typeface="Ebrima"/>
+        <a:font script="Phag" typeface="Phagspa"/>
+        <a:font script="Syrn" typeface="Estrangelo Edessa"/>
+        <a:font script="Syrj" typeface="Estrangelo Edessa"/>
+        <a:font script="Syre" typeface="Estrangelo Edessa"/>
+        <a:font script="Sora" typeface="Nirmala UI"/>
+        <a:font script="Tale" typeface="Microsoft Tai Le"/>
+        <a:font script="Talu" typeface="Microsoft New Tai Lue"/>
+        <a:font script="Tfng" typeface="Ebrima"/>
+      </a:minorFont>
+    </a:fontScheme>
+    <a:fmtScheme name="Office">
+      <a:fillStyleLst>
+        <a:solidFill>
+          <a:schemeClr val="phClr"/>
+        </a:solidFill>
+        <a:gradFill rotWithShape="1">
+          <a:gsLst>
+            <a:gs pos="0">
+              <a:schemeClr val="phClr">
+                <a:lumMod val="110000"/>
+                <a:satMod val="105000"/>
+                <a:tint val="67000"/>
+              </a:schemeClr>
+            </a:gs>
+            <a:gs pos="50000">
+              <a:schemeClr val="phClr">
+                <a:lumMod val="105000"/>
+                <a:satMod val="103000"/>
+                <a:tint val="73000"/>
+              </a:schemeClr>
+            </a:gs>
+            <a:gs pos="100000">
+              <a:schemeClr val="phClr">
+                <a:lumMod val="105000"/>
+                <a:satMod val="109000"/>
+                <a:tint val="81000"/>
+              </a:schemeClr>
+            </a:gs>
+          </a:gsLst>
+          <a:lin ang="5400000" scaled="0"/>
+        </a:gradFill>
+        <a:gradFill rotWithShape="1">
+          <a:gsLst>
+            <a:gs pos="0">
+              <a:schemeClr val="phClr">
+                <a:satMod val="103000"/>
+                <a:lumMod val="102000"/>
+                <a:tint val="94000"/>
+              </a:schemeClr>
+            </a:gs>
+            <a:gs pos="50000">
+              <a:schemeClr val="phClr">
+                <a:satMod val="110000"/>
+                <a:lumMod val="100000"/>
+                <a:shade val="100000"/>
+              </a:schemeClr>
+            </a:gs>
+            <a:gs pos="100000">
+              <a:schemeClr val="phClr">
+                <a:lumMod val="99000"/>
+                <a:satMod val="120000"/>
+                <a:shade val="78000"/>
+              </a:schemeClr>
+            </a:gs>
+          </a:gsLst>
+          <a:lin ang="5400000" scaled="0"/>
+        </a:gradFill>
+      </a:fillStyleLst>
+      <a:lnStyleLst>
+        <a:ln w="12700" cap="flat" cmpd="sng" algn="ctr">
+          <a:solidFill>
+            <a:schemeClr val="phClr"/>
+          </a:solidFill>
+          <a:prstDash val="solid"/>
+          <a:miter lim="800000"/>
+        </a:ln>
+        <a:ln w="19050" cap="flat" cmpd="sng" algn="ctr">
+          <a:solidFill>
+            <a:schemeClr val="phClr"/>
+          </a:solidFill>
+          <a:prstDash val="solid"/>
+          <a:miter lim="800000"/>
+        </a:ln>
+        <a:ln w="25400" cap="flat" cmpd="sng" algn="ctr">
+          <a:solidFill>
+            <a:schemeClr val="phClr"/>
+          </a:solidFill>
+          <a:prstDash val="solid"/>
+          <a:miter lim="800000"/>
+        </a:ln>
+      </a:lnStyleLst>
+      <a:effectStyleLst>
+        <a:effectStyle>
+          <a:effectLst/>
+        </a:effectStyle>
+        <a:effectStyle>
+          <a:effectLst/>
+        </a:effectStyle>
+        <a:effectStyle>
+          <a:effectLst>
+            <a:outerShdw blurRad="57150" dist="19050" dir="5400000" algn="ctr" rotWithShape="0">
+              <a:srgbClr val="000000">
+                <a:alpha val="63000"/>
+              </a:srgbClr>
+            </a:outerShdw>
+          </a:effectLst>
+        </a:effectStyle>
+      </a:effectStyleLst>
+      <a:bgFillStyleLst>
+        <a:solidFill>
+          <a:schemeClr val="phClr"/>
+        </a:solidFill>
+        <a:solidFill>
+          <a:schemeClr val="phClr">
+            <a:tint val="95000"/>
+            <a:satMod val="170000"/>
+          </a:schemeClr>
+        </a:solidFill>
+        <a:gradFill rotWithShape="1">
+          <a:gsLst>
+            <a:gs pos="0">
+              <a:schemeClr val="phClr">
+                <a:tint val="93000"/>
+                <a:satMod val="150000"/>
+                <a:shade val="98000"/>
+                <a:lumMod val="102000"/>
+              </a:schemeClr>
+            </a:gs>
+            <a:gs pos="50000">
+              <a:schemeClr val="phClr">
+                <a:tint val="98000"/>
+                <a:satMod val="130000"/>
+                <a:shade val="90000"/>
+                <a:lumMod val="103000"/>
+              </a:schemeClr>
+            </a:gs>
+            <a:gs pos="100000">
+              <a:schemeClr val="phClr">
+                <a:shade val="63000"/>
+                <a:satMod val="120000"/>
+              </a:schemeClr>
+            </a:gs>
+          </a:gsLst>
+          <a:lin ang="5400000" scaled="0"/>
+        </a:gradFill>
+      </a:bgFillStyleLst>
+    </a:fmtScheme>
+  </a:themeElements>
+  <a:objectDefaults>
+    <a:lnDef>
+      <a:spPr/>
+      <a:bodyPr/>
+      <a:lstStyle/>
+      <a:style>
+        <a:lnRef idx="2">
+          <a:schemeClr val="accent1"/>
+        </a:lnRef>
+        <a:fillRef idx="0">
+          <a:schemeClr val="accent1"/>
+        </a:fillRef>
+        <a:effectRef idx="1">
+          <a:schemeClr val="accent1"/>
+        </a:effectRef>
+        <a:fontRef idx="minor">
+          <a:schemeClr val="tx1"/>
+        </a:fontRef>
+      </a:style>
+    </a:lnDef>
+  </a:objectDefaults>
+  <a:extraClrSchemeLst/>
+  <a:extLst>
+    <a:ext uri="{05A4C25C-085E-4340-85A3-A5531E510DB2}">
+      <thm15:themeFamily xmlns:thm15="http://schemas.microsoft.com/office/thememl/2012/main" name="Office Theme" id="{2E142A2C-CD16-42D6-873A-C26D2A0506FA}" vid="{1BDDFF52-6CD6-40A5-AB3C-68EB2F1E4D0A}"/>
+    </a:ext>
+  </a:extLst>
+</a:theme>
 </file>
</xml_diff>

<commit_message>
Add budget-robustness slide (11 of 13)
fig4 with a two-line takeaway; speaker note carries the single spoken
sentence and the Q&A follow-up about pre-registered predictions.
Conclusions and References shift to 12-13.

Co-Authored-By: Claude Fable 5 <noreply@anthropic.com>
</commit_message>
<xml_diff>
--- a/presentation.pptx
+++ b/presentation.pptx
@@ -4,9 +4,6 @@
   <p:sldMasterIdLst>
     <p:sldMasterId id="2147483648" r:id="rId1"/>
   </p:sldMasterIdLst>
-  <p:notesMasterIdLst>
-    <p:notesMasterId r:id="rId14"/>
-  </p:notesMasterIdLst>
   <p:sldIdLst>
     <p:sldId id="256" r:id="rId2"/>
     <p:sldId id="257" r:id="rId3"/>
@@ -20,7 +17,11 @@
     <p:sldId id="265" r:id="rId11"/>
     <p:sldId id="266" r:id="rId12"/>
     <p:sldId id="267" r:id="rId13"/>
+    <p:sldId id="268" r:id="rId14"/>
   </p:sldIdLst>
+  <p:notesMasterIdLst>
+    <p:notesMasterId r:id="rId15"/>
+  </p:notesMasterIdLst>
   <p:sldSz cx="12192000" cy="6858000"/>
   <p:notesSz cx="6858000" cy="12192000"/>
   <p:defaultTextStyle>
@@ -115,11 +116,6 @@
       </a:defRPr>
     </a:lvl9pPr>
   </p:defaultTextStyle>
-  <p:extLst>
-    <p:ext uri="{EFAFB233-063F-42B5-8137-9DF3F51BA10A}">
-      <p15:sldGuideLst xmlns:p15="http://schemas.microsoft.com/office/powerpoint/2012/main"/>
-    </p:ext>
-  </p:extLst>
 </p:presentation>
 </file>
 
@@ -145,10 +141,234 @@
           <a:chExt cx="0" cy="0"/>
         </a:xfrm>
       </p:grpSpPr>
+      <p:sp>
+        <p:nvSpPr>
+          <p:cNvPr id="2" name="Header Placeholder 1"/>
+          <p:cNvSpPr>
+            <a:spLocks noGrp="1"/>
+          </p:cNvSpPr>
+          <p:nvPr>
+            <p:ph type="hdr" sz="quarter"/>
+          </p:nvPr>
+        </p:nvSpPr>
+        <p:spPr>
+          <a:xfrm>
+            <a:off x="0" y="0"/>
+            <a:ext cx="2971800" cy="458788"/>
+          </a:xfrm>
+          <a:prstGeom prst="rect">
+            <a:avLst/>
+          </a:prstGeom>
+        </p:spPr>
+        <p:txBody>
+          <a:bodyPr vert="horz" lIns="91440" tIns="45720" rIns="91440" bIns="45720" rtlCol="0"/>
+          <a:lstStyle>
+            <a:lvl1pPr algn="l">
+              <a:defRPr sz="1200"/>
+            </a:lvl1pPr>
+          </a:lstStyle>
+          <a:p>
+            <a:endParaRPr lang="en-US"/>
+          </a:p>
+        </p:txBody>
+      </p:sp>
+      <p:sp>
+        <p:nvSpPr>
+          <p:cNvPr id="3" name="Date Placeholder 2"/>
+          <p:cNvSpPr>
+            <a:spLocks noGrp="1"/>
+          </p:cNvSpPr>
+          <p:nvPr>
+            <p:ph type="dt" idx="1"/>
+          </p:nvPr>
+        </p:nvSpPr>
+        <p:spPr>
+          <a:xfrm>
+            <a:off x="3884613" y="0"/>
+            <a:ext cx="2971800" cy="458788"/>
+          </a:xfrm>
+          <a:prstGeom prst="rect">
+            <a:avLst/>
+          </a:prstGeom>
+        </p:spPr>
+        <p:txBody>
+          <a:bodyPr vert="horz" lIns="91440" tIns="45720" rIns="91440" bIns="45720" rtlCol="0"/>
+          <a:lstStyle>
+            <a:lvl1pPr algn="r">
+              <a:defRPr sz="1200"/>
+            </a:lvl1pPr>
+          </a:lstStyle>
+          <a:p>
+            <a:fld id="{5282F153-3F37-0F45-9E97-73ACFA13230C}" type="datetimeFigureOut">
+              <a:rPr lang="en-US"/>
+              <a:t>7/23/19</a:t>
+            </a:fld>
+            <a:endParaRPr lang="en-US"/>
+          </a:p>
+        </p:txBody>
+      </p:sp>
+      <p:sp>
+        <p:nvSpPr>
+          <p:cNvPr id="4" name="Slide Image Placeholder 3"/>
+          <p:cNvSpPr>
+            <a:spLocks noGrp="1" noRot="1" noChangeAspect="1"/>
+          </p:cNvSpPr>
+          <p:nvPr>
+            <p:ph type="sldImg" idx="2"/>
+          </p:nvPr>
+        </p:nvSpPr>
+        <p:spPr>
+          <a:xfrm>
+            <a:off x="685800" y="1143000"/>
+            <a:ext cx="5486400" cy="3086100"/>
+          </a:xfrm>
+          <a:prstGeom prst="rect">
+            <a:avLst/>
+          </a:prstGeom>
+          <a:noFill/>
+          <a:ln w="12700">
+            <a:solidFill>
+              <a:prstClr val="black"/>
+            </a:solidFill>
+          </a:ln>
+        </p:spPr>
+        <p:txBody>
+          <a:bodyPr vert="horz" lIns="91440" tIns="45720" rIns="91440" bIns="45720" rtlCol="0" anchor="ctr"/>
+          <a:lstStyle/>
+          <a:p>
+            <a:endParaRPr lang="en-US"/>
+          </a:p>
+        </p:txBody>
+      </p:sp>
+      <p:sp>
+        <p:nvSpPr>
+          <p:cNvPr id="5" name="Notes Placeholder 4"/>
+          <p:cNvSpPr>
+            <a:spLocks noGrp="1"/>
+          </p:cNvSpPr>
+          <p:nvPr>
+            <p:ph type="body" sz="quarter" idx="3"/>
+          </p:nvPr>
+        </p:nvSpPr>
+        <p:spPr>
+          <a:xfrm>
+            <a:off x="685800" y="4400550"/>
+            <a:ext cx="5486400" cy="3600450"/>
+          </a:xfrm>
+          <a:prstGeom prst="rect">
+            <a:avLst/>
+          </a:prstGeom>
+        </p:spPr>
+        <p:txBody>
+          <a:bodyPr vert="horz" lIns="91440" tIns="45720" rIns="91440" bIns="45720" rtlCol="0"/>
+          <a:lstStyle/>
+          <a:p>
+            <a:pPr lvl="0"/>
+            <a:r>
+              <a:rPr lang="en-US"/>
+              <a:t>Click to edit Master text styles</a:t>
+            </a:r>
+          </a:p>
+          <a:p>
+            <a:pPr lvl="1"/>
+            <a:r>
+              <a:rPr lang="en-US"/>
+              <a:t>Second level</a:t>
+            </a:r>
+          </a:p>
+          <a:p>
+            <a:pPr lvl="2"/>
+            <a:r>
+              <a:rPr lang="en-US"/>
+              <a:t>Third level</a:t>
+            </a:r>
+          </a:p>
+          <a:p>
+            <a:pPr lvl="3"/>
+            <a:r>
+              <a:rPr lang="en-US"/>
+              <a:t>Fourth level</a:t>
+            </a:r>
+          </a:p>
+          <a:p>
+            <a:pPr lvl="4"/>
+            <a:r>
+              <a:rPr lang="en-US"/>
+              <a:t>Fifth level</a:t>
+            </a:r>
+          </a:p>
+        </p:txBody>
+      </p:sp>
+      <p:sp>
+        <p:nvSpPr>
+          <p:cNvPr id="6" name="Footer Placeholder 5"/>
+          <p:cNvSpPr>
+            <a:spLocks noGrp="1"/>
+          </p:cNvSpPr>
+          <p:nvPr>
+            <p:ph type="ftr" sz="quarter" idx="4"/>
+          </p:nvPr>
+        </p:nvSpPr>
+        <p:spPr>
+          <a:xfrm>
+            <a:off x="0" y="8685213"/>
+            <a:ext cx="2971800" cy="458787"/>
+          </a:xfrm>
+          <a:prstGeom prst="rect">
+            <a:avLst/>
+          </a:prstGeom>
+        </p:spPr>
+        <p:txBody>
+          <a:bodyPr vert="horz" lIns="91440" tIns="45720" rIns="91440" bIns="45720" rtlCol="0" anchor="b"/>
+          <a:lstStyle>
+            <a:lvl1pPr algn="l">
+              <a:defRPr sz="1200"/>
+            </a:lvl1pPr>
+          </a:lstStyle>
+          <a:p>
+            <a:endParaRPr lang="en-US"/>
+          </a:p>
+        </p:txBody>
+      </p:sp>
+      <p:sp>
+        <p:nvSpPr>
+          <p:cNvPr id="7" name="Slide Number Placeholder 6"/>
+          <p:cNvSpPr>
+            <a:spLocks noGrp="1"/>
+          </p:cNvSpPr>
+          <p:nvPr>
+            <p:ph type="sldNum" sz="quarter" idx="5"/>
+          </p:nvPr>
+        </p:nvSpPr>
+        <p:spPr>
+          <a:xfrm>
+            <a:off x="3884613" y="8685213"/>
+            <a:ext cx="2971800" cy="458787"/>
+          </a:xfrm>
+          <a:prstGeom prst="rect">
+            <a:avLst/>
+          </a:prstGeom>
+        </p:spPr>
+        <p:txBody>
+          <a:bodyPr vert="horz" lIns="91440" tIns="45720" rIns="91440" bIns="45720" rtlCol="0" anchor="b"/>
+          <a:lstStyle>
+            <a:lvl1pPr algn="r">
+              <a:defRPr sz="1200"/>
+            </a:lvl1pPr>
+          </a:lstStyle>
+          <a:p>
+            <a:fld id="{CE5E9CC1-C706-0F49-92D6-E571CC5EEA8F}" type="slidenum">
+              <a:rPr lang="en-US"/>
+              <a:t>‹#›</a:t>
+            </a:fld>
+            <a:endParaRPr lang="en-US"/>
+          </a:p>
+        </p:txBody>
+      </p:sp>
     </p:spTree>
     <p:extLst>
       <p:ext uri="{BB962C8B-B14F-4D97-AF65-F5344CB8AC3E}">
-        <p14:creationId xmlns:p14="http://schemas.microsoft.com/office/powerpoint/2010/main" val="3776377255"/>
+        <p14:creationId xmlns:p14="http://schemas.microsoft.com/office/powerpoint/2010/main" val="1024086991"/>
       </p:ext>
     </p:extLst>
   </p:cSld>
@@ -296,6 +516,7 @@
               <a:rPr lang="en-US" dirty="0"/>
               <a:t>~30s. One presenter opens. Replace member placeholders with real names. The board on the right is the Pulles (2021) example puzzle with its unique solution, drawn by our own renderer's conventions.</a:t>
             </a:r>
+            <a:endParaRPr lang="en-US" dirty="0"/>
           </a:p>
         </p:txBody>
       </p:sp>
@@ -383,6 +604,7 @@
               <a:rPr lang="en-US" dirty="0"/>
               <a:t>~1 min. The beyond-the-obvious slide. The headline: our density presets predict difficulty for HUMANS (deduction chains), not for solvers - sparse boards have many solutions and finding any one is easy. Tie back to the uniqueness discussion. Calibrating difficulty by measured effort is named future work.</a:t>
             </a:r>
+            <a:endParaRPr lang="en-US" dirty="0"/>
           </a:p>
         </p:txBody>
       </p:sp>
@@ -468,8 +690,9 @@
           <a:p>
             <a:r>
               <a:rPr lang="en-US" dirty="0"/>
-              <a:t>~45s. Every claim here is a measured number from experiments/results/results.csv (overall: SA 45/75 = 60%, HC 21/75 = 28%; hard-only: 19/25 vs 11/25). All four members should have spoken by now (equal input is graded).</a:t>
-            </a:r>
+              <a:t>ONE sentence, ~20s: 'We re-ran the entire sweep with double the budget - almost nothing changed, and hill climbing gained exactly zero - so the solver ranking is structural, not an artifact of the timeout.' If asked in Q&amp;A: we predicted the outcomes before running (full unchanged, hc zero); the one miss was SA, which we expected to gain more - exponential problems shrug at factors of two.</a:t>
+            </a:r>
+            <a:endParaRPr lang="en-US" dirty="0"/>
           </a:p>
         </p:txBody>
       </p:sp>
@@ -555,8 +778,9 @@
           <a:p>
             <a:r>
               <a:rPr lang="en-US" dirty="0"/>
-              <a:t>Not spoken — present for completeness and Q&amp;A.</a:t>
-            </a:r>
+              <a:t>~45s. Every claim here is a measured number from experiments/results/results.csv (overall: SA 45/75 = 60%, HC 21/75 = 28%; hard-only: 19/25 vs 11/25). All four members should have spoken by now (equal input is graded).</a:t>
+            </a:r>
+            <a:endParaRPr lang="en-US" dirty="0"/>
           </a:p>
         </p:txBody>
       </p:sp>
@@ -578,6 +802,94 @@
             <a:fld id="{F7021451-1387-4CA6-816F-3879F97B5CBC}" type="slidenum">
               <a:rPr lang="en-US"/>
               <a:t>12</a:t>
+            </a:fld>
+            <a:endParaRPr lang="en-US"/>
+          </a:p>
+        </p:txBody>
+      </p:sp>
+    </p:spTree>
+    <p:extLst>
+      <p:ext uri="{BB962C8B-B14F-4D97-AF65-F5344CB8AC3E}">
+        <p14:creationId xmlns:p14="http://schemas.microsoft.com/office/powerpoint/2010/main" val="1024086991"/>
+      </p:ext>
+    </p:extLst>
+  </p:cSld>
+  <p:clrMapOvr>
+    <a:masterClrMapping/>
+  </p:clrMapOvr>
+</p:notes>
+</file>
+
+<file path=ppt/notesSlides/notesSlide13.xml><?xml version="1.0" encoding="utf-8"?>
+<p:notes xmlns:a="http://schemas.openxmlformats.org/drawingml/2006/main" xmlns:r="http://schemas.openxmlformats.org/officeDocument/2006/relationships" xmlns:p="http://schemas.openxmlformats.org/presentationml/2006/main">
+  <p:cSld>
+    <p:spTree>
+      <p:nvGrpSpPr>
+        <p:cNvPr id="1" name=""/>
+        <p:cNvGrpSpPr/>
+        <p:nvPr/>
+      </p:nvGrpSpPr>
+      <p:grpSpPr>
+        <a:xfrm>
+          <a:off x="0" y="0"/>
+          <a:ext cx="0" cy="0"/>
+          <a:chOff x="0" y="0"/>
+          <a:chExt cx="0" cy="0"/>
+        </a:xfrm>
+      </p:grpSpPr>
+      <p:sp>
+        <p:nvSpPr>
+          <p:cNvPr id="2" name="Slide Image Placeholder 1"/>
+          <p:cNvSpPr>
+            <a:spLocks noGrp="1" noRot="1" noChangeAspect="1"/>
+          </p:cNvSpPr>
+          <p:nvPr>
+            <p:ph type="sldImg"/>
+          </p:nvPr>
+        </p:nvSpPr>
+        <p:spPr/>
+      </p:sp>
+      <p:sp>
+        <p:nvSpPr>
+          <p:cNvPr id="3" name="Notes Placeholder 2"/>
+          <p:cNvSpPr>
+            <a:spLocks noGrp="1"/>
+          </p:cNvSpPr>
+          <p:nvPr>
+            <p:ph type="body" idx="1"/>
+          </p:nvPr>
+        </p:nvSpPr>
+        <p:spPr/>
+        <p:txBody>
+          <a:bodyPr/>
+          <a:lstStyle/>
+          <a:p>
+            <a:r>
+              <a:rPr lang="en-US" dirty="0"/>
+              <a:t>Not spoken — present for completeness and Q&amp;A.</a:t>
+            </a:r>
+            <a:endParaRPr lang="en-US" dirty="0"/>
+          </a:p>
+        </p:txBody>
+      </p:sp>
+      <p:sp>
+        <p:nvSpPr>
+          <p:cNvPr id="4" name="Slide Number Placeholder 3"/>
+          <p:cNvSpPr>
+            <a:spLocks noGrp="1"/>
+          </p:cNvSpPr>
+          <p:nvPr>
+            <p:ph type="sldNum" sz="quarter" idx="10"/>
+          </p:nvPr>
+        </p:nvSpPr>
+        <p:spPr/>
+        <p:txBody>
+          <a:bodyPr/>
+          <a:lstStyle/>
+          <a:p>
+            <a:fld id="{F7021451-1387-4CA6-816F-3879F97B5CBC}" type="slidenum">
+              <a:rPr lang="en-US"/>
+              <a:t>13</a:t>
             </a:fld>
             <a:endParaRPr lang="en-US"/>
           </a:p>
@@ -644,6 +956,7 @@
               <a:rPr lang="en-US" dirty="0"/>
               <a:t>~1 min. State the rules quickly with the example. Do NOT dwell — the course requires only a brief problem statement. Mention the uniqueness note; it returns in the analysis.</a:t>
             </a:r>
+            <a:endParaRPr lang="en-US" dirty="0"/>
           </a:p>
         </p:txBody>
       </p:sp>
@@ -731,6 +1044,7 @@
               <a:rPr lang="en-US" dirty="0"/>
               <a:t>~1 min. The three cards are the topic-choice justification. Keep the prior-work strip to two sentences — the course explicitly says existing approaches should be mentioned only very briefly.</a:t>
             </a:r>
+            <a:endParaRPr lang="en-US" dirty="0"/>
           </a:p>
         </p:txBody>
       </p:sp>
@@ -818,6 +1132,7 @@
               <a:rPr lang="en-US" dirty="0"/>
               <a:t>~45s. One slide of formalism, no more. Do NOT explain what a CSP or backtracking is — covered in the course. The 'lit is derived' line preempts a common Q&amp;A question about the domain.</a:t>
             </a:r>
+            <a:endParaRPr lang="en-US" dirty="0"/>
           </a:p>
         </p:txBody>
       </p:sp>
@@ -905,6 +1220,7 @@
               <a:rPr lang="en-US" dirty="0"/>
               <a:t>~1 min. The experiment design in one picture: each arrow on the left changes exactly one thing, so differences in the stats are attributable. Right column is the cross-paradigm comparison.</a:t>
             </a:r>
+            <a:endParaRPr lang="en-US" dirty="0"/>
           </a:p>
         </p:txBody>
       </p:sp>
@@ -992,6 +1308,7 @@
               <a:rPr lang="en-US" dirty="0"/>
               <a:t>~45s. The screenshot is the naive solver mid-replay on a 10x10: red frame = conflict at (9,7), green digits = satisfied clues, status bar streams the event counter and search stats. Demo bait: if time allows in Q&amp;A, a 20-second live solve in the GUI is worth more than this slide. Do not show code.</a:t>
             </a:r>
+            <a:endParaRPr lang="en-US" dirty="0"/>
           </a:p>
         </p:txBody>
       </p:sp>
@@ -1079,6 +1396,7 @@
               <a:rPr lang="en-US" dirty="0"/>
               <a:t>~45s. Fill the two [CONFIRM] blanks once the experiment harness is final. The bottom principle matters in Q&amp;A: multi-solution instances make answer-comparison invalid as a correctness test.</a:t>
             </a:r>
+            <a:endParaRPr lang="en-US" dirty="0"/>
           </a:p>
         </p:txBody>
       </p:sp>
@@ -1166,6 +1484,7 @@
               <a:rPr lang="en-US" dirty="0"/>
               <a:t>~1.5 min. THE core slide. Say the numbers out loud: naive 308 nodes on the 7x7, forward checking 12, full inference ZERO - the published puzzle is solved by deduction alone, which is exactly what publishers curate for. Then the scaling panels: 1-2 orders of magnitude between naive and the smart variants. Close with the nodes-vs-time nuance - fewer nodes is not automatically less time.</a:t>
             </a:r>
+            <a:endParaRPr lang="en-US" dirty="0"/>
           </a:p>
         </p:txBody>
       </p:sp>
@@ -1253,6 +1572,7 @@
               <a:rPr lang="en-US" dirty="0"/>
               <a:t>~1.5 min. Cross-paradigm comparison. Lead with SA vs HC (the Perera reproduction), then the one-violation-away story - it is the local-optimum concept made concrete. End on the honest framing: on these sizes complete search wins; incompleteness is the structural caveat.</a:t>
             </a:r>
+            <a:endParaRPr lang="en-US" dirty="0"/>
           </a:p>
         </p:txBody>
       </p:sp>
@@ -1325,11 +1645,6 @@
 <file path=ppt/slideMasters/slideMaster1.xml><?xml version="1.0" encoding="utf-8"?>
 <p:sldMaster xmlns:a="http://schemas.openxmlformats.org/drawingml/2006/main" xmlns:r="http://schemas.openxmlformats.org/officeDocument/2006/relationships" xmlns:p="http://schemas.openxmlformats.org/presentationml/2006/main">
   <p:cSld>
-    <p:bg>
-      <p:bgRef idx="1001">
-        <a:schemeClr val="bg1"/>
-      </p:bgRef>
-    </p:bg>
     <p:spTree>
       <p:nvGrpSpPr>
         <p:cNvPr id="1" name=""/>
@@ -1612,7 +1927,6 @@
         <a:solidFill>
           <a:srgbClr val="17171D"/>
         </a:solidFill>
-        <a:effectLst/>
       </p:bgPr>
     </p:bg>
     <p:spTree>
@@ -1917,7 +2231,7 @@
           <a:bodyPr wrap="square" lIns="0" tIns="0" rIns="0" bIns="0" rtlCol="0" anchor="ctr"/>
           <a:lstStyle/>
           <a:p>
-            <a:pPr marL="0" indent="0" algn="ctr">
+            <a:pPr algn="ctr" indent="0" marL="0">
               <a:buNone/>
             </a:pPr>
             <a:r>
@@ -2006,7 +2320,7 @@
           <a:bodyPr wrap="square" lIns="0" tIns="0" rIns="0" bIns="0" rtlCol="0" anchor="ctr"/>
           <a:lstStyle/>
           <a:p>
-            <a:pPr marL="0" indent="0" algn="ctr">
+            <a:pPr algn="ctr" indent="0" marL="0">
               <a:buNone/>
             </a:pPr>
             <a:r>
@@ -2262,7 +2576,7 @@
           <a:bodyPr wrap="square" lIns="0" tIns="0" rIns="0" bIns="0" rtlCol="0" anchor="ctr"/>
           <a:lstStyle/>
           <a:p>
-            <a:pPr marL="0" indent="0" algn="ctr">
+            <a:pPr algn="ctr" indent="0" marL="0">
               <a:buNone/>
             </a:pPr>
             <a:r>
@@ -3753,7 +4067,7 @@
           <a:bodyPr wrap="square" lIns="0" tIns="0" rIns="0" bIns="0" rtlCol="0" anchor="ctr"/>
           <a:lstStyle/>
           <a:p>
-            <a:pPr marL="0" indent="0" algn="ctr">
+            <a:pPr algn="ctr" indent="0" marL="0">
               <a:buNone/>
             </a:pPr>
             <a:r>
@@ -3959,7 +4273,7 @@
           <a:bodyPr wrap="square" lIns="0" tIns="0" rIns="0" bIns="0" rtlCol="0" anchor="ctr"/>
           <a:lstStyle/>
           <a:p>
-            <a:pPr marL="0" indent="0" algn="ctr">
+            <a:pPr algn="ctr" indent="0" marL="0">
               <a:buNone/>
             </a:pPr>
             <a:r>
@@ -4240,7 +4554,7 @@
           <a:bodyPr wrap="square" lIns="0" tIns="0" rIns="0" bIns="0" rtlCol="0" anchor="ctr"/>
           <a:lstStyle/>
           <a:p>
-            <a:pPr marL="0" indent="0">
+            <a:pPr indent="0" marL="0">
               <a:buNone/>
             </a:pPr>
             <a:r>
@@ -4252,45 +4566,7 @@
                 <a:ea typeface="Arial" pitchFamily="34" charset="-122"/>
                 <a:cs typeface="Arial" pitchFamily="34" charset="-120"/>
               </a:rPr>
-              <a:t>Lighting Up </a:t>
-            </a:r>
-            <a:r>
-              <a:rPr lang="en-US" sz="4000" b="1" dirty="0" err="1">
-                <a:solidFill>
-                  <a:srgbClr val="F2EFE7"/>
-                </a:solidFill>
-                <a:latin typeface="Arial" pitchFamily="34" charset="0"/>
-                <a:ea typeface="Arial" pitchFamily="34" charset="-122"/>
-                <a:cs typeface="Arial" pitchFamily="34" charset="-120"/>
-              </a:rPr>
-              <a:t>Akari</a:t>
-            </a:r>
-            <a:r>
-              <a:rPr lang="en-US" sz="4000" b="1" dirty="0">
-                <a:solidFill>
-                  <a:srgbClr val="F2EFE7"/>
-                </a:solidFill>
-                <a:latin typeface="Arial" pitchFamily="34" charset="0"/>
-                <a:ea typeface="Arial" pitchFamily="34" charset="-122"/>
-                <a:cs typeface="Arial" pitchFamily="34" charset="-120"/>
-              </a:rPr>
-              <a:t> with </a:t>
-            </a:r>
-          </a:p>
-          <a:p>
-            <a:pPr marL="0" indent="0">
-              <a:buNone/>
-            </a:pPr>
-            <a:r>
-              <a:rPr lang="en-US" sz="4000" b="1" dirty="0">
-                <a:solidFill>
-                  <a:srgbClr val="F2EFE7"/>
-                </a:solidFill>
-                <a:latin typeface="Arial" pitchFamily="34" charset="0"/>
-                <a:ea typeface="Arial" pitchFamily="34" charset="-122"/>
-                <a:cs typeface="Arial" pitchFamily="34" charset="-120"/>
-              </a:rPr>
-              <a:t>AI Search</a:t>
+              <a:t>Lighting Up Akari with AI Search</a:t>
             </a:r>
             <a:endParaRPr lang="en-US" sz="4000" dirty="0"/>
           </a:p>
@@ -4317,7 +4593,7 @@
           <a:bodyPr wrap="square" lIns="0" tIns="0" rIns="0" bIns="0" rtlCol="0" anchor="ctr"/>
           <a:lstStyle/>
           <a:p>
-            <a:pPr marL="0" indent="0">
+            <a:pPr indent="0" marL="0">
               <a:buNone/>
             </a:pPr>
             <a:r>
@@ -4334,7 +4610,7 @@
             <a:endParaRPr lang="en-US" sz="1700" dirty="0"/>
           </a:p>
           <a:p>
-            <a:pPr marL="0" indent="0">
+            <a:pPr indent="0" marL="0">
               <a:buNone/>
             </a:pPr>
             <a:r>
@@ -4373,7 +4649,7 @@
           <a:bodyPr wrap="square" lIns="0" tIns="0" rIns="0" bIns="0" rtlCol="0" anchor="ctr"/>
           <a:lstStyle/>
           <a:p>
-            <a:pPr marL="0" indent="0">
+            <a:pPr indent="0" marL="0">
               <a:buNone/>
             </a:pPr>
             <a:r>
@@ -4412,7 +4688,7 @@
           <a:bodyPr wrap="square" lIns="0" tIns="0" rIns="0" bIns="0" rtlCol="0" anchor="ctr"/>
           <a:lstStyle/>
           <a:p>
-            <a:pPr marL="0" indent="0">
+            <a:pPr indent="0" marL="0">
               <a:buNone/>
             </a:pPr>
             <a:r>
@@ -4446,7 +4722,6 @@
         <a:solidFill>
           <a:srgbClr val="17171D"/>
         </a:solidFill>
-        <a:effectLst/>
       </p:bgPr>
     </p:bg>
     <p:spTree>
@@ -4484,7 +4759,7 @@
           <a:bodyPr wrap="square" lIns="0" tIns="0" rIns="0" bIns="0" rtlCol="0" anchor="ctr"/>
           <a:lstStyle/>
           <a:p>
-            <a:pPr marL="0" indent="0">
+            <a:pPr indent="0" marL="0">
               <a:buNone/>
             </a:pPr>
             <a:r>
@@ -4504,15 +4779,15 @@
       </p:sp>
       <p:pic>
         <p:nvPicPr>
-          <p:cNvPr id="3" name="Image 0" descr="C:\Users\Annie\Desktop\AUA\Artificial Intelligence\GroupProject\LightUp\experiments\results\fig3_difficulty.png"/>
+          <p:cNvPr id="3" name="Image 0" descr="C:\Users\Annie\Desktop\AUA\Artificial Intelligence\GroupProject\LightUp\experiments\results\fig3_difficulty.png">    </p:cNvPr>
           <p:cNvPicPr>
             <a:picLocks noChangeAspect="1"/>
           </p:cNvPicPr>
           <p:nvPr/>
         </p:nvPicPr>
         <p:blipFill>
-          <a:blip r:embed="rId3"/>
-          <a:srcRect/>
+          <a:blip r:embed="rId1"/>
+          <a:srcRect l="0" r="0" t="0" b="0"/>
           <a:stretch/>
         </p:blipFill>
         <p:spPr>
@@ -4546,7 +4821,7 @@
           <a:bodyPr wrap="square" lIns="0" tIns="0" rIns="0" bIns="0" rtlCol="0" anchor="t"/>
           <a:lstStyle/>
           <a:p>
-            <a:pPr marL="0" indent="0">
+            <a:pPr indent="0" marL="0">
               <a:spcAft>
                 <a:spcPts val="800"/>
               </a:spcAft>
@@ -4621,7 +4896,7 @@
                 <a:ea typeface="Calibri" pitchFamily="34" charset="-122"/>
                 <a:cs typeface="Calibri" pitchFamily="34" charset="-120"/>
               </a:rPr>
-              <a:t>Full inference is the most stable across densities:  1–4 ms medians everywhere.</a:t>
+              <a:t>Full inference is the most stable across densities: 1–4 ms medians everywhere.</a:t>
             </a:r>
             <a:endParaRPr lang="en-US" sz="1400" dirty="0"/>
           </a:p>
@@ -4648,7 +4923,7 @@
           <a:bodyPr wrap="square" lIns="0" tIns="0" rIns="0" bIns="0" rtlCol="0" anchor="ctr"/>
           <a:lstStyle/>
           <a:p>
-            <a:pPr marL="0" indent="0" algn="r">
+            <a:pPr algn="r" indent="0" marL="0">
               <a:buNone/>
             </a:pPr>
             <a:r>
@@ -4682,7 +4957,6 @@
         <a:solidFill>
           <a:srgbClr val="17171D"/>
         </a:solidFill>
-        <a:effectLst/>
       </p:bgPr>
     </p:bg>
     <p:spTree>
@@ -4720,7 +4994,7 @@
           <a:bodyPr wrap="square" lIns="0" tIns="0" rIns="0" bIns="0" rtlCol="0" anchor="ctr"/>
           <a:lstStyle/>
           <a:p>
-            <a:pPr marL="0" indent="0">
+            <a:pPr indent="0" marL="0">
               <a:buNone/>
             </a:pPr>
             <a:r>
@@ -4732,22 +5006,46 @@
                 <a:ea typeface="Arial" pitchFamily="34" charset="-122"/>
                 <a:cs typeface="Arial" pitchFamily="34" charset="-120"/>
               </a:rPr>
-              <a:t>Conclusions</a:t>
+              <a:t>Robustness — is the 5 s budget arbitrary?</a:t>
             </a:r>
             <a:endParaRPr lang="en-US" sz="3000" dirty="0"/>
           </a:p>
         </p:txBody>
       </p:sp>
-      <p:sp>
-        <p:nvSpPr>
-          <p:cNvPr id="3" name="Text 1"/>
-          <p:cNvSpPr/>
-          <p:nvPr/>
-        </p:nvSpPr>
-        <p:spPr>
-          <a:xfrm>
-            <a:off x="640080" y="1463040"/>
-            <a:ext cx="10881360" cy="3840480"/>
+      <p:pic>
+        <p:nvPicPr>
+          <p:cNvPr id="3" name="Image 0" descr="C:\Users\Annie\Desktop\AUA\Artificial Intelligence\GroupProject\LightUp\experiments\results\fig4_budget.png">    </p:cNvPr>
+          <p:cNvPicPr>
+            <a:picLocks noChangeAspect="1"/>
+          </p:cNvPicPr>
+          <p:nvPr/>
+        </p:nvPicPr>
+        <p:blipFill>
+          <a:blip r:embed="rId1"/>
+          <a:stretch>
+            <a:fillRect/>
+          </a:stretch>
+        </p:blipFill>
+        <p:spPr>
+          <a:xfrm>
+            <a:off x="2258568" y="1234440"/>
+            <a:ext cx="7680960" cy="4270248"/>
+          </a:xfrm>
+          <a:prstGeom prst="rect">
+            <a:avLst/>
+          </a:prstGeom>
+        </p:spPr>
+      </p:pic>
+      <p:sp>
+        <p:nvSpPr>
+          <p:cNvPr id="4" name="Text 1"/>
+          <p:cNvSpPr/>
+          <p:nvPr/>
+        </p:nvSpPr>
+        <p:spPr>
+          <a:xfrm>
+            <a:off x="1371600" y="5715000"/>
+            <a:ext cx="9418320" cy="868680"/>
           </a:xfrm>
           <a:prstGeom prst="rect">
             <a:avLst/>
@@ -4756,144 +5054,37 @@
           <a:ln/>
         </p:spPr>
         <p:txBody>
-          <a:bodyPr wrap="square" lIns="0" tIns="0" rIns="0" bIns="0" rtlCol="0" anchor="t"/>
+          <a:bodyPr wrap="square" lIns="0" tIns="0" rIns="0" bIns="0" rtlCol="0" anchor="ctr"/>
           <a:lstStyle/>
           <a:p>
-            <a:pPr marL="342900" indent="-342900">
-              <a:spcAft>
-                <a:spcPts val="1000"/>
-              </a:spcAft>
-              <a:buSzPct val="100000"/>
-              <a:buChar char="•"/>
-            </a:pPr>
-            <a:r>
-              <a:rPr lang="en-US" sz="1500" dirty="0">
-                <a:solidFill>
-                  <a:srgbClr val="F2EFE7"/>
+            <a:pPr algn="ctr" indent="0" marL="0">
+              <a:buNone/>
+            </a:pPr>
+            <a:r>
+              <a:rPr lang="en-US" sz="1300" i="1" dirty="0">
+                <a:solidFill>
+                  <a:srgbClr val="A9A6B0"/>
                 </a:solidFill>
                 <a:latin typeface="Calibri" pitchFamily="34" charset="0"/>
                 <a:ea typeface="Calibri" pitchFamily="34" charset="-122"/>
                 <a:cs typeface="Calibri" pitchFamily="34" charset="-120"/>
               </a:rPr>
-              <a:t>Inference is the story: full propagation solved all 75 generated instances — the only 100 % solver — and cracked the published 7×7 with zero search nodes.</a:t>
-            </a:r>
-            <a:endParaRPr lang="en-US" sz="1500" dirty="0"/>
-          </a:p>
-          <a:p>
-            <a:pPr marL="342900" indent="-342900">
-              <a:spcAft>
-                <a:spcPts val="1000"/>
-              </a:spcAft>
-              <a:buSzPct val="100000"/>
-              <a:buChar char="•"/>
-            </a:pPr>
-            <a:r>
-              <a:rPr lang="en-US" sz="1500" dirty="0">
-                <a:solidFill>
-                  <a:srgbClr val="F2EFE7"/>
-                </a:solidFill>
-                <a:latin typeface="Calibri" pitchFamily="34" charset="0"/>
-                <a:ea typeface="Calibri" pitchFamily="34" charset="-122"/>
-                <a:cs typeface="Calibri" pitchFamily="34" charset="-120"/>
-              </a:rPr>
-              <a:t>Fewer nodes ≠ less time: full inference needs ~2× fewer nodes than forward checking, but propagation overhead makes fc slightly faster per board at 25×25.</a:t>
-            </a:r>
-            <a:endParaRPr lang="en-US" sz="1500" dirty="0"/>
-          </a:p>
-          <a:p>
-            <a:pPr marL="342900" indent="-342900">
-              <a:spcAft>
-                <a:spcPts val="1000"/>
-              </a:spcAft>
-              <a:buSzPct val="100000"/>
-              <a:buChar char="•"/>
-            </a:pPr>
-            <a:r>
-              <a:rPr lang="en-US" sz="1500" dirty="0">
-                <a:solidFill>
-                  <a:srgbClr val="F2EFE7"/>
-                </a:solidFill>
-                <a:latin typeface="Calibri" pitchFamily="34" charset="0"/>
-                <a:ea typeface="Calibri" pitchFamily="34" charset="-122"/>
-                <a:cs typeface="Calibri" pitchFamily="34" charset="-120"/>
-              </a:rPr>
-              <a:t>Simulated annealing solved 60 % of all instances vs. 28 % for hill climbing (76 % vs 44 % on hard) — reproducing Perera et al.; HC's signature failure is stalling one violation from the goal.</a:t>
-            </a:r>
-            <a:endParaRPr lang="en-US" sz="1500" dirty="0"/>
-          </a:p>
-          <a:p>
-            <a:pPr marL="342900" indent="-342900">
-              <a:spcAft>
-                <a:spcPts val="1000"/>
-              </a:spcAft>
-              <a:buSzPct val="100000"/>
-              <a:buChar char="•"/>
-            </a:pPr>
-            <a:r>
-              <a:rPr lang="en-US" sz="1500" dirty="0">
-                <a:solidFill>
-                  <a:srgbClr val="F2EFE7"/>
-                </a:solidFill>
-                <a:latin typeface="Calibri" pitchFamily="34" charset="0"/>
-                <a:ea typeface="Calibri" pitchFamily="34" charset="-122"/>
-                <a:cs typeface="Calibri" pitchFamily="34" charset="-120"/>
-              </a:rPr>
-              <a:t>Sparser boards were often EASIER for solvers (more solutions to find) — density presets model human difficulty, not search difficulty.</a:t>
-            </a:r>
-            <a:endParaRPr lang="en-US" sz="1500" dirty="0"/>
-          </a:p>
-          <a:p>
-            <a:pPr marL="342900" indent="-342900">
-              <a:buSzPct val="100000"/>
-              <a:buChar char="•"/>
-            </a:pPr>
-            <a:r>
-              <a:rPr lang="en-US" sz="1500" dirty="0">
-                <a:solidFill>
-                  <a:srgbClr val="F2EFE7"/>
-                </a:solidFill>
-                <a:latin typeface="Calibri" pitchFamily="34" charset="0"/>
-                <a:ea typeface="Calibri" pitchFamily="34" charset="-122"/>
-                <a:cs typeface="Calibri" pitchFamily="34" charset="-120"/>
-              </a:rPr>
-              <a:t>Future work: uniqueness-filtered generation, AC-3 / MAC on the binary constraints, difficulty calibration from measured search effort.</a:t>
-            </a:r>
-            <a:endParaRPr lang="en-US" sz="1500" dirty="0"/>
+              <a:t>Doubling the budget on identical instances changed at most 3 results out of 75 per solver — and hill climbing gained exactly zero. More time helps solvers that are slow, not solvers that are stuck: the ranking is structural, not a timeout artifact.</a:t>
+            </a:r>
+            <a:endParaRPr lang="en-US" sz="1300" dirty="0"/>
           </a:p>
         </p:txBody>
       </p:sp>
       <p:sp>
         <p:nvSpPr>
-          <p:cNvPr id="4" name="Shape 2"/>
-          <p:cNvSpPr/>
-          <p:nvPr/>
-        </p:nvSpPr>
-        <p:spPr>
-          <a:xfrm>
-            <a:off x="640080" y="5486400"/>
-            <a:ext cx="10881360" cy="822960"/>
-          </a:xfrm>
-          <a:prstGeom prst="roundRect">
-            <a:avLst>
-              <a:gd name="adj" fmla="val 8889"/>
-            </a:avLst>
-          </a:prstGeom>
-          <a:solidFill>
-            <a:srgbClr val="2B2B35"/>
-          </a:solidFill>
-          <a:ln/>
-        </p:spPr>
-      </p:sp>
-      <p:sp>
-        <p:nvSpPr>
-          <p:cNvPr id="5" name="Text 3"/>
-          <p:cNvSpPr/>
-          <p:nvPr/>
-        </p:nvSpPr>
-        <p:spPr>
-          <a:xfrm>
-            <a:off x="640080" y="5486400"/>
-            <a:ext cx="10881360" cy="822960"/>
+          <p:cNvPr id="6" name="Text 2"/>
+          <p:cNvSpPr/>
+          <p:nvPr/>
+        </p:nvSpPr>
+        <p:spPr>
+          <a:xfrm>
+            <a:off x="11567160" y="6473952"/>
+            <a:ext cx="457200" cy="292608"/>
           </a:xfrm>
           <a:prstGeom prst="rect">
             <a:avLst/>
@@ -4905,46 +5096,7 @@
           <a:bodyPr wrap="square" lIns="0" tIns="0" rIns="0" bIns="0" rtlCol="0" anchor="ctr"/>
           <a:lstStyle/>
           <a:p>
-            <a:pPr marL="0" indent="0" algn="ctr">
-              <a:buNone/>
-            </a:pPr>
-            <a:r>
-              <a:rPr lang="en-US" sz="1600" b="1" dirty="0">
-                <a:solidFill>
-                  <a:srgbClr val="FFD23F"/>
-                </a:solidFill>
-                <a:latin typeface="Arial" pitchFamily="34" charset="0"/>
-                <a:ea typeface="Arial" pitchFamily="34" charset="-122"/>
-                <a:cs typeface="Arial" pitchFamily="34" charset="-120"/>
-              </a:rPr>
-              <a:t>Thank you — questions welcome.</a:t>
-            </a:r>
-            <a:endParaRPr lang="en-US" sz="1600" dirty="0"/>
-          </a:p>
-        </p:txBody>
-      </p:sp>
-      <p:sp>
-        <p:nvSpPr>
-          <p:cNvPr id="7" name="Text 4"/>
-          <p:cNvSpPr/>
-          <p:nvPr/>
-        </p:nvSpPr>
-        <p:spPr>
-          <a:xfrm>
-            <a:off x="11567160" y="6473952"/>
-            <a:ext cx="457200" cy="292608"/>
-          </a:xfrm>
-          <a:prstGeom prst="rect">
-            <a:avLst/>
-          </a:prstGeom>
-          <a:noFill/>
-          <a:ln/>
-        </p:spPr>
-        <p:txBody>
-          <a:bodyPr wrap="square" lIns="0" tIns="0" rIns="0" bIns="0" rtlCol="0" anchor="ctr"/>
-          <a:lstStyle/>
-          <a:p>
-            <a:pPr marL="0" indent="0" algn="r">
+            <a:pPr algn="r" indent="0" marL="0">
               <a:buNone/>
             </a:pPr>
             <a:r>
@@ -4978,7 +5130,6 @@
         <a:solidFill>
           <a:srgbClr val="17171D"/>
         </a:solidFill>
-        <a:effectLst/>
       </p:bgPr>
     </p:bg>
     <p:spTree>
@@ -5016,7 +5167,7 @@
           <a:bodyPr wrap="square" lIns="0" tIns="0" rIns="0" bIns="0" rtlCol="0" anchor="ctr"/>
           <a:lstStyle/>
           <a:p>
-            <a:pPr marL="0" indent="0">
+            <a:pPr indent="0" marL="0">
               <a:buNone/>
             </a:pPr>
             <a:r>
@@ -5028,7 +5179,7 @@
                 <a:ea typeface="Arial" pitchFamily="34" charset="-122"/>
                 <a:cs typeface="Arial" pitchFamily="34" charset="-120"/>
               </a:rPr>
-              <a:t>References</a:t>
+              <a:t>Conclusions</a:t>
             </a:r>
             <a:endParaRPr lang="en-US" sz="3000" dirty="0"/>
           </a:p>
@@ -5043,7 +5194,7 @@
         <p:spPr>
           <a:xfrm>
             <a:off x="640080" y="1463040"/>
-            <a:ext cx="10881360" cy="4114800"/>
+            <a:ext cx="10881360" cy="3840480"/>
           </a:xfrm>
           <a:prstGeom prst="rect">
             <a:avLst/>
@@ -5063,7 +5214,7 @@
               <a:buChar char="•"/>
             </a:pPr>
             <a:r>
-              <a:rPr lang="en-US" sz="1400" dirty="0">
+              <a:rPr lang="en-US" sz="1500" dirty="0">
                 <a:solidFill>
                   <a:srgbClr val="F2EFE7"/>
                 </a:solidFill>
@@ -5071,9 +5222,9 @@
                 <a:ea typeface="Calibri" pitchFamily="34" charset="-122"/>
                 <a:cs typeface="Calibri" pitchFamily="34" charset="-120"/>
               </a:rPr>
-              <a:t>B. McPhail (2005). Light Up is NP-complete.</a:t>
-            </a:r>
-            <a:endParaRPr lang="en-US" sz="1400" dirty="0"/>
+              <a:t>Inference is the story: full propagation solved all 75 generated instances — the only 100 % solver — and cracked the published 7×7 with zero search nodes.</a:t>
+            </a:r>
+            <a:endParaRPr lang="en-US" sz="1500" dirty="0"/>
           </a:p>
           <a:p>
             <a:pPr marL="342900" indent="-342900">
@@ -5084,7 +5235,7 @@
               <a:buChar char="•"/>
             </a:pPr>
             <a:r>
-              <a:rPr lang="en-US" sz="1400" dirty="0">
+              <a:rPr lang="en-US" sz="1500" dirty="0">
                 <a:solidFill>
                   <a:srgbClr val="F2EFE7"/>
                 </a:solidFill>
@@ -5092,9 +5243,9 @@
                 <a:ea typeface="Calibri" pitchFamily="34" charset="-122"/>
                 <a:cs typeface="Calibri" pitchFamily="34" charset="-120"/>
               </a:rPr>
-              <a:t>B. Pulles (2021). Analysis of Akari. Bachelor thesis, Radboud University.</a:t>
-            </a:r>
-            <a:endParaRPr lang="en-US" sz="1400" dirty="0"/>
+              <a:t>Fewer nodes ≠ less time: full inference needs ~2× fewer nodes than forward checking, but propagation overhead makes fc slightly faster per board at 25×25.</a:t>
+            </a:r>
+            <a:endParaRPr lang="en-US" sz="1500" dirty="0"/>
           </a:p>
           <a:p>
             <a:pPr marL="342900" indent="-342900">
@@ -5105,7 +5256,7 @@
               <a:buChar char="•"/>
             </a:pPr>
             <a:r>
-              <a:rPr lang="en-US" sz="1400" dirty="0">
+              <a:rPr lang="en-US" sz="1500" dirty="0">
                 <a:solidFill>
                   <a:srgbClr val="F2EFE7"/>
                 </a:solidFill>
@@ -5113,9 +5264,9 @@
                 <a:ea typeface="Calibri" pitchFamily="34" charset="-122"/>
                 <a:cs typeface="Calibri" pitchFamily="34" charset="-120"/>
               </a:rPr>
-              <a:t>L. Sun, J. Browning, R. Perera (2021). Shedding Some Light on Light Up with Artificial Intelligence. arXiv:2107.10429.</a:t>
-            </a:r>
-            <a:endParaRPr lang="en-US" sz="1400" dirty="0"/>
+              <a:t>Simulated annealing solved 60 % of all instances vs. 28 % for hill climbing (76 % vs 44 % on hard) — reproducing Perera et al.; HC's signature failure is stalling one violation from the goal.</a:t>
+            </a:r>
+            <a:endParaRPr lang="en-US" sz="1500" dirty="0"/>
           </a:p>
           <a:p>
             <a:pPr marL="342900" indent="-342900">
@@ -5126,7 +5277,7 @@
               <a:buChar char="•"/>
             </a:pPr>
             <a:r>
-              <a:rPr lang="en-US" sz="1400" dirty="0">
+              <a:rPr lang="en-US" sz="1500" dirty="0">
                 <a:solidFill>
                   <a:srgbClr val="F2EFE7"/>
                 </a:solidFill>
@@ -5134,10 +5285,221 @@
                 <a:ea typeface="Calibri" pitchFamily="34" charset="-122"/>
                 <a:cs typeface="Calibri" pitchFamily="34" charset="-120"/>
               </a:rPr>
-              <a:t>S. Salcedo-Sanz et al. (2009). A nested two-steps evolutionary algorithm for the light-up puzzle. ICGA Journal 32.</a:t>
-            </a:r>
-            <a:endParaRPr lang="en-US" sz="1400" dirty="0"/>
-          </a:p>
+              <a:t>Sparser boards were often EASIER for solvers (more solutions to find) — density presets model human difficulty, not search difficulty.</a:t>
+            </a:r>
+            <a:endParaRPr lang="en-US" sz="1500" dirty="0"/>
+          </a:p>
+          <a:p>
+            <a:pPr marL="342900" indent="-342900">
+              <a:buSzPct val="100000"/>
+              <a:buChar char="•"/>
+            </a:pPr>
+            <a:r>
+              <a:rPr lang="en-US" sz="1500" dirty="0">
+                <a:solidFill>
+                  <a:srgbClr val="F2EFE7"/>
+                </a:solidFill>
+                <a:latin typeface="Calibri" pitchFamily="34" charset="0"/>
+                <a:ea typeface="Calibri" pitchFamily="34" charset="-122"/>
+                <a:cs typeface="Calibri" pitchFamily="34" charset="-120"/>
+              </a:rPr>
+              <a:t>Future work: uniqueness-filtered generation, AC-3 / MAC on the binary constraints, difficulty calibration from measured search effort.</a:t>
+            </a:r>
+            <a:endParaRPr lang="en-US" sz="1500" dirty="0"/>
+          </a:p>
+        </p:txBody>
+      </p:sp>
+      <p:sp>
+        <p:nvSpPr>
+          <p:cNvPr id="4" name="Shape 2"/>
+          <p:cNvSpPr/>
+          <p:nvPr/>
+        </p:nvSpPr>
+        <p:spPr>
+          <a:xfrm>
+            <a:off x="640080" y="5486400"/>
+            <a:ext cx="10881360" cy="822960"/>
+          </a:xfrm>
+          <a:prstGeom prst="roundRect">
+            <a:avLst>
+              <a:gd name="adj" fmla="val 8889"/>
+            </a:avLst>
+          </a:prstGeom>
+          <a:solidFill>
+            <a:srgbClr val="2B2B35"/>
+          </a:solidFill>
+          <a:ln/>
+        </p:spPr>
+      </p:sp>
+      <p:sp>
+        <p:nvSpPr>
+          <p:cNvPr id="5" name="Text 3"/>
+          <p:cNvSpPr/>
+          <p:nvPr/>
+        </p:nvSpPr>
+        <p:spPr>
+          <a:xfrm>
+            <a:off x="640080" y="5486400"/>
+            <a:ext cx="10881360" cy="822960"/>
+          </a:xfrm>
+          <a:prstGeom prst="rect">
+            <a:avLst/>
+          </a:prstGeom>
+          <a:noFill/>
+          <a:ln/>
+        </p:spPr>
+        <p:txBody>
+          <a:bodyPr wrap="square" lIns="0" tIns="0" rIns="0" bIns="0" rtlCol="0" anchor="ctr"/>
+          <a:lstStyle/>
+          <a:p>
+            <a:pPr algn="ctr" indent="0" marL="0">
+              <a:buNone/>
+            </a:pPr>
+            <a:r>
+              <a:rPr lang="en-US" sz="1600" b="1" dirty="0">
+                <a:solidFill>
+                  <a:srgbClr val="FFD23F"/>
+                </a:solidFill>
+                <a:latin typeface="Arial" pitchFamily="34" charset="0"/>
+                <a:ea typeface="Arial" pitchFamily="34" charset="-122"/>
+                <a:cs typeface="Arial" pitchFamily="34" charset="-120"/>
+              </a:rPr>
+              <a:t>Thank you — questions welcome.</a:t>
+            </a:r>
+            <a:endParaRPr lang="en-US" sz="1600" dirty="0"/>
+          </a:p>
+        </p:txBody>
+      </p:sp>
+      <p:sp>
+        <p:nvSpPr>
+          <p:cNvPr id="7" name="Text 4"/>
+          <p:cNvSpPr/>
+          <p:nvPr/>
+        </p:nvSpPr>
+        <p:spPr>
+          <a:xfrm>
+            <a:off x="11567160" y="6473952"/>
+            <a:ext cx="457200" cy="292608"/>
+          </a:xfrm>
+          <a:prstGeom prst="rect">
+            <a:avLst/>
+          </a:prstGeom>
+          <a:noFill/>
+          <a:ln/>
+        </p:spPr>
+        <p:txBody>
+          <a:bodyPr wrap="square" lIns="0" tIns="0" rIns="0" bIns="0" rtlCol="0" anchor="ctr"/>
+          <a:lstStyle/>
+          <a:p>
+            <a:pPr algn="r" indent="0" marL="0">
+              <a:buNone/>
+            </a:pPr>
+            <a:r>
+              <a:rPr lang="en-US" sz="1000" dirty="0">
+                <a:solidFill>
+                  <a:srgbClr val="A9A6B0"/>
+                </a:solidFill>
+                <a:latin typeface="Calibri" pitchFamily="34" charset="0"/>
+                <a:ea typeface="Calibri" pitchFamily="34" charset="-122"/>
+                <a:cs typeface="Calibri" pitchFamily="34" charset="-120"/>
+              </a:rPr>
+              <a:t>12</a:t>
+            </a:r>
+            <a:endParaRPr lang="en-US" sz="1000" dirty="0"/>
+          </a:p>
+        </p:txBody>
+      </p:sp>
+    </p:spTree>
+  </p:cSld>
+  <p:clrMapOvr>
+    <a:masterClrMapping/>
+  </p:clrMapOvr>
+</p:sld>
+</file>
+
+<file path=ppt/slides/slide13.xml><?xml version="1.0" encoding="utf-8"?>
+<p:sld xmlns:a="http://schemas.openxmlformats.org/drawingml/2006/main" xmlns:r="http://schemas.openxmlformats.org/officeDocument/2006/relationships" xmlns:p="http://schemas.openxmlformats.org/presentationml/2006/main">
+  <p:cSld name="Slide 13">
+    <p:bg>
+      <p:bgPr>
+        <a:solidFill>
+          <a:srgbClr val="17171D"/>
+        </a:solidFill>
+      </p:bgPr>
+    </p:bg>
+    <p:spTree>
+      <p:nvGrpSpPr>
+        <p:cNvPr id="1" name=""/>
+        <p:cNvGrpSpPr/>
+        <p:nvPr/>
+      </p:nvGrpSpPr>
+      <p:grpSpPr>
+        <a:xfrm>
+          <a:off x="0" y="0"/>
+          <a:ext cx="0" cy="0"/>
+          <a:chOff x="0" y="0"/>
+          <a:chExt cx="0" cy="0"/>
+        </a:xfrm>
+      </p:grpSpPr>
+      <p:sp>
+        <p:nvSpPr>
+          <p:cNvPr id="2" name="Text 0"/>
+          <p:cNvSpPr/>
+          <p:nvPr/>
+        </p:nvSpPr>
+        <p:spPr>
+          <a:xfrm>
+            <a:off x="502920" y="292608"/>
+            <a:ext cx="11155680" cy="685800"/>
+          </a:xfrm>
+          <a:prstGeom prst="rect">
+            <a:avLst/>
+          </a:prstGeom>
+          <a:noFill/>
+          <a:ln/>
+        </p:spPr>
+        <p:txBody>
+          <a:bodyPr wrap="square" lIns="0" tIns="0" rIns="0" bIns="0" rtlCol="0" anchor="ctr"/>
+          <a:lstStyle/>
+          <a:p>
+            <a:pPr indent="0" marL="0">
+              <a:buNone/>
+            </a:pPr>
+            <a:r>
+              <a:rPr lang="en-US" sz="3000" b="1" dirty="0">
+                <a:solidFill>
+                  <a:srgbClr val="F2EFE7"/>
+                </a:solidFill>
+                <a:latin typeface="Arial" pitchFamily="34" charset="0"/>
+                <a:ea typeface="Arial" pitchFamily="34" charset="-122"/>
+                <a:cs typeface="Arial" pitchFamily="34" charset="-120"/>
+              </a:rPr>
+              <a:t>References</a:t>
+            </a:r>
+            <a:endParaRPr lang="en-US" sz="3000" dirty="0"/>
+          </a:p>
+        </p:txBody>
+      </p:sp>
+      <p:sp>
+        <p:nvSpPr>
+          <p:cNvPr id="3" name="Text 1"/>
+          <p:cNvSpPr/>
+          <p:nvPr/>
+        </p:nvSpPr>
+        <p:spPr>
+          <a:xfrm>
+            <a:off x="640080" y="1463040"/>
+            <a:ext cx="10881360" cy="4114800"/>
+          </a:xfrm>
+          <a:prstGeom prst="rect">
+            <a:avLst/>
+          </a:prstGeom>
+          <a:noFill/>
+          <a:ln/>
+        </p:spPr>
+        <p:txBody>
+          <a:bodyPr wrap="square" lIns="0" tIns="0" rIns="0" bIns="0" rtlCol="0" anchor="t"/>
+          <a:lstStyle/>
           <a:p>
             <a:pPr marL="342900" indent="-342900">
               <a:spcAft>
@@ -5155,7 +5517,7 @@
                 <a:ea typeface="Calibri" pitchFamily="34" charset="-122"/>
                 <a:cs typeface="Calibri" pitchFamily="34" charset="-120"/>
               </a:rPr>
-              <a:t>S. Russell, P. Norvig (2021). Artificial Intelligence: A Modern Approach, 4th ed. — Chapters 3, 4, 6.</a:t>
+              <a:t>B. McPhail (2005). Light Up is NP-complete.</a:t>
             </a:r>
             <a:endParaRPr lang="en-US" sz="1400" dirty="0"/>
           </a:p>
@@ -5176,6 +5538,90 @@
                 <a:ea typeface="Calibri" pitchFamily="34" charset="-122"/>
                 <a:cs typeface="Calibri" pitchFamily="34" charset="-120"/>
               </a:rPr>
+              <a:t>B. Pulles (2021). Analysis of Akari. Bachelor thesis, Radboud University.</a:t>
+            </a:r>
+            <a:endParaRPr lang="en-US" sz="1400" dirty="0"/>
+          </a:p>
+          <a:p>
+            <a:pPr marL="342900" indent="-342900">
+              <a:spcAft>
+                <a:spcPts val="1000"/>
+              </a:spcAft>
+              <a:buSzPct val="100000"/>
+              <a:buChar char="•"/>
+            </a:pPr>
+            <a:r>
+              <a:rPr lang="en-US" sz="1400" dirty="0">
+                <a:solidFill>
+                  <a:srgbClr val="F2EFE7"/>
+                </a:solidFill>
+                <a:latin typeface="Calibri" pitchFamily="34" charset="0"/>
+                <a:ea typeface="Calibri" pitchFamily="34" charset="-122"/>
+                <a:cs typeface="Calibri" pitchFamily="34" charset="-120"/>
+              </a:rPr>
+              <a:t>L. Sun, J. Browning, R. Perera (2021). Shedding Some Light on Light Up with Artificial Intelligence. arXiv:2107.10429.</a:t>
+            </a:r>
+            <a:endParaRPr lang="en-US" sz="1400" dirty="0"/>
+          </a:p>
+          <a:p>
+            <a:pPr marL="342900" indent="-342900">
+              <a:spcAft>
+                <a:spcPts val="1000"/>
+              </a:spcAft>
+              <a:buSzPct val="100000"/>
+              <a:buChar char="•"/>
+            </a:pPr>
+            <a:r>
+              <a:rPr lang="en-US" sz="1400" dirty="0">
+                <a:solidFill>
+                  <a:srgbClr val="F2EFE7"/>
+                </a:solidFill>
+                <a:latin typeface="Calibri" pitchFamily="34" charset="0"/>
+                <a:ea typeface="Calibri" pitchFamily="34" charset="-122"/>
+                <a:cs typeface="Calibri" pitchFamily="34" charset="-120"/>
+              </a:rPr>
+              <a:t>S. Salcedo-Sanz et al. (2009). A nested two-steps evolutionary algorithm for the light-up puzzle. ICGA Journal 32.</a:t>
+            </a:r>
+            <a:endParaRPr lang="en-US" sz="1400" dirty="0"/>
+          </a:p>
+          <a:p>
+            <a:pPr marL="342900" indent="-342900">
+              <a:spcAft>
+                <a:spcPts val="1000"/>
+              </a:spcAft>
+              <a:buSzPct val="100000"/>
+              <a:buChar char="•"/>
+            </a:pPr>
+            <a:r>
+              <a:rPr lang="en-US" sz="1400" dirty="0">
+                <a:solidFill>
+                  <a:srgbClr val="F2EFE7"/>
+                </a:solidFill>
+                <a:latin typeface="Calibri" pitchFamily="34" charset="0"/>
+                <a:ea typeface="Calibri" pitchFamily="34" charset="-122"/>
+                <a:cs typeface="Calibri" pitchFamily="34" charset="-120"/>
+              </a:rPr>
+              <a:t>S. Russell, P. Norvig (2021). Artificial Intelligence: A Modern Approach, 4th ed. — Chapters 3, 4, 6.</a:t>
+            </a:r>
+            <a:endParaRPr lang="en-US" sz="1400" dirty="0"/>
+          </a:p>
+          <a:p>
+            <a:pPr marL="342900" indent="-342900">
+              <a:spcAft>
+                <a:spcPts val="1000"/>
+              </a:spcAft>
+              <a:buSzPct val="100000"/>
+              <a:buChar char="•"/>
+            </a:pPr>
+            <a:r>
+              <a:rPr lang="en-US" sz="1400" dirty="0">
+                <a:solidFill>
+                  <a:srgbClr val="F2EFE7"/>
+                </a:solidFill>
+                <a:latin typeface="Calibri" pitchFamily="34" charset="0"/>
+                <a:ea typeface="Calibri" pitchFamily="34" charset="-122"/>
+                <a:cs typeface="Calibri" pitchFamily="34" charset="-120"/>
+              </a:rPr>
               <a:t>puzzle-light-up.com — rules and reference instances.</a:t>
             </a:r>
             <a:endParaRPr lang="en-US" sz="1400" dirty="0"/>
@@ -5203,7 +5649,7 @@
           <a:bodyPr wrap="square" lIns="0" tIns="0" rIns="0" bIns="0" rtlCol="0" anchor="ctr"/>
           <a:lstStyle/>
           <a:p>
-            <a:pPr marL="0" indent="0" algn="r">
+            <a:pPr algn="r" indent="0" marL="0">
               <a:buNone/>
             </a:pPr>
             <a:r>
@@ -5215,7 +5661,7 @@
                 <a:ea typeface="Calibri" pitchFamily="34" charset="-122"/>
                 <a:cs typeface="Calibri" pitchFamily="34" charset="-120"/>
               </a:rPr>
-              <a:t>12</a:t>
+              <a:t>13</a:t>
             </a:r>
             <a:endParaRPr lang="en-US" sz="1000" dirty="0"/>
           </a:p>
@@ -5237,7 +5683,6 @@
         <a:solidFill>
           <a:srgbClr val="17171D"/>
         </a:solidFill>
-        <a:effectLst/>
       </p:bgPr>
     </p:bg>
     <p:spTree>
@@ -5275,7 +5720,7 @@
           <a:bodyPr wrap="square" lIns="0" tIns="0" rIns="0" bIns="0" rtlCol="0" anchor="ctr"/>
           <a:lstStyle/>
           <a:p>
-            <a:pPr marL="0" indent="0">
+            <a:pPr indent="0" marL="0">
               <a:buNone/>
             </a:pPr>
             <a:r>
@@ -5314,7 +5759,7 @@
           <a:bodyPr wrap="square" lIns="0" tIns="0" rIns="0" bIns="0" rtlCol="0" anchor="t"/>
           <a:lstStyle/>
           <a:p>
-            <a:pPr marL="0" indent="0">
+            <a:pPr indent="0" marL="0">
               <a:buNone/>
             </a:pPr>
             <a:r>
@@ -5331,7 +5776,7 @@
             <a:endParaRPr lang="en-US" sz="1800" dirty="0"/>
           </a:p>
           <a:p>
-            <a:pPr marL="0" indent="0">
+            <a:pPr indent="0" marL="0">
               <a:buNone/>
             </a:pPr>
             <a:r>
@@ -5370,7 +5815,7 @@
           <a:bodyPr wrap="square" lIns="0" tIns="0" rIns="0" bIns="0" rtlCol="0" anchor="t"/>
           <a:lstStyle/>
           <a:p>
-            <a:pPr marL="0" indent="0">
+            <a:pPr indent="0" marL="0">
               <a:buNone/>
             </a:pPr>
             <a:r>
@@ -5387,7 +5832,7 @@
             <a:endParaRPr lang="en-US" sz="1800" dirty="0"/>
           </a:p>
           <a:p>
-            <a:pPr marL="0" indent="0">
+            <a:pPr indent="0" marL="0">
               <a:buNone/>
             </a:pPr>
             <a:r>
@@ -5426,7 +5871,7 @@
           <a:bodyPr wrap="square" lIns="0" tIns="0" rIns="0" bIns="0" rtlCol="0" anchor="t"/>
           <a:lstStyle/>
           <a:p>
-            <a:pPr marL="0" indent="0">
+            <a:pPr indent="0" marL="0">
               <a:buNone/>
             </a:pPr>
             <a:r>
@@ -5443,7 +5888,7 @@
             <a:endParaRPr lang="en-US" sz="1800" dirty="0"/>
           </a:p>
           <a:p>
-            <a:pPr marL="0" indent="0">
+            <a:pPr indent="0" marL="0">
               <a:buNone/>
             </a:pPr>
             <a:r>
@@ -5482,7 +5927,7 @@
           <a:bodyPr wrap="square" lIns="0" tIns="0" rIns="0" bIns="0" rtlCol="0" anchor="ctr"/>
           <a:lstStyle/>
           <a:p>
-            <a:pPr marL="0" indent="0">
+            <a:pPr indent="0" marL="0">
               <a:buNone/>
             </a:pPr>
             <a:r>
@@ -5546,7 +5991,7 @@
           <a:bodyPr wrap="square" lIns="0" tIns="0" rIns="0" bIns="0" rtlCol="0" anchor="ctr"/>
           <a:lstStyle/>
           <a:p>
-            <a:pPr marL="0" indent="0" algn="ctr">
+            <a:pPr algn="ctr" indent="0" marL="0">
               <a:buNone/>
             </a:pPr>
             <a:r>
@@ -6136,7 +6581,7 @@
           <a:bodyPr wrap="square" lIns="0" tIns="0" rIns="0" bIns="0" rtlCol="0" anchor="ctr"/>
           <a:lstStyle/>
           <a:p>
-            <a:pPr marL="0" indent="0" algn="ctr">
+            <a:pPr algn="ctr" indent="0" marL="0">
               <a:buNone/>
             </a:pPr>
             <a:r>
@@ -6175,7 +6620,7 @@
           <a:bodyPr wrap="square" lIns="0" tIns="0" rIns="0" bIns="0" rtlCol="0" anchor="ctr"/>
           <a:lstStyle/>
           <a:p>
-            <a:pPr marL="0" indent="0" algn="r">
+            <a:pPr algn="r" indent="0" marL="0">
               <a:buNone/>
             </a:pPr>
             <a:r>
@@ -6209,7 +6654,6 @@
         <a:solidFill>
           <a:srgbClr val="17171D"/>
         </a:solidFill>
-        <a:effectLst/>
       </p:bgPr>
     </p:bg>
     <p:spTree>
@@ -6247,7 +6691,7 @@
           <a:bodyPr wrap="square" lIns="0" tIns="0" rIns="0" bIns="0" rtlCol="0" anchor="ctr"/>
           <a:lstStyle/>
           <a:p>
-            <a:pPr marL="0" indent="0">
+            <a:pPr indent="0" marL="0">
               <a:buNone/>
             </a:pPr>
             <a:r>
@@ -6308,7 +6752,7 @@
           <a:bodyPr wrap="square" lIns="0" tIns="0" rIns="0" bIns="0" rtlCol="0" anchor="t"/>
           <a:lstStyle/>
           <a:p>
-            <a:pPr marL="0" indent="0">
+            <a:pPr indent="0" marL="0">
               <a:buNone/>
             </a:pPr>
             <a:r>
@@ -6325,7 +6769,7 @@
             <a:endParaRPr lang="en-US" sz="1900" dirty="0"/>
           </a:p>
           <a:p>
-            <a:pPr marL="0" indent="0">
+            <a:pPr indent="0" marL="0">
               <a:buNone/>
             </a:pPr>
             <a:r>
@@ -6386,7 +6830,7 @@
           <a:bodyPr wrap="square" lIns="0" tIns="0" rIns="0" bIns="0" rtlCol="0" anchor="t"/>
           <a:lstStyle/>
           <a:p>
-            <a:pPr marL="0" indent="0">
+            <a:pPr indent="0" marL="0">
               <a:buNone/>
             </a:pPr>
             <a:r>
@@ -6403,7 +6847,7 @@
             <a:endParaRPr lang="en-US" sz="1900" dirty="0"/>
           </a:p>
           <a:p>
-            <a:pPr marL="0" indent="0">
+            <a:pPr indent="0" marL="0">
               <a:buNone/>
             </a:pPr>
             <a:r>
@@ -6464,7 +6908,7 @@
           <a:bodyPr wrap="square" lIns="0" tIns="0" rIns="0" bIns="0" rtlCol="0" anchor="t"/>
           <a:lstStyle/>
           <a:p>
-            <a:pPr marL="0" indent="0">
+            <a:pPr indent="0" marL="0">
               <a:buNone/>
             </a:pPr>
             <a:r>
@@ -6481,7 +6925,7 @@
             <a:endParaRPr lang="en-US" sz="1900" dirty="0"/>
           </a:p>
           <a:p>
-            <a:pPr marL="0" indent="0">
+            <a:pPr indent="0" marL="0">
               <a:buNone/>
             </a:pPr>
             <a:r>
@@ -6520,7 +6964,7 @@
           <a:bodyPr wrap="square" lIns="0" tIns="0" rIns="0" bIns="0" rtlCol="0" anchor="ctr"/>
           <a:lstStyle/>
           <a:p>
-            <a:pPr marL="0" indent="0">
+            <a:pPr indent="0" marL="0">
               <a:buNone/>
             </a:pPr>
             <a:r>
@@ -6534,6 +6978,9 @@
               </a:rPr>
               <a:t>Existing approaches (briefly): </a:t>
             </a:r>
+            <a:pPr indent="0" marL="0">
+              <a:buNone/>
+            </a:pPr>
             <a:r>
               <a:rPr lang="en-US" sz="1400" dirty="0">
                 <a:solidFill>
@@ -6570,7 +7017,7 @@
           <a:bodyPr wrap="square" lIns="0" tIns="0" rIns="0" bIns="0" rtlCol="0" anchor="ctr"/>
           <a:lstStyle/>
           <a:p>
-            <a:pPr marL="0" indent="0" algn="r">
+            <a:pPr algn="r" indent="0" marL="0">
               <a:buNone/>
             </a:pPr>
             <a:r>
@@ -6604,7 +7051,6 @@
         <a:solidFill>
           <a:srgbClr val="17171D"/>
         </a:solidFill>
-        <a:effectLst/>
       </p:bgPr>
     </p:bg>
     <p:spTree>
@@ -6642,7 +7088,7 @@
           <a:bodyPr wrap="square" lIns="0" tIns="0" rIns="0" bIns="0" rtlCol="0" anchor="ctr"/>
           <a:lstStyle/>
           <a:p>
-            <a:pPr marL="0" indent="0">
+            <a:pPr indent="0" marL="0">
               <a:buNone/>
             </a:pPr>
             <a:r>
@@ -6676,27 +7122,15 @@
         </p:nvGraphicFramePr>
         <p:xfrm>
           <a:off x="640080" y="1463040"/>
-          <a:ext cx="10881360" cy="2834640"/>
+          <a:ext cx="10881360" cy="914400"/>
         </p:xfrm>
         <a:graphic>
           <a:graphicData uri="http://schemas.openxmlformats.org/drawingml/2006/table">
             <a:tbl>
               <a:tblPr/>
               <a:tblGrid>
-                <a:gridCol w="2377440">
-                  <a:extLst>
-                    <a:ext uri="{9D8B030D-6E8A-4147-A177-3AD203B41FA5}">
-                      <a16:colId xmlns:a16="http://schemas.microsoft.com/office/drawing/2014/main" val="20000"/>
-                    </a:ext>
-                  </a:extLst>
-                </a:gridCol>
-                <a:gridCol w="8503920">
-                  <a:extLst>
-                    <a:ext uri="{9D8B030D-6E8A-4147-A177-3AD203B41FA5}">
-                      <a16:colId xmlns:a16="http://schemas.microsoft.com/office/drawing/2014/main" val="20001"/>
-                    </a:ext>
-                  </a:extLst>
-                </a:gridCol>
+                <a:gridCol w="2377440"/>
+                <a:gridCol w="8503920"/>
               </a:tblGrid>
               <a:tr h="566928">
                 <a:tc>
@@ -6704,7 +7138,7 @@
                     <a:bodyPr/>
                     <a:lstStyle/>
                     <a:p>
-                      <a:pPr marL="0" indent="0">
+                      <a:pPr indent="0" marL="0">
                         <a:buNone/>
                       </a:pPr>
                       <a:r>
@@ -6772,7 +7206,7 @@
                     <a:bodyPr/>
                     <a:lstStyle/>
                     <a:p>
-                      <a:pPr marL="0" indent="0">
+                      <a:pPr indent="0" marL="0">
                         <a:buNone/>
                       </a:pPr>
                       <a:r>
@@ -6835,11 +7269,6 @@
                     </a:solidFill>
                   </a:tcPr>
                 </a:tc>
-                <a:extLst>
-                  <a:ext uri="{0D108BD9-81ED-4DB2-BD59-A6C34878D82A}">
-                    <a16:rowId xmlns:a16="http://schemas.microsoft.com/office/drawing/2014/main" val="10000"/>
-                  </a:ext>
-                </a:extLst>
               </a:tr>
               <a:tr h="566928">
                 <a:tc>
@@ -6847,7 +7276,7 @@
                     <a:bodyPr/>
                     <a:lstStyle/>
                     <a:p>
-                      <a:pPr marL="0" indent="0">
+                      <a:pPr indent="0" marL="0">
                         <a:buNone/>
                       </a:pPr>
                       <a:r>
@@ -6915,7 +7344,7 @@
                     <a:bodyPr/>
                     <a:lstStyle/>
                     <a:p>
-                      <a:pPr marL="0" indent="0">
+                      <a:pPr indent="0" marL="0">
                         <a:buNone/>
                       </a:pPr>
                       <a:r>
@@ -6978,11 +7407,6 @@
                     </a:solidFill>
                   </a:tcPr>
                 </a:tc>
-                <a:extLst>
-                  <a:ext uri="{0D108BD9-81ED-4DB2-BD59-A6C34878D82A}">
-                    <a16:rowId xmlns:a16="http://schemas.microsoft.com/office/drawing/2014/main" val="10001"/>
-                  </a:ext>
-                </a:extLst>
               </a:tr>
               <a:tr h="566928">
                 <a:tc>
@@ -6990,7 +7414,7 @@
                     <a:bodyPr/>
                     <a:lstStyle/>
                     <a:p>
-                      <a:pPr marL="0" indent="0">
+                      <a:pPr indent="0" marL="0">
                         <a:buNone/>
                       </a:pPr>
                       <a:r>
@@ -7058,7 +7482,7 @@
                     <a:bodyPr/>
                     <a:lstStyle/>
                     <a:p>
-                      <a:pPr marL="0" indent="0">
+                      <a:pPr indent="0" marL="0">
                         <a:buNone/>
                       </a:pPr>
                       <a:r>
@@ -7121,11 +7545,6 @@
                     </a:solidFill>
                   </a:tcPr>
                 </a:tc>
-                <a:extLst>
-                  <a:ext uri="{0D108BD9-81ED-4DB2-BD59-A6C34878D82A}">
-                    <a16:rowId xmlns:a16="http://schemas.microsoft.com/office/drawing/2014/main" val="10002"/>
-                  </a:ext>
-                </a:extLst>
               </a:tr>
               <a:tr h="566928">
                 <a:tc>
@@ -7133,7 +7552,7 @@
                     <a:bodyPr/>
                     <a:lstStyle/>
                     <a:p>
-                      <a:pPr marL="0" indent="0">
+                      <a:pPr indent="0" marL="0">
                         <a:buNone/>
                       </a:pPr>
                       <a:r>
@@ -7201,7 +7620,7 @@
                     <a:bodyPr/>
                     <a:lstStyle/>
                     <a:p>
-                      <a:pPr marL="0" indent="0">
+                      <a:pPr indent="0" marL="0">
                         <a:buNone/>
                       </a:pPr>
                       <a:r>
@@ -7264,11 +7683,6 @@
                     </a:solidFill>
                   </a:tcPr>
                 </a:tc>
-                <a:extLst>
-                  <a:ext uri="{0D108BD9-81ED-4DB2-BD59-A6C34878D82A}">
-                    <a16:rowId xmlns:a16="http://schemas.microsoft.com/office/drawing/2014/main" val="10003"/>
-                  </a:ext>
-                </a:extLst>
               </a:tr>
               <a:tr h="566928">
                 <a:tc>
@@ -7276,7 +7690,7 @@
                     <a:bodyPr/>
                     <a:lstStyle/>
                     <a:p>
-                      <a:pPr marL="0" indent="0">
+                      <a:pPr indent="0" marL="0">
                         <a:buNone/>
                       </a:pPr>
                       <a:r>
@@ -7344,7 +7758,7 @@
                     <a:bodyPr/>
                     <a:lstStyle/>
                     <a:p>
-                      <a:pPr marL="0" indent="0">
+                      <a:pPr indent="0" marL="0">
                         <a:buNone/>
                       </a:pPr>
                       <a:r>
@@ -7407,11 +7821,6 @@
                     </a:solidFill>
                   </a:tcPr>
                 </a:tc>
-                <a:extLst>
-                  <a:ext uri="{0D108BD9-81ED-4DB2-BD59-A6C34878D82A}">
-                    <a16:rowId xmlns:a16="http://schemas.microsoft.com/office/drawing/2014/main" val="10004"/>
-                  </a:ext>
-                </a:extLst>
               </a:tr>
             </a:tbl>
           </a:graphicData>
@@ -7438,7 +7847,7 @@
           <a:bodyPr wrap="square" lIns="0" tIns="0" rIns="0" bIns="0" rtlCol="0" anchor="ctr"/>
           <a:lstStyle/>
           <a:p>
-            <a:pPr marL="0" indent="0">
+            <a:pPr indent="0" marL="0">
               <a:buNone/>
             </a:pPr>
             <a:r>
@@ -7477,7 +7886,7 @@
           <a:bodyPr wrap="square" lIns="0" tIns="0" rIns="0" bIns="0" rtlCol="0" anchor="ctr"/>
           <a:lstStyle/>
           <a:p>
-            <a:pPr marL="0" indent="0" algn="r">
+            <a:pPr algn="r" indent="0" marL="0">
               <a:buNone/>
             </a:pPr>
             <a:r>
@@ -7511,7 +7920,6 @@
         <a:solidFill>
           <a:srgbClr val="17171D"/>
         </a:solidFill>
-        <a:effectLst/>
       </p:bgPr>
     </p:bg>
     <p:spTree>
@@ -7549,7 +7957,7 @@
           <a:bodyPr wrap="square" lIns="0" tIns="0" rIns="0" bIns="0" rtlCol="0" anchor="ctr"/>
           <a:lstStyle/>
           <a:p>
-            <a:pPr marL="0" indent="0">
+            <a:pPr indent="0" marL="0">
               <a:buNone/>
             </a:pPr>
             <a:r>
@@ -7610,7 +8018,7 @@
           <a:bodyPr wrap="square" lIns="0" tIns="0" rIns="0" bIns="0" rtlCol="0" anchor="ctr"/>
           <a:lstStyle/>
           <a:p>
-            <a:pPr marL="0" indent="0">
+            <a:pPr indent="0" marL="0">
               <a:buNone/>
             </a:pPr>
             <a:r>
@@ -7624,6 +8032,9 @@
               </a:rPr>
               <a:t>Backtracking — naive  </a:t>
             </a:r>
+            <a:pPr indent="0" marL="0">
+              <a:buNone/>
+            </a:pPr>
             <a:r>
               <a:rPr lang="en-US" sz="1250" dirty="0">
                 <a:solidFill>
@@ -7706,7 +8117,7 @@
           <a:bodyPr wrap="square" lIns="0" tIns="0" rIns="0" bIns="0" rtlCol="0" anchor="ctr"/>
           <a:lstStyle/>
           <a:p>
-            <a:pPr marL="0" indent="0">
+            <a:pPr indent="0" marL="0">
               <a:buNone/>
             </a:pPr>
             <a:r>
@@ -7720,6 +8131,9 @@
               </a:rPr>
               <a:t>+ ordering heuristics  </a:t>
             </a:r>
+            <a:pPr indent="0" marL="0">
+              <a:buNone/>
+            </a:pPr>
             <a:r>
               <a:rPr lang="en-US" sz="1250" dirty="0">
                 <a:solidFill>
@@ -7802,7 +8216,7 @@
           <a:bodyPr wrap="square" lIns="0" tIns="0" rIns="0" bIns="0" rtlCol="0" anchor="ctr"/>
           <a:lstStyle/>
           <a:p>
-            <a:pPr marL="0" indent="0">
+            <a:pPr indent="0" marL="0">
               <a:buNone/>
             </a:pPr>
             <a:r>
@@ -7816,6 +8230,9 @@
               </a:rPr>
               <a:t>+ inference  </a:t>
             </a:r>
+            <a:pPr indent="0" marL="0">
+              <a:buNone/>
+            </a:pPr>
             <a:r>
               <a:rPr lang="en-US" sz="1250" dirty="0">
                 <a:solidFill>
@@ -7874,7 +8291,7 @@
           <a:bodyPr wrap="square" lIns="0" tIns="0" rIns="0" bIns="0" rtlCol="0" anchor="ctr"/>
           <a:lstStyle/>
           <a:p>
-            <a:pPr marL="0" indent="0">
+            <a:pPr indent="0" marL="0">
               <a:buNone/>
             </a:pPr>
             <a:r>
@@ -7888,6 +8305,9 @@
               </a:rPr>
               <a:t>Hill climbing  </a:t>
             </a:r>
+            <a:pPr indent="0" marL="0">
+              <a:buNone/>
+            </a:pPr>
             <a:r>
               <a:rPr lang="en-US" sz="1250" dirty="0">
                 <a:solidFill>
@@ -7946,7 +8366,7 @@
           <a:bodyPr wrap="square" lIns="0" tIns="0" rIns="0" bIns="0" rtlCol="0" anchor="ctr"/>
           <a:lstStyle/>
           <a:p>
-            <a:pPr marL="0" indent="0">
+            <a:pPr indent="0" marL="0">
               <a:buNone/>
             </a:pPr>
             <a:r>
@@ -7960,6 +8380,9 @@
               </a:rPr>
               <a:t>Simulated annealing  </a:t>
             </a:r>
+            <a:pPr indent="0" marL="0">
+              <a:buNone/>
+            </a:pPr>
             <a:r>
               <a:rPr lang="en-US" sz="1250" dirty="0">
                 <a:solidFill>
@@ -7996,7 +8419,7 @@
           <a:bodyPr wrap="square" lIns="0" tIns="0" rIns="0" bIns="0" rtlCol="0" anchor="ctr"/>
           <a:lstStyle/>
           <a:p>
-            <a:pPr marL="0" indent="0">
+            <a:pPr indent="0" marL="0">
               <a:buNone/>
             </a:pPr>
             <a:r>
@@ -8035,7 +8458,7 @@
           <a:bodyPr wrap="square" lIns="0" tIns="0" rIns="0" bIns="0" rtlCol="0" anchor="ctr"/>
           <a:lstStyle/>
           <a:p>
-            <a:pPr marL="0" indent="0" algn="r">
+            <a:pPr algn="r" indent="0" marL="0">
               <a:buNone/>
             </a:pPr>
             <a:r>
@@ -8069,7 +8492,6 @@
         <a:solidFill>
           <a:srgbClr val="17171D"/>
         </a:solidFill>
-        <a:effectLst/>
       </p:bgPr>
     </p:bg>
     <p:spTree>
@@ -8107,7 +8529,7 @@
           <a:bodyPr wrap="square" lIns="0" tIns="0" rIns="0" bIns="0" rtlCol="0" anchor="ctr"/>
           <a:lstStyle/>
           <a:p>
-            <a:pPr marL="0" indent="0">
+            <a:pPr indent="0" marL="0">
               <a:buNone/>
             </a:pPr>
             <a:r>
@@ -8146,7 +8568,7 @@
           <a:bodyPr wrap="square" lIns="0" tIns="0" rIns="0" bIns="0" rtlCol="0" anchor="t"/>
           <a:lstStyle/>
           <a:p>
-            <a:pPr marL="0" indent="0">
+            <a:pPr indent="0" marL="0">
               <a:buNone/>
             </a:pPr>
             <a:r>
@@ -8163,7 +8585,7 @@
             <a:endParaRPr lang="en-US" sz="1600" dirty="0"/>
           </a:p>
           <a:p>
-            <a:pPr marL="0" indent="0">
+            <a:pPr indent="0" marL="0">
               <a:buNone/>
             </a:pPr>
             <a:r>
@@ -8202,7 +8624,7 @@
           <a:bodyPr wrap="square" lIns="0" tIns="0" rIns="0" bIns="0" rtlCol="0" anchor="t"/>
           <a:lstStyle/>
           <a:p>
-            <a:pPr marL="0" indent="0">
+            <a:pPr indent="0" marL="0">
               <a:buNone/>
             </a:pPr>
             <a:r>
@@ -8219,7 +8641,7 @@
             <a:endParaRPr lang="en-US" sz="1600" dirty="0"/>
           </a:p>
           <a:p>
-            <a:pPr marL="0" indent="0">
+            <a:pPr indent="0" marL="0">
               <a:buNone/>
             </a:pPr>
             <a:r>
@@ -8258,7 +8680,7 @@
           <a:bodyPr wrap="square" lIns="0" tIns="0" rIns="0" bIns="0" rtlCol="0" anchor="t"/>
           <a:lstStyle/>
           <a:p>
-            <a:pPr marL="0" indent="0">
+            <a:pPr indent="0" marL="0">
               <a:buNone/>
             </a:pPr>
             <a:r>
@@ -8275,7 +8697,7 @@
             <a:endParaRPr lang="en-US" sz="1600" dirty="0"/>
           </a:p>
           <a:p>
-            <a:pPr marL="0" indent="0">
+            <a:pPr indent="0" marL="0">
               <a:buNone/>
             </a:pPr>
             <a:r>
@@ -8295,15 +8717,15 @@
       </p:sp>
       <p:pic>
         <p:nvPicPr>
-          <p:cNvPr id="6" name="Image 0" descr="C:\Users\Annie\AppData\Local\Temp\claude\C--Users-Annie-Desktop-AUA-Artificial-Intelligence-GroupProject\3713b754-8c0d-4788-ba37-4fc6479a5014\scratchpad\gui_screenshot.png"/>
+          <p:cNvPr id="6" name="Image 0" descr="C:\Users\Annie\AppData\Local\Temp\claude\C--Users-Annie-Desktop-AUA-Artificial-Intelligence-GroupProject\3713b754-8c0d-4788-ba37-4fc6479a5014\scratchpad\gui_screenshot.png">    </p:cNvPr>
           <p:cNvPicPr>
             <a:picLocks noChangeAspect="1"/>
           </p:cNvPicPr>
           <p:nvPr/>
         </p:nvPicPr>
         <p:blipFill>
-          <a:blip r:embed="rId3"/>
-          <a:srcRect/>
+          <a:blip r:embed="rId1"/>
+          <a:srcRect l="0" r="0" t="0" b="0"/>
           <a:stretch/>
         </p:blipFill>
         <p:spPr>
@@ -8337,7 +8759,7 @@
           <a:bodyPr wrap="square" lIns="0" tIns="0" rIns="0" bIns="0" rtlCol="0" anchor="ctr"/>
           <a:lstStyle/>
           <a:p>
-            <a:pPr marL="0" indent="0" algn="r">
+            <a:pPr algn="r" indent="0" marL="0">
               <a:buNone/>
             </a:pPr>
             <a:r>
@@ -8371,7 +8793,6 @@
         <a:solidFill>
           <a:srgbClr val="17171D"/>
         </a:solidFill>
-        <a:effectLst/>
       </p:bgPr>
     </p:bg>
     <p:spTree>
@@ -8409,7 +8830,7 @@
           <a:bodyPr wrap="square" lIns="0" tIns="0" rIns="0" bIns="0" rtlCol="0" anchor="ctr"/>
           <a:lstStyle/>
           <a:p>
-            <a:pPr marL="0" indent="0">
+            <a:pPr indent="0" marL="0">
               <a:buNone/>
             </a:pPr>
             <a:r>
@@ -8448,7 +8869,7 @@
           <a:bodyPr wrap="square" lIns="0" tIns="0" rIns="0" bIns="0" rtlCol="0" anchor="t"/>
           <a:lstStyle/>
           <a:p>
-            <a:pPr marL="0" indent="0">
+            <a:pPr indent="0" marL="0">
               <a:buNone/>
             </a:pPr>
             <a:r>
@@ -8547,7 +8968,7 @@
           <a:bodyPr wrap="square" lIns="0" tIns="0" rIns="0" bIns="0" rtlCol="0" anchor="t"/>
           <a:lstStyle/>
           <a:p>
-            <a:pPr marL="0" indent="0">
+            <a:pPr indent="0" marL="0">
               <a:buNone/>
             </a:pPr>
             <a:r>
@@ -8668,7 +9089,7 @@
           <a:bodyPr wrap="square" lIns="0" tIns="0" rIns="0" bIns="0" rtlCol="0" anchor="ctr"/>
           <a:lstStyle/>
           <a:p>
-            <a:pPr marL="0" indent="0">
+            <a:pPr indent="0" marL="0">
               <a:buNone/>
             </a:pPr>
             <a:r>
@@ -8707,7 +9128,7 @@
           <a:bodyPr wrap="square" lIns="0" tIns="0" rIns="0" bIns="0" rtlCol="0" anchor="ctr"/>
           <a:lstStyle/>
           <a:p>
-            <a:pPr marL="0" indent="0" algn="r">
+            <a:pPr algn="r" indent="0" marL="0">
               <a:buNone/>
             </a:pPr>
             <a:r>
@@ -8741,7 +9162,6 @@
         <a:solidFill>
           <a:srgbClr val="17171D"/>
         </a:solidFill>
-        <a:effectLst/>
       </p:bgPr>
     </p:bg>
     <p:spTree>
@@ -8779,7 +9199,7 @@
           <a:bodyPr wrap="square" lIns="0" tIns="0" rIns="0" bIns="0" rtlCol="0" anchor="ctr"/>
           <a:lstStyle/>
           <a:p>
-            <a:pPr marL="0" indent="0">
+            <a:pPr indent="0" marL="0">
               <a:buNone/>
             </a:pPr>
             <a:r>
@@ -8818,7 +9238,7 @@
           <a:bodyPr wrap="square" lIns="0" tIns="0" rIns="0" bIns="0" rtlCol="0" anchor="ctr"/>
           <a:lstStyle/>
           <a:p>
-            <a:pPr marL="0" indent="0">
+            <a:pPr indent="0" marL="0">
               <a:buNone/>
             </a:pPr>
             <a:r>
@@ -8857,7 +9277,7 @@
           <a:bodyPr wrap="square" lIns="0" tIns="0" rIns="0" bIns="0" rtlCol="0" anchor="ctr"/>
           <a:lstStyle/>
           <a:p>
-            <a:pPr marL="0" indent="0">
+            <a:pPr indent="0" marL="0">
               <a:buNone/>
             </a:pPr>
             <a:r>
@@ -8874,7 +9294,7 @@
             <a:endParaRPr lang="en-US" sz="1200" dirty="0"/>
           </a:p>
           <a:p>
-            <a:pPr marL="0" indent="0">
+            <a:pPr indent="0" marL="0">
               <a:buNone/>
             </a:pPr>
             <a:r>
@@ -8913,7 +9333,7 @@
           <a:bodyPr wrap="square" lIns="0" tIns="0" rIns="0" bIns="0" rtlCol="0" anchor="ctr"/>
           <a:lstStyle/>
           <a:p>
-            <a:pPr marL="0" indent="0">
+            <a:pPr indent="0" marL="0">
               <a:buNone/>
             </a:pPr>
             <a:r>
@@ -8952,7 +9372,7 @@
           <a:bodyPr wrap="square" lIns="0" tIns="0" rIns="0" bIns="0" rtlCol="0" anchor="ctr"/>
           <a:lstStyle/>
           <a:p>
-            <a:pPr marL="0" indent="0">
+            <a:pPr indent="0" marL="0">
               <a:buNone/>
             </a:pPr>
             <a:r>
@@ -8969,7 +9389,7 @@
             <a:endParaRPr lang="en-US" sz="1200" dirty="0"/>
           </a:p>
           <a:p>
-            <a:pPr marL="0" indent="0">
+            <a:pPr indent="0" marL="0">
               <a:buNone/>
             </a:pPr>
             <a:r>
@@ -8989,14 +9409,14 @@
       </p:sp>
       <p:pic>
         <p:nvPicPr>
-          <p:cNvPr id="7" name="Image 0" descr="C:\Users\Annie\Desktop\AUA\Artificial Intelligence\GroupProject\LightUp\experiments\results\fig1_bt_scaling.png"/>
+          <p:cNvPr id="7" name="Image 0" descr="C:\Users\Annie\Desktop\AUA\Artificial Intelligence\GroupProject\LightUp\experiments\results\fig1_bt_scaling.png">    </p:cNvPr>
           <p:cNvPicPr>
             <a:picLocks noChangeAspect="1"/>
           </p:cNvPicPr>
           <p:nvPr/>
         </p:nvPicPr>
         <p:blipFill>
-          <a:blip r:embed="rId3"/>
+          <a:blip r:embed="rId1"/>
           <a:stretch>
             <a:fillRect/>
           </a:stretch>
@@ -9032,7 +9452,7 @@
           <a:bodyPr wrap="square" lIns="0" tIns="0" rIns="0" bIns="0" rtlCol="0" anchor="ctr"/>
           <a:lstStyle/>
           <a:p>
-            <a:pPr marL="0" indent="0">
+            <a:pPr indent="0" marL="0">
               <a:buNone/>
             </a:pPr>
             <a:r>
@@ -9071,7 +9491,7 @@
           <a:bodyPr wrap="square" lIns="0" tIns="0" rIns="0" bIns="0" rtlCol="0" anchor="ctr"/>
           <a:lstStyle/>
           <a:p>
-            <a:pPr marL="0" indent="0" algn="r">
+            <a:pPr algn="r" indent="0" marL="0">
               <a:buNone/>
             </a:pPr>
             <a:r>
@@ -9105,7 +9525,6 @@
         <a:solidFill>
           <a:srgbClr val="17171D"/>
         </a:solidFill>
-        <a:effectLst/>
       </p:bgPr>
     </p:bg>
     <p:spTree>
@@ -9143,7 +9562,7 @@
           <a:bodyPr wrap="square" lIns="0" tIns="0" rIns="0" bIns="0" rtlCol="0" anchor="ctr"/>
           <a:lstStyle/>
           <a:p>
-            <a:pPr marL="0" indent="0">
+            <a:pPr indent="0" marL="0">
               <a:buNone/>
             </a:pPr>
             <a:r>
@@ -9163,15 +9582,15 @@
       </p:sp>
       <p:pic>
         <p:nvPicPr>
-          <p:cNvPr id="3" name="Image 0" descr="C:\Users\Annie\Desktop\AUA\Artificial Intelligence\GroupProject\LightUp\experiments\results\fig2_paradigms.png"/>
+          <p:cNvPr id="3" name="Image 0" descr="C:\Users\Annie\Desktop\AUA\Artificial Intelligence\GroupProject\LightUp\experiments\results\fig2_paradigms.png">    </p:cNvPr>
           <p:cNvPicPr>
             <a:picLocks noChangeAspect="1"/>
           </p:cNvPicPr>
           <p:nvPr/>
         </p:nvPicPr>
         <p:blipFill>
-          <a:blip r:embed="rId3"/>
-          <a:srcRect/>
+          <a:blip r:embed="rId1"/>
+          <a:srcRect l="0" r="0" t="0" b="0"/>
           <a:stretch/>
         </p:blipFill>
         <p:spPr>
@@ -9205,7 +9624,7 @@
           <a:bodyPr wrap="square" lIns="0" tIns="0" rIns="0" bIns="0" rtlCol="0" anchor="t"/>
           <a:lstStyle/>
           <a:p>
-            <a:pPr marL="0" indent="0">
+            <a:pPr indent="0" marL="0">
               <a:spcAft>
                 <a:spcPts val="800"/>
               </a:spcAft>
@@ -9328,7 +9747,7 @@
           <a:bodyPr wrap="square" lIns="0" tIns="0" rIns="0" bIns="0" rtlCol="0" anchor="ctr"/>
           <a:lstStyle/>
           <a:p>
-            <a:pPr marL="0" indent="0" algn="r">
+            <a:pPr algn="r" indent="0" marL="0">
               <a:buNone/>
             </a:pPr>
             <a:r>
@@ -9647,319 +10066,4 @@
     </a:ext>
   </a:extLst>
 </a:theme>
-</file>
-
-<file path=ppt/theme/theme2.xml><?xml version="1.0" encoding="utf-8"?>
-<a:theme xmlns:a="http://schemas.openxmlformats.org/drawingml/2006/main" name="Office Theme">
-  <a:themeElements>
-    <a:clrScheme name="Office">
-      <a:dk1>
-        <a:sysClr val="windowText" lastClr="000000"/>
-      </a:dk1>
-      <a:lt1>
-        <a:sysClr val="window" lastClr="FFFFFF"/>
-      </a:lt1>
-      <a:dk2>
-        <a:srgbClr val="0E2841"/>
-      </a:dk2>
-      <a:lt2>
-        <a:srgbClr val="E8E8E8"/>
-      </a:lt2>
-      <a:accent1>
-        <a:srgbClr val="156082"/>
-      </a:accent1>
-      <a:accent2>
-        <a:srgbClr val="E97132"/>
-      </a:accent2>
-      <a:accent3>
-        <a:srgbClr val="196B24"/>
-      </a:accent3>
-      <a:accent4>
-        <a:srgbClr val="0F9ED5"/>
-      </a:accent4>
-      <a:accent5>
-        <a:srgbClr val="A02B93"/>
-      </a:accent5>
-      <a:accent6>
-        <a:srgbClr val="4EA72E"/>
-      </a:accent6>
-      <a:hlink>
-        <a:srgbClr val="467886"/>
-      </a:hlink>
-      <a:folHlink>
-        <a:srgbClr val="96607D"/>
-      </a:folHlink>
-    </a:clrScheme>
-    <a:fontScheme name="Office">
-      <a:majorFont>
-        <a:latin typeface="Aptos Display" panose="02110004020202020204"/>
-        <a:ea typeface=""/>
-        <a:cs typeface=""/>
-        <a:font script="Jpan" typeface="游ゴシック Light"/>
-        <a:font script="Hang" typeface="맑은 고딕"/>
-        <a:font script="Hans" typeface="等线 Light"/>
-        <a:font script="Hant" typeface="新細明體"/>
-        <a:font script="Arab" typeface="Times New Roman"/>
-        <a:font script="Hebr" typeface="Times New Roman"/>
-        <a:font script="Thai" typeface="Angsana New"/>
-        <a:font script="Ethi" typeface="Nyala"/>
-        <a:font script="Beng" typeface="Vrinda"/>
-        <a:font script="Gujr" typeface="Shruti"/>
-        <a:font script="Khmr" typeface="MoolBoran"/>
-        <a:font script="Knda" typeface="Tunga"/>
-        <a:font script="Guru" typeface="Raavi"/>
-        <a:font script="Cans" typeface="Euphemia"/>
-        <a:font script="Cher" typeface="Plantagenet Cherokee"/>
-        <a:font script="Yiii" typeface="Microsoft Yi Baiti"/>
-        <a:font script="Tibt" typeface="Microsoft Himalaya"/>
-        <a:font script="Thaa" typeface="MV Boli"/>
-        <a:font script="Deva" typeface="Mangal"/>
-        <a:font script="Telu" typeface="Gautami"/>
-        <a:font script="Taml" typeface="Latha"/>
-        <a:font script="Syrc" typeface="Estrangelo Edessa"/>
-        <a:font script="Orya" typeface="Kalinga"/>
-        <a:font script="Mlym" typeface="Kartika"/>
-        <a:font script="Laoo" typeface="DokChampa"/>
-        <a:font script="Sinh" typeface="Iskoola Pota"/>
-        <a:font script="Mong" typeface="Mongolian Baiti"/>
-        <a:font script="Viet" typeface="Times New Roman"/>
-        <a:font script="Uigh" typeface="Microsoft Uighur"/>
-        <a:font script="Geor" typeface="Sylfaen"/>
-        <a:font script="Armn" typeface="Arial"/>
-        <a:font script="Bugi" typeface="Leelawadee UI"/>
-        <a:font script="Bopo" typeface="Microsoft JhengHei"/>
-        <a:font script="Java" typeface="Javanese Text"/>
-        <a:font script="Lisu" typeface="Segoe UI"/>
-        <a:font script="Mymr" typeface="Myanmar Text"/>
-        <a:font script="Nkoo" typeface="Ebrima"/>
-        <a:font script="Olck" typeface="Nirmala UI"/>
-        <a:font script="Osma" typeface="Ebrima"/>
-        <a:font script="Phag" typeface="Phagspa"/>
-        <a:font script="Syrn" typeface="Estrangelo Edessa"/>
-        <a:font script="Syrj" typeface="Estrangelo Edessa"/>
-        <a:font script="Syre" typeface="Estrangelo Edessa"/>
-        <a:font script="Sora" typeface="Nirmala UI"/>
-        <a:font script="Tale" typeface="Microsoft Tai Le"/>
-        <a:font script="Talu" typeface="Microsoft New Tai Lue"/>
-        <a:font script="Tfng" typeface="Ebrima"/>
-      </a:majorFont>
-      <a:minorFont>
-        <a:latin typeface="Aptos" panose="02110004020202020204"/>
-        <a:ea typeface=""/>
-        <a:cs typeface=""/>
-        <a:font script="Jpan" typeface="游ゴシック"/>
-        <a:font script="Hang" typeface="맑은 고딕"/>
-        <a:font script="Hans" typeface="等线"/>
-        <a:font script="Hant" typeface="新細明體"/>
-        <a:font script="Arab" typeface="Arial"/>
-        <a:font script="Hebr" typeface="Arial"/>
-        <a:font script="Thai" typeface="Cordia New"/>
-        <a:font script="Ethi" typeface="Nyala"/>
-        <a:font script="Beng" typeface="Vrinda"/>
-        <a:font script="Gujr" typeface="Shruti"/>
-        <a:font script="Khmr" typeface="DaunPenh"/>
-        <a:font script="Knda" typeface="Tunga"/>
-        <a:font script="Guru" typeface="Raavi"/>
-        <a:font script="Cans" typeface="Euphemia"/>
-        <a:font script="Cher" typeface="Plantagenet Cherokee"/>
-        <a:font script="Yiii" typeface="Microsoft Yi Baiti"/>
-        <a:font script="Tibt" typeface="Microsoft Himalaya"/>
-        <a:font script="Thaa" typeface="MV Boli"/>
-        <a:font script="Deva" typeface="Mangal"/>
-        <a:font script="Telu" typeface="Gautami"/>
-        <a:font script="Taml" typeface="Latha"/>
-        <a:font script="Syrc" typeface="Estrangelo Edessa"/>
-        <a:font script="Orya" typeface="Kalinga"/>
-        <a:font script="Mlym" typeface="Kartika"/>
-        <a:font script="Laoo" typeface="DokChampa"/>
-        <a:font script="Sinh" typeface="Iskoola Pota"/>
-        <a:font script="Mong" typeface="Mongolian Baiti"/>
-        <a:font script="Viet" typeface="Arial"/>
-        <a:font script="Uigh" typeface="Microsoft Uighur"/>
-        <a:font script="Geor" typeface="Sylfaen"/>
-        <a:font script="Armn" typeface="Arial"/>
-        <a:font script="Bugi" typeface="Leelawadee UI"/>
-        <a:font script="Bopo" typeface="Microsoft JhengHei"/>
-        <a:font script="Java" typeface="Javanese Text"/>
-        <a:font script="Lisu" typeface="Segoe UI"/>
-        <a:font script="Mymr" typeface="Myanmar Text"/>
-        <a:font script="Nkoo" typeface="Ebrima"/>
-        <a:font script="Olck" typeface="Nirmala UI"/>
-        <a:font script="Osma" typeface="Ebrima"/>
-        <a:font script="Phag" typeface="Phagspa"/>
-        <a:font script="Syrn" typeface="Estrangelo Edessa"/>
-        <a:font script="Syrj" typeface="Estrangelo Edessa"/>
-        <a:font script="Syre" typeface="Estrangelo Edessa"/>
-        <a:font script="Sora" typeface="Nirmala UI"/>
-        <a:font script="Tale" typeface="Microsoft Tai Le"/>
-        <a:font script="Talu" typeface="Microsoft New Tai Lue"/>
-        <a:font script="Tfng" typeface="Ebrima"/>
-      </a:minorFont>
-    </a:fontScheme>
-    <a:fmtScheme name="Office">
-      <a:fillStyleLst>
-        <a:solidFill>
-          <a:schemeClr val="phClr"/>
-        </a:solidFill>
-        <a:gradFill rotWithShape="1">
-          <a:gsLst>
-            <a:gs pos="0">
-              <a:schemeClr val="phClr">
-                <a:lumMod val="110000"/>
-                <a:satMod val="105000"/>
-                <a:tint val="67000"/>
-              </a:schemeClr>
-            </a:gs>
-            <a:gs pos="50000">
-              <a:schemeClr val="phClr">
-                <a:lumMod val="105000"/>
-                <a:satMod val="103000"/>
-                <a:tint val="73000"/>
-              </a:schemeClr>
-            </a:gs>
-            <a:gs pos="100000">
-              <a:schemeClr val="phClr">
-                <a:lumMod val="105000"/>
-                <a:satMod val="109000"/>
-                <a:tint val="81000"/>
-              </a:schemeClr>
-            </a:gs>
-          </a:gsLst>
-          <a:lin ang="5400000" scaled="0"/>
-        </a:gradFill>
-        <a:gradFill rotWithShape="1">
-          <a:gsLst>
-            <a:gs pos="0">
-              <a:schemeClr val="phClr">
-                <a:satMod val="103000"/>
-                <a:lumMod val="102000"/>
-                <a:tint val="94000"/>
-              </a:schemeClr>
-            </a:gs>
-            <a:gs pos="50000">
-              <a:schemeClr val="phClr">
-                <a:satMod val="110000"/>
-                <a:lumMod val="100000"/>
-                <a:shade val="100000"/>
-              </a:schemeClr>
-            </a:gs>
-            <a:gs pos="100000">
-              <a:schemeClr val="phClr">
-                <a:lumMod val="99000"/>
-                <a:satMod val="120000"/>
-                <a:shade val="78000"/>
-              </a:schemeClr>
-            </a:gs>
-          </a:gsLst>
-          <a:lin ang="5400000" scaled="0"/>
-        </a:gradFill>
-      </a:fillStyleLst>
-      <a:lnStyleLst>
-        <a:ln w="12700" cap="flat" cmpd="sng" algn="ctr">
-          <a:solidFill>
-            <a:schemeClr val="phClr"/>
-          </a:solidFill>
-          <a:prstDash val="solid"/>
-          <a:miter lim="800000"/>
-        </a:ln>
-        <a:ln w="19050" cap="flat" cmpd="sng" algn="ctr">
-          <a:solidFill>
-            <a:schemeClr val="phClr"/>
-          </a:solidFill>
-          <a:prstDash val="solid"/>
-          <a:miter lim="800000"/>
-        </a:ln>
-        <a:ln w="25400" cap="flat" cmpd="sng" algn="ctr">
-          <a:solidFill>
-            <a:schemeClr val="phClr"/>
-          </a:solidFill>
-          <a:prstDash val="solid"/>
-          <a:miter lim="800000"/>
-        </a:ln>
-      </a:lnStyleLst>
-      <a:effectStyleLst>
-        <a:effectStyle>
-          <a:effectLst/>
-        </a:effectStyle>
-        <a:effectStyle>
-          <a:effectLst/>
-        </a:effectStyle>
-        <a:effectStyle>
-          <a:effectLst>
-            <a:outerShdw blurRad="57150" dist="19050" dir="5400000" algn="ctr" rotWithShape="0">
-              <a:srgbClr val="000000">
-                <a:alpha val="63000"/>
-              </a:srgbClr>
-            </a:outerShdw>
-          </a:effectLst>
-        </a:effectStyle>
-      </a:effectStyleLst>
-      <a:bgFillStyleLst>
-        <a:solidFill>
-          <a:schemeClr val="phClr"/>
-        </a:solidFill>
-        <a:solidFill>
-          <a:schemeClr val="phClr">
-            <a:tint val="95000"/>
-            <a:satMod val="170000"/>
-          </a:schemeClr>
-        </a:solidFill>
-        <a:gradFill rotWithShape="1">
-          <a:gsLst>
-            <a:gs pos="0">
-              <a:schemeClr val="phClr">
-                <a:tint val="93000"/>
-                <a:satMod val="150000"/>
-                <a:shade val="98000"/>
-                <a:lumMod val="102000"/>
-              </a:schemeClr>
-            </a:gs>
-            <a:gs pos="50000">
-              <a:schemeClr val="phClr">
-                <a:tint val="98000"/>
-                <a:satMod val="130000"/>
-                <a:shade val="90000"/>
-                <a:lumMod val="103000"/>
-              </a:schemeClr>
-            </a:gs>
-            <a:gs pos="100000">
-              <a:schemeClr val="phClr">
-                <a:shade val="63000"/>
-                <a:satMod val="120000"/>
-              </a:schemeClr>
-            </a:gs>
-          </a:gsLst>
-          <a:lin ang="5400000" scaled="0"/>
-        </a:gradFill>
-      </a:bgFillStyleLst>
-    </a:fmtScheme>
-  </a:themeElements>
-  <a:objectDefaults>
-    <a:lnDef>
-      <a:spPr/>
-      <a:bodyPr/>
-      <a:lstStyle/>
-      <a:style>
-        <a:lnRef idx="2">
-          <a:schemeClr val="accent1"/>
-        </a:lnRef>
-        <a:fillRef idx="0">
-          <a:schemeClr val="accent1"/>
-        </a:fillRef>
-        <a:effectRef idx="1">
-          <a:schemeClr val="accent1"/>
-        </a:effectRef>
-        <a:fontRef idx="minor">
-          <a:schemeClr val="tx1"/>
-        </a:fontRef>
-      </a:style>
-    </a:lnDef>
-  </a:objectDefaults>
-  <a:extraClrSchemeLst/>
-  <a:extLst>
-    <a:ext uri="{05A4C25C-085E-4340-85A3-A5531E510DB2}">
-      <thm15:themeFamily xmlns:thm15="http://schemas.microsoft.com/office/thememl/2012/main" name="Office Theme" id="{2E142A2C-CD16-42D6-873A-C26D2A0506FA}" vid="{1BDDFF52-6CD6-40A5-AB3C-68EB2F1E4D0A}"/>
-    </a:ext>
-  </a:extLst>
-</a:theme>
 </file>
</xml_diff>

<commit_message>
Add report-notes.md: working notes for writing the report
Captures the discussion points that lived only in chat: where every
artifact lives, mapping to the required report structure, the arguments
to make (lit-as-derived, uniqueness vs convention, constraint taxonomy,
consistency precision, validator boundary, fc-vs-full, DPLL parallel and
why-no-SAT, local search formulation), all measured findings, the
experimental-design points and caveats, references with their roles, and
draft figure captions.  Header states explicitly: notes, not report text
- the report must be written by the team in their own words.

Co-Authored-By: Claude Fable 5 <noreply@anthropic.com>
</commit_message>
<xml_diff>
--- a/presentation.pptx
+++ b/presentation.pptx
@@ -4,6 +4,9 @@
   <p:sldMasterIdLst>
     <p:sldMasterId id="2147483648" r:id="rId1"/>
   </p:sldMasterIdLst>
+  <p:notesMasterIdLst>
+    <p:notesMasterId r:id="rId15"/>
+  </p:notesMasterIdLst>
   <p:sldIdLst>
     <p:sldId id="256" r:id="rId2"/>
     <p:sldId id="257" r:id="rId3"/>
@@ -19,9 +22,6 @@
     <p:sldId id="267" r:id="rId13"/>
     <p:sldId id="268" r:id="rId14"/>
   </p:sldIdLst>
-  <p:notesMasterIdLst>
-    <p:notesMasterId r:id="rId15"/>
-  </p:notesMasterIdLst>
   <p:sldSz cx="12192000" cy="6858000"/>
   <p:notesSz cx="6858000" cy="12192000"/>
   <p:defaultTextStyle>
@@ -116,6 +116,11 @@
       </a:defRPr>
     </a:lvl9pPr>
   </p:defaultTextStyle>
+  <p:extLst>
+    <p:ext uri="{EFAFB233-063F-42B5-8137-9DF3F51BA10A}">
+      <p15:sldGuideLst xmlns:p15="http://schemas.microsoft.com/office/powerpoint/2012/main"/>
+    </p:ext>
+  </p:extLst>
 </p:presentation>
 </file>
 
@@ -141,234 +146,10 @@
           <a:chExt cx="0" cy="0"/>
         </a:xfrm>
       </p:grpSpPr>
-      <p:sp>
-        <p:nvSpPr>
-          <p:cNvPr id="2" name="Header Placeholder 1"/>
-          <p:cNvSpPr>
-            <a:spLocks noGrp="1"/>
-          </p:cNvSpPr>
-          <p:nvPr>
-            <p:ph type="hdr" sz="quarter"/>
-          </p:nvPr>
-        </p:nvSpPr>
-        <p:spPr>
-          <a:xfrm>
-            <a:off x="0" y="0"/>
-            <a:ext cx="2971800" cy="458788"/>
-          </a:xfrm>
-          <a:prstGeom prst="rect">
-            <a:avLst/>
-          </a:prstGeom>
-        </p:spPr>
-        <p:txBody>
-          <a:bodyPr vert="horz" lIns="91440" tIns="45720" rIns="91440" bIns="45720" rtlCol="0"/>
-          <a:lstStyle>
-            <a:lvl1pPr algn="l">
-              <a:defRPr sz="1200"/>
-            </a:lvl1pPr>
-          </a:lstStyle>
-          <a:p>
-            <a:endParaRPr lang="en-US"/>
-          </a:p>
-        </p:txBody>
-      </p:sp>
-      <p:sp>
-        <p:nvSpPr>
-          <p:cNvPr id="3" name="Date Placeholder 2"/>
-          <p:cNvSpPr>
-            <a:spLocks noGrp="1"/>
-          </p:cNvSpPr>
-          <p:nvPr>
-            <p:ph type="dt" idx="1"/>
-          </p:nvPr>
-        </p:nvSpPr>
-        <p:spPr>
-          <a:xfrm>
-            <a:off x="3884613" y="0"/>
-            <a:ext cx="2971800" cy="458788"/>
-          </a:xfrm>
-          <a:prstGeom prst="rect">
-            <a:avLst/>
-          </a:prstGeom>
-        </p:spPr>
-        <p:txBody>
-          <a:bodyPr vert="horz" lIns="91440" tIns="45720" rIns="91440" bIns="45720" rtlCol="0"/>
-          <a:lstStyle>
-            <a:lvl1pPr algn="r">
-              <a:defRPr sz="1200"/>
-            </a:lvl1pPr>
-          </a:lstStyle>
-          <a:p>
-            <a:fld id="{5282F153-3F37-0F45-9E97-73ACFA13230C}" type="datetimeFigureOut">
-              <a:rPr lang="en-US"/>
-              <a:t>7/23/19</a:t>
-            </a:fld>
-            <a:endParaRPr lang="en-US"/>
-          </a:p>
-        </p:txBody>
-      </p:sp>
-      <p:sp>
-        <p:nvSpPr>
-          <p:cNvPr id="4" name="Slide Image Placeholder 3"/>
-          <p:cNvSpPr>
-            <a:spLocks noGrp="1" noRot="1" noChangeAspect="1"/>
-          </p:cNvSpPr>
-          <p:nvPr>
-            <p:ph type="sldImg" idx="2"/>
-          </p:nvPr>
-        </p:nvSpPr>
-        <p:spPr>
-          <a:xfrm>
-            <a:off x="685800" y="1143000"/>
-            <a:ext cx="5486400" cy="3086100"/>
-          </a:xfrm>
-          <a:prstGeom prst="rect">
-            <a:avLst/>
-          </a:prstGeom>
-          <a:noFill/>
-          <a:ln w="12700">
-            <a:solidFill>
-              <a:prstClr val="black"/>
-            </a:solidFill>
-          </a:ln>
-        </p:spPr>
-        <p:txBody>
-          <a:bodyPr vert="horz" lIns="91440" tIns="45720" rIns="91440" bIns="45720" rtlCol="0" anchor="ctr"/>
-          <a:lstStyle/>
-          <a:p>
-            <a:endParaRPr lang="en-US"/>
-          </a:p>
-        </p:txBody>
-      </p:sp>
-      <p:sp>
-        <p:nvSpPr>
-          <p:cNvPr id="5" name="Notes Placeholder 4"/>
-          <p:cNvSpPr>
-            <a:spLocks noGrp="1"/>
-          </p:cNvSpPr>
-          <p:nvPr>
-            <p:ph type="body" sz="quarter" idx="3"/>
-          </p:nvPr>
-        </p:nvSpPr>
-        <p:spPr>
-          <a:xfrm>
-            <a:off x="685800" y="4400550"/>
-            <a:ext cx="5486400" cy="3600450"/>
-          </a:xfrm>
-          <a:prstGeom prst="rect">
-            <a:avLst/>
-          </a:prstGeom>
-        </p:spPr>
-        <p:txBody>
-          <a:bodyPr vert="horz" lIns="91440" tIns="45720" rIns="91440" bIns="45720" rtlCol="0"/>
-          <a:lstStyle/>
-          <a:p>
-            <a:pPr lvl="0"/>
-            <a:r>
-              <a:rPr lang="en-US"/>
-              <a:t>Click to edit Master text styles</a:t>
-            </a:r>
-          </a:p>
-          <a:p>
-            <a:pPr lvl="1"/>
-            <a:r>
-              <a:rPr lang="en-US"/>
-              <a:t>Second level</a:t>
-            </a:r>
-          </a:p>
-          <a:p>
-            <a:pPr lvl="2"/>
-            <a:r>
-              <a:rPr lang="en-US"/>
-              <a:t>Third level</a:t>
-            </a:r>
-          </a:p>
-          <a:p>
-            <a:pPr lvl="3"/>
-            <a:r>
-              <a:rPr lang="en-US"/>
-              <a:t>Fourth level</a:t>
-            </a:r>
-          </a:p>
-          <a:p>
-            <a:pPr lvl="4"/>
-            <a:r>
-              <a:rPr lang="en-US"/>
-              <a:t>Fifth level</a:t>
-            </a:r>
-          </a:p>
-        </p:txBody>
-      </p:sp>
-      <p:sp>
-        <p:nvSpPr>
-          <p:cNvPr id="6" name="Footer Placeholder 5"/>
-          <p:cNvSpPr>
-            <a:spLocks noGrp="1"/>
-          </p:cNvSpPr>
-          <p:nvPr>
-            <p:ph type="ftr" sz="quarter" idx="4"/>
-          </p:nvPr>
-        </p:nvSpPr>
-        <p:spPr>
-          <a:xfrm>
-            <a:off x="0" y="8685213"/>
-            <a:ext cx="2971800" cy="458787"/>
-          </a:xfrm>
-          <a:prstGeom prst="rect">
-            <a:avLst/>
-          </a:prstGeom>
-        </p:spPr>
-        <p:txBody>
-          <a:bodyPr vert="horz" lIns="91440" tIns="45720" rIns="91440" bIns="45720" rtlCol="0" anchor="b"/>
-          <a:lstStyle>
-            <a:lvl1pPr algn="l">
-              <a:defRPr sz="1200"/>
-            </a:lvl1pPr>
-          </a:lstStyle>
-          <a:p>
-            <a:endParaRPr lang="en-US"/>
-          </a:p>
-        </p:txBody>
-      </p:sp>
-      <p:sp>
-        <p:nvSpPr>
-          <p:cNvPr id="7" name="Slide Number Placeholder 6"/>
-          <p:cNvSpPr>
-            <a:spLocks noGrp="1"/>
-          </p:cNvSpPr>
-          <p:nvPr>
-            <p:ph type="sldNum" sz="quarter" idx="5"/>
-          </p:nvPr>
-        </p:nvSpPr>
-        <p:spPr>
-          <a:xfrm>
-            <a:off x="3884613" y="8685213"/>
-            <a:ext cx="2971800" cy="458787"/>
-          </a:xfrm>
-          <a:prstGeom prst="rect">
-            <a:avLst/>
-          </a:prstGeom>
-        </p:spPr>
-        <p:txBody>
-          <a:bodyPr vert="horz" lIns="91440" tIns="45720" rIns="91440" bIns="45720" rtlCol="0" anchor="b"/>
-          <a:lstStyle>
-            <a:lvl1pPr algn="r">
-              <a:defRPr sz="1200"/>
-            </a:lvl1pPr>
-          </a:lstStyle>
-          <a:p>
-            <a:fld id="{CE5E9CC1-C706-0F49-92D6-E571CC5EEA8F}" type="slidenum">
-              <a:rPr lang="en-US"/>
-              <a:t>‹#›</a:t>
-            </a:fld>
-            <a:endParaRPr lang="en-US"/>
-          </a:p>
-        </p:txBody>
-      </p:sp>
     </p:spTree>
     <p:extLst>
       <p:ext uri="{BB962C8B-B14F-4D97-AF65-F5344CB8AC3E}">
-        <p14:creationId xmlns:p14="http://schemas.microsoft.com/office/powerpoint/2010/main" val="1024086991"/>
+        <p14:creationId xmlns:p14="http://schemas.microsoft.com/office/powerpoint/2010/main" val="3380503886"/>
       </p:ext>
     </p:extLst>
   </p:cSld>
@@ -516,7 +297,6 @@
               <a:rPr lang="en-US" dirty="0"/>
               <a:t>~30s. One presenter opens. Replace member placeholders with real names. The board on the right is the Pulles (2021) example puzzle with its unique solution, drawn by our own renderer's conventions.</a:t>
             </a:r>
-            <a:endParaRPr lang="en-US" dirty="0"/>
           </a:p>
         </p:txBody>
       </p:sp>
@@ -604,7 +384,6 @@
               <a:rPr lang="en-US" dirty="0"/>
               <a:t>~1 min. The beyond-the-obvious slide. The headline: our density presets predict difficulty for HUMANS (deduction chains), not for solvers - sparse boards have many solutions and finding any one is easy. Tie back to the uniqueness discussion. Calibrating difficulty by measured effort is named future work.</a:t>
             </a:r>
-            <a:endParaRPr lang="en-US" dirty="0"/>
           </a:p>
         </p:txBody>
       </p:sp>
@@ -692,7 +471,6 @@
               <a:rPr lang="en-US" dirty="0"/>
               <a:t>ONE sentence, ~20s: 'We re-ran the entire sweep with double the budget - almost nothing changed, and hill climbing gained exactly zero - so the solver ranking is structural, not an artifact of the timeout.' If asked in Q&amp;A: we predicted the outcomes before running (full unchanged, hc zero); the one miss was SA, which we expected to gain more - exponential problems shrug at factors of two.</a:t>
             </a:r>
-            <a:endParaRPr lang="en-US" dirty="0"/>
           </a:p>
         </p:txBody>
       </p:sp>
@@ -780,7 +558,6 @@
               <a:rPr lang="en-US" dirty="0"/>
               <a:t>~45s. Every claim here is a measured number from experiments/results/results.csv (overall: SA 45/75 = 60%, HC 21/75 = 28%; hard-only: 19/25 vs 11/25). All four members should have spoken by now (equal input is graded).</a:t>
             </a:r>
-            <a:endParaRPr lang="en-US" dirty="0"/>
           </a:p>
         </p:txBody>
       </p:sp>
@@ -868,7 +645,6 @@
               <a:rPr lang="en-US" dirty="0"/>
               <a:t>Not spoken — present for completeness and Q&amp;A.</a:t>
             </a:r>
-            <a:endParaRPr lang="en-US" dirty="0"/>
           </a:p>
         </p:txBody>
       </p:sp>
@@ -956,7 +732,6 @@
               <a:rPr lang="en-US" dirty="0"/>
               <a:t>~1 min. State the rules quickly with the example. Do NOT dwell — the course requires only a brief problem statement. Mention the uniqueness note; it returns in the analysis.</a:t>
             </a:r>
-            <a:endParaRPr lang="en-US" dirty="0"/>
           </a:p>
         </p:txBody>
       </p:sp>
@@ -1044,7 +819,6 @@
               <a:rPr lang="en-US" dirty="0"/>
               <a:t>~1 min. The three cards are the topic-choice justification. Keep the prior-work strip to two sentences — the course explicitly says existing approaches should be mentioned only very briefly.</a:t>
             </a:r>
-            <a:endParaRPr lang="en-US" dirty="0"/>
           </a:p>
         </p:txBody>
       </p:sp>
@@ -1132,7 +906,6 @@
               <a:rPr lang="en-US" dirty="0"/>
               <a:t>~45s. One slide of formalism, no more. Do NOT explain what a CSP or backtracking is — covered in the course. The 'lit is derived' line preempts a common Q&amp;A question about the domain.</a:t>
             </a:r>
-            <a:endParaRPr lang="en-US" dirty="0"/>
           </a:p>
         </p:txBody>
       </p:sp>
@@ -1220,7 +993,6 @@
               <a:rPr lang="en-US" dirty="0"/>
               <a:t>~1 min. The experiment design in one picture: each arrow on the left changes exactly one thing, so differences in the stats are attributable. Right column is the cross-paradigm comparison.</a:t>
             </a:r>
-            <a:endParaRPr lang="en-US" dirty="0"/>
           </a:p>
         </p:txBody>
       </p:sp>
@@ -1308,7 +1080,6 @@
               <a:rPr lang="en-US" dirty="0"/>
               <a:t>~45s. The screenshot is the naive solver mid-replay on a 10x10: red frame = conflict at (9,7), green digits = satisfied clues, status bar streams the event counter and search stats. Demo bait: if time allows in Q&amp;A, a 20-second live solve in the GUI is worth more than this slide. Do not show code.</a:t>
             </a:r>
-            <a:endParaRPr lang="en-US" dirty="0"/>
           </a:p>
         </p:txBody>
       </p:sp>
@@ -1396,7 +1167,6 @@
               <a:rPr lang="en-US" dirty="0"/>
               <a:t>~45s. Fill the two [CONFIRM] blanks once the experiment harness is final. The bottom principle matters in Q&amp;A: multi-solution instances make answer-comparison invalid as a correctness test.</a:t>
             </a:r>
-            <a:endParaRPr lang="en-US" dirty="0"/>
           </a:p>
         </p:txBody>
       </p:sp>
@@ -1484,7 +1254,6 @@
               <a:rPr lang="en-US" dirty="0"/>
               <a:t>~1.5 min. THE core slide. Say the numbers out loud: naive 308 nodes on the 7x7, forward checking 12, full inference ZERO - the published puzzle is solved by deduction alone, which is exactly what publishers curate for. Then the scaling panels: 1-2 orders of magnitude between naive and the smart variants. Close with the nodes-vs-time nuance - fewer nodes is not automatically less time.</a:t>
             </a:r>
-            <a:endParaRPr lang="en-US" dirty="0"/>
           </a:p>
         </p:txBody>
       </p:sp>
@@ -1572,7 +1341,6 @@
               <a:rPr lang="en-US" dirty="0"/>
               <a:t>~1.5 min. Cross-paradigm comparison. Lead with SA vs HC (the Perera reproduction), then the one-violation-away story - it is the local-optimum concept made concrete. End on the honest framing: on these sizes complete search wins; incompleteness is the structural caveat.</a:t>
             </a:r>
-            <a:endParaRPr lang="en-US" dirty="0"/>
           </a:p>
         </p:txBody>
       </p:sp>
@@ -1645,6 +1413,11 @@
 <file path=ppt/slideMasters/slideMaster1.xml><?xml version="1.0" encoding="utf-8"?>
 <p:sldMaster xmlns:a="http://schemas.openxmlformats.org/drawingml/2006/main" xmlns:r="http://schemas.openxmlformats.org/officeDocument/2006/relationships" xmlns:p="http://schemas.openxmlformats.org/presentationml/2006/main">
   <p:cSld>
+    <p:bg>
+      <p:bgRef idx="1001">
+        <a:schemeClr val="bg1"/>
+      </p:bgRef>
+    </p:bg>
     <p:spTree>
       <p:nvGrpSpPr>
         <p:cNvPr id="1" name=""/>
@@ -1927,6 +1700,7 @@
         <a:solidFill>
           <a:srgbClr val="17171D"/>
         </a:solidFill>
+        <a:effectLst/>
       </p:bgPr>
     </p:bg>
     <p:spTree>
@@ -2231,7 +2005,7 @@
           <a:bodyPr wrap="square" lIns="0" tIns="0" rIns="0" bIns="0" rtlCol="0" anchor="ctr"/>
           <a:lstStyle/>
           <a:p>
-            <a:pPr algn="ctr" indent="0" marL="0">
+            <a:pPr marL="0" indent="0" algn="ctr">
               <a:buNone/>
             </a:pPr>
             <a:r>
@@ -2320,7 +2094,7 @@
           <a:bodyPr wrap="square" lIns="0" tIns="0" rIns="0" bIns="0" rtlCol="0" anchor="ctr"/>
           <a:lstStyle/>
           <a:p>
-            <a:pPr algn="ctr" indent="0" marL="0">
+            <a:pPr marL="0" indent="0" algn="ctr">
               <a:buNone/>
             </a:pPr>
             <a:r>
@@ -2576,7 +2350,7 @@
           <a:bodyPr wrap="square" lIns="0" tIns="0" rIns="0" bIns="0" rtlCol="0" anchor="ctr"/>
           <a:lstStyle/>
           <a:p>
-            <a:pPr algn="ctr" indent="0" marL="0">
+            <a:pPr marL="0" indent="0" algn="ctr">
               <a:buNone/>
             </a:pPr>
             <a:r>
@@ -4067,7 +3841,7 @@
           <a:bodyPr wrap="square" lIns="0" tIns="0" rIns="0" bIns="0" rtlCol="0" anchor="ctr"/>
           <a:lstStyle/>
           <a:p>
-            <a:pPr algn="ctr" indent="0" marL="0">
+            <a:pPr marL="0" indent="0" algn="ctr">
               <a:buNone/>
             </a:pPr>
             <a:r>
@@ -4273,7 +4047,7 @@
           <a:bodyPr wrap="square" lIns="0" tIns="0" rIns="0" bIns="0" rtlCol="0" anchor="ctr"/>
           <a:lstStyle/>
           <a:p>
-            <a:pPr algn="ctr" indent="0" marL="0">
+            <a:pPr marL="0" indent="0" algn="ctr">
               <a:buNone/>
             </a:pPr>
             <a:r>
@@ -4554,7 +4328,7 @@
           <a:bodyPr wrap="square" lIns="0" tIns="0" rIns="0" bIns="0" rtlCol="0" anchor="ctr"/>
           <a:lstStyle/>
           <a:p>
-            <a:pPr indent="0" marL="0">
+            <a:pPr marL="0" indent="0">
               <a:buNone/>
             </a:pPr>
             <a:r>
@@ -4566,7 +4340,23 @@
                 <a:ea typeface="Arial" pitchFamily="34" charset="-122"/>
                 <a:cs typeface="Arial" pitchFamily="34" charset="-120"/>
               </a:rPr>
-              <a:t>Lighting Up Akari with AI Search</a:t>
+              <a:t>Lighting Up Akari with </a:t>
+            </a:r>
+          </a:p>
+          <a:p>
+            <a:pPr marL="0" indent="0">
+              <a:buNone/>
+            </a:pPr>
+            <a:r>
+              <a:rPr lang="en-US" sz="4000" b="1" dirty="0">
+                <a:solidFill>
+                  <a:srgbClr val="F2EFE7"/>
+                </a:solidFill>
+                <a:latin typeface="Arial" pitchFamily="34" charset="0"/>
+                <a:ea typeface="Arial" pitchFamily="34" charset="-122"/>
+                <a:cs typeface="Arial" pitchFamily="34" charset="-120"/>
+              </a:rPr>
+              <a:t>AI Search</a:t>
             </a:r>
             <a:endParaRPr lang="en-US" sz="4000" dirty="0"/>
           </a:p>
@@ -4593,7 +4383,7 @@
           <a:bodyPr wrap="square" lIns="0" tIns="0" rIns="0" bIns="0" rtlCol="0" anchor="ctr"/>
           <a:lstStyle/>
           <a:p>
-            <a:pPr indent="0" marL="0">
+            <a:pPr marL="0" indent="0">
               <a:buNone/>
             </a:pPr>
             <a:r>
@@ -4610,7 +4400,7 @@
             <a:endParaRPr lang="en-US" sz="1700" dirty="0"/>
           </a:p>
           <a:p>
-            <a:pPr indent="0" marL="0">
+            <a:pPr marL="0" indent="0">
               <a:buNone/>
             </a:pPr>
             <a:r>
@@ -4649,7 +4439,7 @@
           <a:bodyPr wrap="square" lIns="0" tIns="0" rIns="0" bIns="0" rtlCol="0" anchor="ctr"/>
           <a:lstStyle/>
           <a:p>
-            <a:pPr indent="0" marL="0">
+            <a:pPr marL="0" indent="0">
               <a:buNone/>
             </a:pPr>
             <a:r>
@@ -4661,7 +4451,18 @@
                 <a:ea typeface="Calibri" pitchFamily="34" charset="-122"/>
                 <a:cs typeface="Calibri" pitchFamily="34" charset="-120"/>
               </a:rPr>
-              <a:t>[Member 1]  ·  [Member 2]  ·  [Member 3]  ·  [Member 4]</a:t>
+              <a:t>Anna Gasparyan ·  Ani Baghumyan ·  Izabella </a:t>
+            </a:r>
+            <a:r>
+              <a:rPr lang="en-US" sz="1400" dirty="0" err="1">
+                <a:solidFill>
+                  <a:srgbClr val="F2EFE7"/>
+                </a:solidFill>
+                <a:latin typeface="Calibri" pitchFamily="34" charset="0"/>
+                <a:ea typeface="Calibri" pitchFamily="34" charset="-122"/>
+                <a:cs typeface="Calibri" pitchFamily="34" charset="-120"/>
+              </a:rPr>
+              <a:t>Atajanyan</a:t>
             </a:r>
             <a:endParaRPr lang="en-US" sz="1400" dirty="0"/>
           </a:p>
@@ -4688,7 +4489,7 @@
           <a:bodyPr wrap="square" lIns="0" tIns="0" rIns="0" bIns="0" rtlCol="0" anchor="ctr"/>
           <a:lstStyle/>
           <a:p>
-            <a:pPr indent="0" marL="0">
+            <a:pPr marL="0" indent="0">
               <a:buNone/>
             </a:pPr>
             <a:r>
@@ -4722,6 +4523,7 @@
         <a:solidFill>
           <a:srgbClr val="17171D"/>
         </a:solidFill>
+        <a:effectLst/>
       </p:bgPr>
     </p:bg>
     <p:spTree>
@@ -4759,7 +4561,7 @@
           <a:bodyPr wrap="square" lIns="0" tIns="0" rIns="0" bIns="0" rtlCol="0" anchor="ctr"/>
           <a:lstStyle/>
           <a:p>
-            <a:pPr indent="0" marL="0">
+            <a:pPr marL="0" indent="0">
               <a:buNone/>
             </a:pPr>
             <a:r>
@@ -4779,15 +4581,15 @@
       </p:sp>
       <p:pic>
         <p:nvPicPr>
-          <p:cNvPr id="3" name="Image 0" descr="C:\Users\Annie\Desktop\AUA\Artificial Intelligence\GroupProject\LightUp\experiments\results\fig3_difficulty.png">    </p:cNvPr>
+          <p:cNvPr id="3" name="Image 0" descr="C:\Users\Annie\Desktop\AUA\Artificial Intelligence\GroupProject\LightUp\experiments\results\fig3_difficulty.png"/>
           <p:cNvPicPr>
             <a:picLocks noChangeAspect="1"/>
           </p:cNvPicPr>
           <p:nvPr/>
         </p:nvPicPr>
         <p:blipFill>
-          <a:blip r:embed="rId1"/>
-          <a:srcRect l="0" r="0" t="0" b="0"/>
+          <a:blip r:embed="rId3"/>
+          <a:srcRect/>
           <a:stretch/>
         </p:blipFill>
         <p:spPr>
@@ -4821,7 +4623,7 @@
           <a:bodyPr wrap="square" lIns="0" tIns="0" rIns="0" bIns="0" rtlCol="0" anchor="t"/>
           <a:lstStyle/>
           <a:p>
-            <a:pPr indent="0" marL="0">
+            <a:pPr marL="0" indent="0">
               <a:spcAft>
                 <a:spcPts val="800"/>
               </a:spcAft>
@@ -4923,7 +4725,7 @@
           <a:bodyPr wrap="square" lIns="0" tIns="0" rIns="0" bIns="0" rtlCol="0" anchor="ctr"/>
           <a:lstStyle/>
           <a:p>
-            <a:pPr algn="r" indent="0" marL="0">
+            <a:pPr marL="0" indent="0" algn="r">
               <a:buNone/>
             </a:pPr>
             <a:r>
@@ -4957,6 +4759,7 @@
         <a:solidFill>
           <a:srgbClr val="17171D"/>
         </a:solidFill>
+        <a:effectLst/>
       </p:bgPr>
     </p:bg>
     <p:spTree>
@@ -4994,7 +4797,7 @@
           <a:bodyPr wrap="square" lIns="0" tIns="0" rIns="0" bIns="0" rtlCol="0" anchor="ctr"/>
           <a:lstStyle/>
           <a:p>
-            <a:pPr indent="0" marL="0">
+            <a:pPr marL="0" indent="0">
               <a:buNone/>
             </a:pPr>
             <a:r>
@@ -5014,14 +4817,14 @@
       </p:sp>
       <p:pic>
         <p:nvPicPr>
-          <p:cNvPr id="3" name="Image 0" descr="C:\Users\Annie\Desktop\AUA\Artificial Intelligence\GroupProject\LightUp\experiments\results\fig4_budget.png">    </p:cNvPr>
+          <p:cNvPr id="3" name="Image 0" descr="C:\Users\Annie\Desktop\AUA\Artificial Intelligence\GroupProject\LightUp\experiments\results\fig4_budget.png"/>
           <p:cNvPicPr>
             <a:picLocks noChangeAspect="1"/>
           </p:cNvPicPr>
           <p:nvPr/>
         </p:nvPicPr>
         <p:blipFill>
-          <a:blip r:embed="rId1"/>
+          <a:blip r:embed="rId3"/>
           <a:stretch>
             <a:fillRect/>
           </a:stretch>
@@ -5057,7 +4860,7 @@
           <a:bodyPr wrap="square" lIns="0" tIns="0" rIns="0" bIns="0" rtlCol="0" anchor="ctr"/>
           <a:lstStyle/>
           <a:p>
-            <a:pPr algn="ctr" indent="0" marL="0">
+            <a:pPr marL="0" indent="0" algn="ctr">
               <a:buNone/>
             </a:pPr>
             <a:r>
@@ -5096,7 +4899,7 @@
           <a:bodyPr wrap="square" lIns="0" tIns="0" rIns="0" bIns="0" rtlCol="0" anchor="ctr"/>
           <a:lstStyle/>
           <a:p>
-            <a:pPr algn="r" indent="0" marL="0">
+            <a:pPr marL="0" indent="0" algn="r">
               <a:buNone/>
             </a:pPr>
             <a:r>
@@ -5130,6 +4933,7 @@
         <a:solidFill>
           <a:srgbClr val="17171D"/>
         </a:solidFill>
+        <a:effectLst/>
       </p:bgPr>
     </p:bg>
     <p:spTree>
@@ -5167,7 +4971,7 @@
           <a:bodyPr wrap="square" lIns="0" tIns="0" rIns="0" bIns="0" rtlCol="0" anchor="ctr"/>
           <a:lstStyle/>
           <a:p>
-            <a:pPr indent="0" marL="0">
+            <a:pPr marL="0" indent="0">
               <a:buNone/>
             </a:pPr>
             <a:r>
@@ -5352,7 +5156,7 @@
           <a:bodyPr wrap="square" lIns="0" tIns="0" rIns="0" bIns="0" rtlCol="0" anchor="ctr"/>
           <a:lstStyle/>
           <a:p>
-            <a:pPr algn="ctr" indent="0" marL="0">
+            <a:pPr marL="0" indent="0" algn="ctr">
               <a:buNone/>
             </a:pPr>
             <a:r>
@@ -5391,7 +5195,7 @@
           <a:bodyPr wrap="square" lIns="0" tIns="0" rIns="0" bIns="0" rtlCol="0" anchor="ctr"/>
           <a:lstStyle/>
           <a:p>
-            <a:pPr algn="r" indent="0" marL="0">
+            <a:pPr marL="0" indent="0" algn="r">
               <a:buNone/>
             </a:pPr>
             <a:r>
@@ -5425,6 +5229,7 @@
         <a:solidFill>
           <a:srgbClr val="17171D"/>
         </a:solidFill>
+        <a:effectLst/>
       </p:bgPr>
     </p:bg>
     <p:spTree>
@@ -5462,7 +5267,7 @@
           <a:bodyPr wrap="square" lIns="0" tIns="0" rIns="0" bIns="0" rtlCol="0" anchor="ctr"/>
           <a:lstStyle/>
           <a:p>
-            <a:pPr indent="0" marL="0">
+            <a:pPr marL="0" indent="0">
               <a:buNone/>
             </a:pPr>
             <a:r>
@@ -5649,7 +5454,7 @@
           <a:bodyPr wrap="square" lIns="0" tIns="0" rIns="0" bIns="0" rtlCol="0" anchor="ctr"/>
           <a:lstStyle/>
           <a:p>
-            <a:pPr algn="r" indent="0" marL="0">
+            <a:pPr marL="0" indent="0" algn="r">
               <a:buNone/>
             </a:pPr>
             <a:r>
@@ -5683,6 +5488,7 @@
         <a:solidFill>
           <a:srgbClr val="17171D"/>
         </a:solidFill>
+        <a:effectLst/>
       </p:bgPr>
     </p:bg>
     <p:spTree>
@@ -5720,7 +5526,7 @@
           <a:bodyPr wrap="square" lIns="0" tIns="0" rIns="0" bIns="0" rtlCol="0" anchor="ctr"/>
           <a:lstStyle/>
           <a:p>
-            <a:pPr indent="0" marL="0">
+            <a:pPr marL="0" indent="0">
               <a:buNone/>
             </a:pPr>
             <a:r>
@@ -5759,7 +5565,7 @@
           <a:bodyPr wrap="square" lIns="0" tIns="0" rIns="0" bIns="0" rtlCol="0" anchor="t"/>
           <a:lstStyle/>
           <a:p>
-            <a:pPr indent="0" marL="0">
+            <a:pPr marL="0" indent="0">
               <a:buNone/>
             </a:pPr>
             <a:r>
@@ -5776,7 +5582,7 @@
             <a:endParaRPr lang="en-US" sz="1800" dirty="0"/>
           </a:p>
           <a:p>
-            <a:pPr indent="0" marL="0">
+            <a:pPr marL="0" indent="0">
               <a:buNone/>
             </a:pPr>
             <a:r>
@@ -5815,7 +5621,7 @@
           <a:bodyPr wrap="square" lIns="0" tIns="0" rIns="0" bIns="0" rtlCol="0" anchor="t"/>
           <a:lstStyle/>
           <a:p>
-            <a:pPr indent="0" marL="0">
+            <a:pPr marL="0" indent="0">
               <a:buNone/>
             </a:pPr>
             <a:r>
@@ -5832,7 +5638,7 @@
             <a:endParaRPr lang="en-US" sz="1800" dirty="0"/>
           </a:p>
           <a:p>
-            <a:pPr indent="0" marL="0">
+            <a:pPr marL="0" indent="0">
               <a:buNone/>
             </a:pPr>
             <a:r>
@@ -5871,7 +5677,7 @@
           <a:bodyPr wrap="square" lIns="0" tIns="0" rIns="0" bIns="0" rtlCol="0" anchor="t"/>
           <a:lstStyle/>
           <a:p>
-            <a:pPr indent="0" marL="0">
+            <a:pPr marL="0" indent="0">
               <a:buNone/>
             </a:pPr>
             <a:r>
@@ -5888,7 +5694,7 @@
             <a:endParaRPr lang="en-US" sz="1800" dirty="0"/>
           </a:p>
           <a:p>
-            <a:pPr indent="0" marL="0">
+            <a:pPr marL="0" indent="0">
               <a:buNone/>
             </a:pPr>
             <a:r>
@@ -5927,7 +5733,7 @@
           <a:bodyPr wrap="square" lIns="0" tIns="0" rIns="0" bIns="0" rtlCol="0" anchor="ctr"/>
           <a:lstStyle/>
           <a:p>
-            <a:pPr indent="0" marL="0">
+            <a:pPr marL="0" indent="0">
               <a:buNone/>
             </a:pPr>
             <a:r>
@@ -5991,7 +5797,7 @@
           <a:bodyPr wrap="square" lIns="0" tIns="0" rIns="0" bIns="0" rtlCol="0" anchor="ctr"/>
           <a:lstStyle/>
           <a:p>
-            <a:pPr algn="ctr" indent="0" marL="0">
+            <a:pPr marL="0" indent="0" algn="ctr">
               <a:buNone/>
             </a:pPr>
             <a:r>
@@ -6581,7 +6387,7 @@
           <a:bodyPr wrap="square" lIns="0" tIns="0" rIns="0" bIns="0" rtlCol="0" anchor="ctr"/>
           <a:lstStyle/>
           <a:p>
-            <a:pPr algn="ctr" indent="0" marL="0">
+            <a:pPr marL="0" indent="0" algn="ctr">
               <a:buNone/>
             </a:pPr>
             <a:r>
@@ -6620,7 +6426,7 @@
           <a:bodyPr wrap="square" lIns="0" tIns="0" rIns="0" bIns="0" rtlCol="0" anchor="ctr"/>
           <a:lstStyle/>
           <a:p>
-            <a:pPr algn="r" indent="0" marL="0">
+            <a:pPr marL="0" indent="0" algn="r">
               <a:buNone/>
             </a:pPr>
             <a:r>
@@ -6654,6 +6460,7 @@
         <a:solidFill>
           <a:srgbClr val="17171D"/>
         </a:solidFill>
+        <a:effectLst/>
       </p:bgPr>
     </p:bg>
     <p:spTree>
@@ -6691,7 +6498,7 @@
           <a:bodyPr wrap="square" lIns="0" tIns="0" rIns="0" bIns="0" rtlCol="0" anchor="ctr"/>
           <a:lstStyle/>
           <a:p>
-            <a:pPr indent="0" marL="0">
+            <a:pPr marL="0" indent="0">
               <a:buNone/>
             </a:pPr>
             <a:r>
@@ -6752,7 +6559,7 @@
           <a:bodyPr wrap="square" lIns="0" tIns="0" rIns="0" bIns="0" rtlCol="0" anchor="t"/>
           <a:lstStyle/>
           <a:p>
-            <a:pPr indent="0" marL="0">
+            <a:pPr marL="0" indent="0">
               <a:buNone/>
             </a:pPr>
             <a:r>
@@ -6769,7 +6576,7 @@
             <a:endParaRPr lang="en-US" sz="1900" dirty="0"/>
           </a:p>
           <a:p>
-            <a:pPr indent="0" marL="0">
+            <a:pPr marL="0" indent="0">
               <a:buNone/>
             </a:pPr>
             <a:r>
@@ -6830,7 +6637,7 @@
           <a:bodyPr wrap="square" lIns="0" tIns="0" rIns="0" bIns="0" rtlCol="0" anchor="t"/>
           <a:lstStyle/>
           <a:p>
-            <a:pPr indent="0" marL="0">
+            <a:pPr marL="0" indent="0">
               <a:buNone/>
             </a:pPr>
             <a:r>
@@ -6847,7 +6654,7 @@
             <a:endParaRPr lang="en-US" sz="1900" dirty="0"/>
           </a:p>
           <a:p>
-            <a:pPr indent="0" marL="0">
+            <a:pPr marL="0" indent="0">
               <a:buNone/>
             </a:pPr>
             <a:r>
@@ -6908,7 +6715,7 @@
           <a:bodyPr wrap="square" lIns="0" tIns="0" rIns="0" bIns="0" rtlCol="0" anchor="t"/>
           <a:lstStyle/>
           <a:p>
-            <a:pPr indent="0" marL="0">
+            <a:pPr marL="0" indent="0">
               <a:buNone/>
             </a:pPr>
             <a:r>
@@ -6925,7 +6732,7 @@
             <a:endParaRPr lang="en-US" sz="1900" dirty="0"/>
           </a:p>
           <a:p>
-            <a:pPr indent="0" marL="0">
+            <a:pPr marL="0" indent="0">
               <a:buNone/>
             </a:pPr>
             <a:r>
@@ -6964,7 +6771,7 @@
           <a:bodyPr wrap="square" lIns="0" tIns="0" rIns="0" bIns="0" rtlCol="0" anchor="ctr"/>
           <a:lstStyle/>
           <a:p>
-            <a:pPr indent="0" marL="0">
+            <a:pPr marL="0" indent="0">
               <a:buNone/>
             </a:pPr>
             <a:r>
@@ -6978,9 +6785,6 @@
               </a:rPr>
               <a:t>Existing approaches (briefly): </a:t>
             </a:r>
-            <a:pPr indent="0" marL="0">
-              <a:buNone/>
-            </a:pPr>
             <a:r>
               <a:rPr lang="en-US" sz="1400" dirty="0">
                 <a:solidFill>
@@ -7017,7 +6821,7 @@
           <a:bodyPr wrap="square" lIns="0" tIns="0" rIns="0" bIns="0" rtlCol="0" anchor="ctr"/>
           <a:lstStyle/>
           <a:p>
-            <a:pPr algn="r" indent="0" marL="0">
+            <a:pPr marL="0" indent="0" algn="r">
               <a:buNone/>
             </a:pPr>
             <a:r>
@@ -7051,6 +6855,7 @@
         <a:solidFill>
           <a:srgbClr val="17171D"/>
         </a:solidFill>
+        <a:effectLst/>
       </p:bgPr>
     </p:bg>
     <p:spTree>
@@ -7088,7 +6893,7 @@
           <a:bodyPr wrap="square" lIns="0" tIns="0" rIns="0" bIns="0" rtlCol="0" anchor="ctr"/>
           <a:lstStyle/>
           <a:p>
-            <a:pPr indent="0" marL="0">
+            <a:pPr marL="0" indent="0">
               <a:buNone/>
             </a:pPr>
             <a:r>
@@ -7122,15 +6927,27 @@
         </p:nvGraphicFramePr>
         <p:xfrm>
           <a:off x="640080" y="1463040"/>
-          <a:ext cx="10881360" cy="914400"/>
+          <a:ext cx="10881360" cy="2834640"/>
         </p:xfrm>
         <a:graphic>
           <a:graphicData uri="http://schemas.openxmlformats.org/drawingml/2006/table">
             <a:tbl>
               <a:tblPr/>
               <a:tblGrid>
-                <a:gridCol w="2377440"/>
-                <a:gridCol w="8503920"/>
+                <a:gridCol w="2377440">
+                  <a:extLst>
+                    <a:ext uri="{9D8B030D-6E8A-4147-A177-3AD203B41FA5}">
+                      <a16:colId xmlns:a16="http://schemas.microsoft.com/office/drawing/2014/main" val="20000"/>
+                    </a:ext>
+                  </a:extLst>
+                </a:gridCol>
+                <a:gridCol w="8503920">
+                  <a:extLst>
+                    <a:ext uri="{9D8B030D-6E8A-4147-A177-3AD203B41FA5}">
+                      <a16:colId xmlns:a16="http://schemas.microsoft.com/office/drawing/2014/main" val="20001"/>
+                    </a:ext>
+                  </a:extLst>
+                </a:gridCol>
               </a:tblGrid>
               <a:tr h="566928">
                 <a:tc>
@@ -7138,7 +6955,7 @@
                     <a:bodyPr/>
                     <a:lstStyle/>
                     <a:p>
-                      <a:pPr indent="0" marL="0">
+                      <a:pPr marL="0" indent="0">
                         <a:buNone/>
                       </a:pPr>
                       <a:r>
@@ -7206,7 +7023,7 @@
                     <a:bodyPr/>
                     <a:lstStyle/>
                     <a:p>
-                      <a:pPr indent="0" marL="0">
+                      <a:pPr marL="0" indent="0">
                         <a:buNone/>
                       </a:pPr>
                       <a:r>
@@ -7269,6 +7086,11 @@
                     </a:solidFill>
                   </a:tcPr>
                 </a:tc>
+                <a:extLst>
+                  <a:ext uri="{0D108BD9-81ED-4DB2-BD59-A6C34878D82A}">
+                    <a16:rowId xmlns:a16="http://schemas.microsoft.com/office/drawing/2014/main" val="10000"/>
+                  </a:ext>
+                </a:extLst>
               </a:tr>
               <a:tr h="566928">
                 <a:tc>
@@ -7276,7 +7098,7 @@
                     <a:bodyPr/>
                     <a:lstStyle/>
                     <a:p>
-                      <a:pPr indent="0" marL="0">
+                      <a:pPr marL="0" indent="0">
                         <a:buNone/>
                       </a:pPr>
                       <a:r>
@@ -7344,7 +7166,7 @@
                     <a:bodyPr/>
                     <a:lstStyle/>
                     <a:p>
-                      <a:pPr indent="0" marL="0">
+                      <a:pPr marL="0" indent="0">
                         <a:buNone/>
                       </a:pPr>
                       <a:r>
@@ -7407,6 +7229,11 @@
                     </a:solidFill>
                   </a:tcPr>
                 </a:tc>
+                <a:extLst>
+                  <a:ext uri="{0D108BD9-81ED-4DB2-BD59-A6C34878D82A}">
+                    <a16:rowId xmlns:a16="http://schemas.microsoft.com/office/drawing/2014/main" val="10001"/>
+                  </a:ext>
+                </a:extLst>
               </a:tr>
               <a:tr h="566928">
                 <a:tc>
@@ -7414,7 +7241,7 @@
                     <a:bodyPr/>
                     <a:lstStyle/>
                     <a:p>
-                      <a:pPr indent="0" marL="0">
+                      <a:pPr marL="0" indent="0">
                         <a:buNone/>
                       </a:pPr>
                       <a:r>
@@ -7482,7 +7309,7 @@
                     <a:bodyPr/>
                     <a:lstStyle/>
                     <a:p>
-                      <a:pPr indent="0" marL="0">
+                      <a:pPr marL="0" indent="0">
                         <a:buNone/>
                       </a:pPr>
                       <a:r>
@@ -7545,6 +7372,11 @@
                     </a:solidFill>
                   </a:tcPr>
                 </a:tc>
+                <a:extLst>
+                  <a:ext uri="{0D108BD9-81ED-4DB2-BD59-A6C34878D82A}">
+                    <a16:rowId xmlns:a16="http://schemas.microsoft.com/office/drawing/2014/main" val="10002"/>
+                  </a:ext>
+                </a:extLst>
               </a:tr>
               <a:tr h="566928">
                 <a:tc>
@@ -7552,7 +7384,7 @@
                     <a:bodyPr/>
                     <a:lstStyle/>
                     <a:p>
-                      <a:pPr indent="0" marL="0">
+                      <a:pPr marL="0" indent="0">
                         <a:buNone/>
                       </a:pPr>
                       <a:r>
@@ -7620,7 +7452,7 @@
                     <a:bodyPr/>
                     <a:lstStyle/>
                     <a:p>
-                      <a:pPr indent="0" marL="0">
+                      <a:pPr marL="0" indent="0">
                         <a:buNone/>
                       </a:pPr>
                       <a:r>
@@ -7683,6 +7515,11 @@
                     </a:solidFill>
                   </a:tcPr>
                 </a:tc>
+                <a:extLst>
+                  <a:ext uri="{0D108BD9-81ED-4DB2-BD59-A6C34878D82A}">
+                    <a16:rowId xmlns:a16="http://schemas.microsoft.com/office/drawing/2014/main" val="10003"/>
+                  </a:ext>
+                </a:extLst>
               </a:tr>
               <a:tr h="566928">
                 <a:tc>
@@ -7690,7 +7527,7 @@
                     <a:bodyPr/>
                     <a:lstStyle/>
                     <a:p>
-                      <a:pPr indent="0" marL="0">
+                      <a:pPr marL="0" indent="0">
                         <a:buNone/>
                       </a:pPr>
                       <a:r>
@@ -7758,7 +7595,7 @@
                     <a:bodyPr/>
                     <a:lstStyle/>
                     <a:p>
-                      <a:pPr indent="0" marL="0">
+                      <a:pPr marL="0" indent="0">
                         <a:buNone/>
                       </a:pPr>
                       <a:r>
@@ -7821,6 +7658,11 @@
                     </a:solidFill>
                   </a:tcPr>
                 </a:tc>
+                <a:extLst>
+                  <a:ext uri="{0D108BD9-81ED-4DB2-BD59-A6C34878D82A}">
+                    <a16:rowId xmlns:a16="http://schemas.microsoft.com/office/drawing/2014/main" val="10004"/>
+                  </a:ext>
+                </a:extLst>
               </a:tr>
             </a:tbl>
           </a:graphicData>
@@ -7847,7 +7689,7 @@
           <a:bodyPr wrap="square" lIns="0" tIns="0" rIns="0" bIns="0" rtlCol="0" anchor="ctr"/>
           <a:lstStyle/>
           <a:p>
-            <a:pPr indent="0" marL="0">
+            <a:pPr marL="0" indent="0">
               <a:buNone/>
             </a:pPr>
             <a:r>
@@ -7886,7 +7728,7 @@
           <a:bodyPr wrap="square" lIns="0" tIns="0" rIns="0" bIns="0" rtlCol="0" anchor="ctr"/>
           <a:lstStyle/>
           <a:p>
-            <a:pPr algn="r" indent="0" marL="0">
+            <a:pPr marL="0" indent="0" algn="r">
               <a:buNone/>
             </a:pPr>
             <a:r>
@@ -7920,6 +7762,7 @@
         <a:solidFill>
           <a:srgbClr val="17171D"/>
         </a:solidFill>
+        <a:effectLst/>
       </p:bgPr>
     </p:bg>
     <p:spTree>
@@ -7957,7 +7800,7 @@
           <a:bodyPr wrap="square" lIns="0" tIns="0" rIns="0" bIns="0" rtlCol="0" anchor="ctr"/>
           <a:lstStyle/>
           <a:p>
-            <a:pPr indent="0" marL="0">
+            <a:pPr marL="0" indent="0">
               <a:buNone/>
             </a:pPr>
             <a:r>
@@ -8018,7 +7861,7 @@
           <a:bodyPr wrap="square" lIns="0" tIns="0" rIns="0" bIns="0" rtlCol="0" anchor="ctr"/>
           <a:lstStyle/>
           <a:p>
-            <a:pPr indent="0" marL="0">
+            <a:pPr marL="0" indent="0">
               <a:buNone/>
             </a:pPr>
             <a:r>
@@ -8032,9 +7875,6 @@
               </a:rPr>
               <a:t>Backtracking — naive  </a:t>
             </a:r>
-            <a:pPr indent="0" marL="0">
-              <a:buNone/>
-            </a:pPr>
             <a:r>
               <a:rPr lang="en-US" sz="1250" dirty="0">
                 <a:solidFill>
@@ -8117,7 +7957,7 @@
           <a:bodyPr wrap="square" lIns="0" tIns="0" rIns="0" bIns="0" rtlCol="0" anchor="ctr"/>
           <a:lstStyle/>
           <a:p>
-            <a:pPr indent="0" marL="0">
+            <a:pPr marL="0" indent="0">
               <a:buNone/>
             </a:pPr>
             <a:r>
@@ -8131,9 +7971,6 @@
               </a:rPr>
               <a:t>+ ordering heuristics  </a:t>
             </a:r>
-            <a:pPr indent="0" marL="0">
-              <a:buNone/>
-            </a:pPr>
             <a:r>
               <a:rPr lang="en-US" sz="1250" dirty="0">
                 <a:solidFill>
@@ -8216,7 +8053,7 @@
           <a:bodyPr wrap="square" lIns="0" tIns="0" rIns="0" bIns="0" rtlCol="0" anchor="ctr"/>
           <a:lstStyle/>
           <a:p>
-            <a:pPr indent="0" marL="0">
+            <a:pPr marL="0" indent="0">
               <a:buNone/>
             </a:pPr>
             <a:r>
@@ -8230,9 +8067,6 @@
               </a:rPr>
               <a:t>+ inference  </a:t>
             </a:r>
-            <a:pPr indent="0" marL="0">
-              <a:buNone/>
-            </a:pPr>
             <a:r>
               <a:rPr lang="en-US" sz="1250" dirty="0">
                 <a:solidFill>
@@ -8291,7 +8125,7 @@
           <a:bodyPr wrap="square" lIns="0" tIns="0" rIns="0" bIns="0" rtlCol="0" anchor="ctr"/>
           <a:lstStyle/>
           <a:p>
-            <a:pPr indent="0" marL="0">
+            <a:pPr marL="0" indent="0">
               <a:buNone/>
             </a:pPr>
             <a:r>
@@ -8305,9 +8139,6 @@
               </a:rPr>
               <a:t>Hill climbing  </a:t>
             </a:r>
-            <a:pPr indent="0" marL="0">
-              <a:buNone/>
-            </a:pPr>
             <a:r>
               <a:rPr lang="en-US" sz="1250" dirty="0">
                 <a:solidFill>
@@ -8366,7 +8197,7 @@
           <a:bodyPr wrap="square" lIns="0" tIns="0" rIns="0" bIns="0" rtlCol="0" anchor="ctr"/>
           <a:lstStyle/>
           <a:p>
-            <a:pPr indent="0" marL="0">
+            <a:pPr marL="0" indent="0">
               <a:buNone/>
             </a:pPr>
             <a:r>
@@ -8380,9 +8211,6 @@
               </a:rPr>
               <a:t>Simulated annealing  </a:t>
             </a:r>
-            <a:pPr indent="0" marL="0">
-              <a:buNone/>
-            </a:pPr>
             <a:r>
               <a:rPr lang="en-US" sz="1250" dirty="0">
                 <a:solidFill>
@@ -8419,7 +8247,7 @@
           <a:bodyPr wrap="square" lIns="0" tIns="0" rIns="0" bIns="0" rtlCol="0" anchor="ctr"/>
           <a:lstStyle/>
           <a:p>
-            <a:pPr indent="0" marL="0">
+            <a:pPr marL="0" indent="0">
               <a:buNone/>
             </a:pPr>
             <a:r>
@@ -8458,7 +8286,7 @@
           <a:bodyPr wrap="square" lIns="0" tIns="0" rIns="0" bIns="0" rtlCol="0" anchor="ctr"/>
           <a:lstStyle/>
           <a:p>
-            <a:pPr algn="r" indent="0" marL="0">
+            <a:pPr marL="0" indent="0" algn="r">
               <a:buNone/>
             </a:pPr>
             <a:r>
@@ -8492,6 +8320,7 @@
         <a:solidFill>
           <a:srgbClr val="17171D"/>
         </a:solidFill>
+        <a:effectLst/>
       </p:bgPr>
     </p:bg>
     <p:spTree>
@@ -8529,7 +8358,7 @@
           <a:bodyPr wrap="square" lIns="0" tIns="0" rIns="0" bIns="0" rtlCol="0" anchor="ctr"/>
           <a:lstStyle/>
           <a:p>
-            <a:pPr indent="0" marL="0">
+            <a:pPr marL="0" indent="0">
               <a:buNone/>
             </a:pPr>
             <a:r>
@@ -8568,7 +8397,7 @@
           <a:bodyPr wrap="square" lIns="0" tIns="0" rIns="0" bIns="0" rtlCol="0" anchor="t"/>
           <a:lstStyle/>
           <a:p>
-            <a:pPr indent="0" marL="0">
+            <a:pPr marL="0" indent="0">
               <a:buNone/>
             </a:pPr>
             <a:r>
@@ -8585,7 +8414,7 @@
             <a:endParaRPr lang="en-US" sz="1600" dirty="0"/>
           </a:p>
           <a:p>
-            <a:pPr indent="0" marL="0">
+            <a:pPr marL="0" indent="0">
               <a:buNone/>
             </a:pPr>
             <a:r>
@@ -8624,7 +8453,7 @@
           <a:bodyPr wrap="square" lIns="0" tIns="0" rIns="0" bIns="0" rtlCol="0" anchor="t"/>
           <a:lstStyle/>
           <a:p>
-            <a:pPr indent="0" marL="0">
+            <a:pPr marL="0" indent="0">
               <a:buNone/>
             </a:pPr>
             <a:r>
@@ -8641,7 +8470,7 @@
             <a:endParaRPr lang="en-US" sz="1600" dirty="0"/>
           </a:p>
           <a:p>
-            <a:pPr indent="0" marL="0">
+            <a:pPr marL="0" indent="0">
               <a:buNone/>
             </a:pPr>
             <a:r>
@@ -8680,7 +8509,7 @@
           <a:bodyPr wrap="square" lIns="0" tIns="0" rIns="0" bIns="0" rtlCol="0" anchor="t"/>
           <a:lstStyle/>
           <a:p>
-            <a:pPr indent="0" marL="0">
+            <a:pPr marL="0" indent="0">
               <a:buNone/>
             </a:pPr>
             <a:r>
@@ -8697,7 +8526,7 @@
             <a:endParaRPr lang="en-US" sz="1600" dirty="0"/>
           </a:p>
           <a:p>
-            <a:pPr indent="0" marL="0">
+            <a:pPr marL="0" indent="0">
               <a:buNone/>
             </a:pPr>
             <a:r>
@@ -8717,15 +8546,15 @@
       </p:sp>
       <p:pic>
         <p:nvPicPr>
-          <p:cNvPr id="6" name="Image 0" descr="C:\Users\Annie\AppData\Local\Temp\claude\C--Users-Annie-Desktop-AUA-Artificial-Intelligence-GroupProject\3713b754-8c0d-4788-ba37-4fc6479a5014\scratchpad\gui_screenshot.png">    </p:cNvPr>
+          <p:cNvPr id="6" name="Image 0" descr="C:\Users\Annie\AppData\Local\Temp\claude\C--Users-Annie-Desktop-AUA-Artificial-Intelligence-GroupProject\3713b754-8c0d-4788-ba37-4fc6479a5014\scratchpad\gui_screenshot.png"/>
           <p:cNvPicPr>
             <a:picLocks noChangeAspect="1"/>
           </p:cNvPicPr>
           <p:nvPr/>
         </p:nvPicPr>
         <p:blipFill>
-          <a:blip r:embed="rId1"/>
-          <a:srcRect l="0" r="0" t="0" b="0"/>
+          <a:blip r:embed="rId3"/>
+          <a:srcRect/>
           <a:stretch/>
         </p:blipFill>
         <p:spPr>
@@ -8759,7 +8588,7 @@
           <a:bodyPr wrap="square" lIns="0" tIns="0" rIns="0" bIns="0" rtlCol="0" anchor="ctr"/>
           <a:lstStyle/>
           <a:p>
-            <a:pPr algn="r" indent="0" marL="0">
+            <a:pPr marL="0" indent="0" algn="r">
               <a:buNone/>
             </a:pPr>
             <a:r>
@@ -8793,6 +8622,7 @@
         <a:solidFill>
           <a:srgbClr val="17171D"/>
         </a:solidFill>
+        <a:effectLst/>
       </p:bgPr>
     </p:bg>
     <p:spTree>
@@ -8830,7 +8660,7 @@
           <a:bodyPr wrap="square" lIns="0" tIns="0" rIns="0" bIns="0" rtlCol="0" anchor="ctr"/>
           <a:lstStyle/>
           <a:p>
-            <a:pPr indent="0" marL="0">
+            <a:pPr marL="0" indent="0">
               <a:buNone/>
             </a:pPr>
             <a:r>
@@ -8869,7 +8699,7 @@
           <a:bodyPr wrap="square" lIns="0" tIns="0" rIns="0" bIns="0" rtlCol="0" anchor="t"/>
           <a:lstStyle/>
           <a:p>
-            <a:pPr indent="0" marL="0">
+            <a:pPr marL="0" indent="0">
               <a:buNone/>
             </a:pPr>
             <a:r>
@@ -8968,7 +8798,7 @@
           <a:bodyPr wrap="square" lIns="0" tIns="0" rIns="0" bIns="0" rtlCol="0" anchor="t"/>
           <a:lstStyle/>
           <a:p>
-            <a:pPr indent="0" marL="0">
+            <a:pPr marL="0" indent="0">
               <a:buNone/>
             </a:pPr>
             <a:r>
@@ -9089,7 +8919,7 @@
           <a:bodyPr wrap="square" lIns="0" tIns="0" rIns="0" bIns="0" rtlCol="0" anchor="ctr"/>
           <a:lstStyle/>
           <a:p>
-            <a:pPr indent="0" marL="0">
+            <a:pPr marL="0" indent="0">
               <a:buNone/>
             </a:pPr>
             <a:r>
@@ -9128,7 +8958,7 @@
           <a:bodyPr wrap="square" lIns="0" tIns="0" rIns="0" bIns="0" rtlCol="0" anchor="ctr"/>
           <a:lstStyle/>
           <a:p>
-            <a:pPr algn="r" indent="0" marL="0">
+            <a:pPr marL="0" indent="0" algn="r">
               <a:buNone/>
             </a:pPr>
             <a:r>
@@ -9162,6 +8992,7 @@
         <a:solidFill>
           <a:srgbClr val="17171D"/>
         </a:solidFill>
+        <a:effectLst/>
       </p:bgPr>
     </p:bg>
     <p:spTree>
@@ -9199,7 +9030,7 @@
           <a:bodyPr wrap="square" lIns="0" tIns="0" rIns="0" bIns="0" rtlCol="0" anchor="ctr"/>
           <a:lstStyle/>
           <a:p>
-            <a:pPr indent="0" marL="0">
+            <a:pPr marL="0" indent="0">
               <a:buNone/>
             </a:pPr>
             <a:r>
@@ -9238,7 +9069,7 @@
           <a:bodyPr wrap="square" lIns="0" tIns="0" rIns="0" bIns="0" rtlCol="0" anchor="ctr"/>
           <a:lstStyle/>
           <a:p>
-            <a:pPr indent="0" marL="0">
+            <a:pPr marL="0" indent="0">
               <a:buNone/>
             </a:pPr>
             <a:r>
@@ -9277,7 +9108,7 @@
           <a:bodyPr wrap="square" lIns="0" tIns="0" rIns="0" bIns="0" rtlCol="0" anchor="ctr"/>
           <a:lstStyle/>
           <a:p>
-            <a:pPr indent="0" marL="0">
+            <a:pPr marL="0" indent="0">
               <a:buNone/>
             </a:pPr>
             <a:r>
@@ -9294,7 +9125,7 @@
             <a:endParaRPr lang="en-US" sz="1200" dirty="0"/>
           </a:p>
           <a:p>
-            <a:pPr indent="0" marL="0">
+            <a:pPr marL="0" indent="0">
               <a:buNone/>
             </a:pPr>
             <a:r>
@@ -9333,7 +9164,7 @@
           <a:bodyPr wrap="square" lIns="0" tIns="0" rIns="0" bIns="0" rtlCol="0" anchor="ctr"/>
           <a:lstStyle/>
           <a:p>
-            <a:pPr indent="0" marL="0">
+            <a:pPr marL="0" indent="0">
               <a:buNone/>
             </a:pPr>
             <a:r>
@@ -9372,7 +9203,7 @@
           <a:bodyPr wrap="square" lIns="0" tIns="0" rIns="0" bIns="0" rtlCol="0" anchor="ctr"/>
           <a:lstStyle/>
           <a:p>
-            <a:pPr indent="0" marL="0">
+            <a:pPr marL="0" indent="0">
               <a:buNone/>
             </a:pPr>
             <a:r>
@@ -9389,7 +9220,7 @@
             <a:endParaRPr lang="en-US" sz="1200" dirty="0"/>
           </a:p>
           <a:p>
-            <a:pPr indent="0" marL="0">
+            <a:pPr marL="0" indent="0">
               <a:buNone/>
             </a:pPr>
             <a:r>
@@ -9409,14 +9240,14 @@
       </p:sp>
       <p:pic>
         <p:nvPicPr>
-          <p:cNvPr id="7" name="Image 0" descr="C:\Users\Annie\Desktop\AUA\Artificial Intelligence\GroupProject\LightUp\experiments\results\fig1_bt_scaling.png">    </p:cNvPr>
+          <p:cNvPr id="7" name="Image 0" descr="C:\Users\Annie\Desktop\AUA\Artificial Intelligence\GroupProject\LightUp\experiments\results\fig1_bt_scaling.png"/>
           <p:cNvPicPr>
             <a:picLocks noChangeAspect="1"/>
           </p:cNvPicPr>
           <p:nvPr/>
         </p:nvPicPr>
         <p:blipFill>
-          <a:blip r:embed="rId1"/>
+          <a:blip r:embed="rId3"/>
           <a:stretch>
             <a:fillRect/>
           </a:stretch>
@@ -9452,7 +9283,7 @@
           <a:bodyPr wrap="square" lIns="0" tIns="0" rIns="0" bIns="0" rtlCol="0" anchor="ctr"/>
           <a:lstStyle/>
           <a:p>
-            <a:pPr indent="0" marL="0">
+            <a:pPr marL="0" indent="0">
               <a:buNone/>
             </a:pPr>
             <a:r>
@@ -9491,7 +9322,7 @@
           <a:bodyPr wrap="square" lIns="0" tIns="0" rIns="0" bIns="0" rtlCol="0" anchor="ctr"/>
           <a:lstStyle/>
           <a:p>
-            <a:pPr algn="r" indent="0" marL="0">
+            <a:pPr marL="0" indent="0" algn="r">
               <a:buNone/>
             </a:pPr>
             <a:r>
@@ -9525,6 +9356,7 @@
         <a:solidFill>
           <a:srgbClr val="17171D"/>
         </a:solidFill>
+        <a:effectLst/>
       </p:bgPr>
     </p:bg>
     <p:spTree>
@@ -9562,7 +9394,7 @@
           <a:bodyPr wrap="square" lIns="0" tIns="0" rIns="0" bIns="0" rtlCol="0" anchor="ctr"/>
           <a:lstStyle/>
           <a:p>
-            <a:pPr indent="0" marL="0">
+            <a:pPr marL="0" indent="0">
               <a:buNone/>
             </a:pPr>
             <a:r>
@@ -9582,15 +9414,15 @@
       </p:sp>
       <p:pic>
         <p:nvPicPr>
-          <p:cNvPr id="3" name="Image 0" descr="C:\Users\Annie\Desktop\AUA\Artificial Intelligence\GroupProject\LightUp\experiments\results\fig2_paradigms.png">    </p:cNvPr>
+          <p:cNvPr id="3" name="Image 0" descr="C:\Users\Annie\Desktop\AUA\Artificial Intelligence\GroupProject\LightUp\experiments\results\fig2_paradigms.png"/>
           <p:cNvPicPr>
             <a:picLocks noChangeAspect="1"/>
           </p:cNvPicPr>
           <p:nvPr/>
         </p:nvPicPr>
         <p:blipFill>
-          <a:blip r:embed="rId1"/>
-          <a:srcRect l="0" r="0" t="0" b="0"/>
+          <a:blip r:embed="rId3"/>
+          <a:srcRect/>
           <a:stretch/>
         </p:blipFill>
         <p:spPr>
@@ -9624,7 +9456,7 @@
           <a:bodyPr wrap="square" lIns="0" tIns="0" rIns="0" bIns="0" rtlCol="0" anchor="t"/>
           <a:lstStyle/>
           <a:p>
-            <a:pPr indent="0" marL="0">
+            <a:pPr marL="0" indent="0">
               <a:spcAft>
                 <a:spcPts val="800"/>
               </a:spcAft>
@@ -9747,7 +9579,7 @@
           <a:bodyPr wrap="square" lIns="0" tIns="0" rIns="0" bIns="0" rtlCol="0" anchor="ctr"/>
           <a:lstStyle/>
           <a:p>
-            <a:pPr algn="r" indent="0" marL="0">
+            <a:pPr marL="0" indent="0" algn="r">
               <a:buNone/>
             </a:pPr>
             <a:r>
@@ -10066,4 +9898,319 @@
     </a:ext>
   </a:extLst>
 </a:theme>
+</file>
+
+<file path=ppt/theme/theme2.xml><?xml version="1.0" encoding="utf-8"?>
+<a:theme xmlns:a="http://schemas.openxmlformats.org/drawingml/2006/main" name="Office Theme">
+  <a:themeElements>
+    <a:clrScheme name="Office">
+      <a:dk1>
+        <a:sysClr val="windowText" lastClr="000000"/>
+      </a:dk1>
+      <a:lt1>
+        <a:sysClr val="window" lastClr="FFFFFF"/>
+      </a:lt1>
+      <a:dk2>
+        <a:srgbClr val="0E2841"/>
+      </a:dk2>
+      <a:lt2>
+        <a:srgbClr val="E8E8E8"/>
+      </a:lt2>
+      <a:accent1>
+        <a:srgbClr val="156082"/>
+      </a:accent1>
+      <a:accent2>
+        <a:srgbClr val="E97132"/>
+      </a:accent2>
+      <a:accent3>
+        <a:srgbClr val="196B24"/>
+      </a:accent3>
+      <a:accent4>
+        <a:srgbClr val="0F9ED5"/>
+      </a:accent4>
+      <a:accent5>
+        <a:srgbClr val="A02B93"/>
+      </a:accent5>
+      <a:accent6>
+        <a:srgbClr val="4EA72E"/>
+      </a:accent6>
+      <a:hlink>
+        <a:srgbClr val="467886"/>
+      </a:hlink>
+      <a:folHlink>
+        <a:srgbClr val="96607D"/>
+      </a:folHlink>
+    </a:clrScheme>
+    <a:fontScheme name="Office">
+      <a:majorFont>
+        <a:latin typeface="Aptos Display" panose="02110004020202020204"/>
+        <a:ea typeface=""/>
+        <a:cs typeface=""/>
+        <a:font script="Jpan" typeface="游ゴシック Light"/>
+        <a:font script="Hang" typeface="맑은 고딕"/>
+        <a:font script="Hans" typeface="等线 Light"/>
+        <a:font script="Hant" typeface="新細明體"/>
+        <a:font script="Arab" typeface="Times New Roman"/>
+        <a:font script="Hebr" typeface="Times New Roman"/>
+        <a:font script="Thai" typeface="Angsana New"/>
+        <a:font script="Ethi" typeface="Nyala"/>
+        <a:font script="Beng" typeface="Vrinda"/>
+        <a:font script="Gujr" typeface="Shruti"/>
+        <a:font script="Khmr" typeface="MoolBoran"/>
+        <a:font script="Knda" typeface="Tunga"/>
+        <a:font script="Guru" typeface="Raavi"/>
+        <a:font script="Cans" typeface="Euphemia"/>
+        <a:font script="Cher" typeface="Plantagenet Cherokee"/>
+        <a:font script="Yiii" typeface="Microsoft Yi Baiti"/>
+        <a:font script="Tibt" typeface="Microsoft Himalaya"/>
+        <a:font script="Thaa" typeface="MV Boli"/>
+        <a:font script="Deva" typeface="Mangal"/>
+        <a:font script="Telu" typeface="Gautami"/>
+        <a:font script="Taml" typeface="Latha"/>
+        <a:font script="Syrc" typeface="Estrangelo Edessa"/>
+        <a:font script="Orya" typeface="Kalinga"/>
+        <a:font script="Mlym" typeface="Kartika"/>
+        <a:font script="Laoo" typeface="DokChampa"/>
+        <a:font script="Sinh" typeface="Iskoola Pota"/>
+        <a:font script="Mong" typeface="Mongolian Baiti"/>
+        <a:font script="Viet" typeface="Times New Roman"/>
+        <a:font script="Uigh" typeface="Microsoft Uighur"/>
+        <a:font script="Geor" typeface="Sylfaen"/>
+        <a:font script="Armn" typeface="Arial"/>
+        <a:font script="Bugi" typeface="Leelawadee UI"/>
+        <a:font script="Bopo" typeface="Microsoft JhengHei"/>
+        <a:font script="Java" typeface="Javanese Text"/>
+        <a:font script="Lisu" typeface="Segoe UI"/>
+        <a:font script="Mymr" typeface="Myanmar Text"/>
+        <a:font script="Nkoo" typeface="Ebrima"/>
+        <a:font script="Olck" typeface="Nirmala UI"/>
+        <a:font script="Osma" typeface="Ebrima"/>
+        <a:font script="Phag" typeface="Phagspa"/>
+        <a:font script="Syrn" typeface="Estrangelo Edessa"/>
+        <a:font script="Syrj" typeface="Estrangelo Edessa"/>
+        <a:font script="Syre" typeface="Estrangelo Edessa"/>
+        <a:font script="Sora" typeface="Nirmala UI"/>
+        <a:font script="Tale" typeface="Microsoft Tai Le"/>
+        <a:font script="Talu" typeface="Microsoft New Tai Lue"/>
+        <a:font script="Tfng" typeface="Ebrima"/>
+      </a:majorFont>
+      <a:minorFont>
+        <a:latin typeface="Aptos" panose="02110004020202020204"/>
+        <a:ea typeface=""/>
+        <a:cs typeface=""/>
+        <a:font script="Jpan" typeface="游ゴシック"/>
+        <a:font script="Hang" typeface="맑은 고딕"/>
+        <a:font script="Hans" typeface="等线"/>
+        <a:font script="Hant" typeface="新細明體"/>
+        <a:font script="Arab" typeface="Arial"/>
+        <a:font script="Hebr" typeface="Arial"/>
+        <a:font script="Thai" typeface="Cordia New"/>
+        <a:font script="Ethi" typeface="Nyala"/>
+        <a:font script="Beng" typeface="Vrinda"/>
+        <a:font script="Gujr" typeface="Shruti"/>
+        <a:font script="Khmr" typeface="DaunPenh"/>
+        <a:font script="Knda" typeface="Tunga"/>
+        <a:font script="Guru" typeface="Raavi"/>
+        <a:font script="Cans" typeface="Euphemia"/>
+        <a:font script="Cher" typeface="Plantagenet Cherokee"/>
+        <a:font script="Yiii" typeface="Microsoft Yi Baiti"/>
+        <a:font script="Tibt" typeface="Microsoft Himalaya"/>
+        <a:font script="Thaa" typeface="MV Boli"/>
+        <a:font script="Deva" typeface="Mangal"/>
+        <a:font script="Telu" typeface="Gautami"/>
+        <a:font script="Taml" typeface="Latha"/>
+        <a:font script="Syrc" typeface="Estrangelo Edessa"/>
+        <a:font script="Orya" typeface="Kalinga"/>
+        <a:font script="Mlym" typeface="Kartika"/>
+        <a:font script="Laoo" typeface="DokChampa"/>
+        <a:font script="Sinh" typeface="Iskoola Pota"/>
+        <a:font script="Mong" typeface="Mongolian Baiti"/>
+        <a:font script="Viet" typeface="Arial"/>
+        <a:font script="Uigh" typeface="Microsoft Uighur"/>
+        <a:font script="Geor" typeface="Sylfaen"/>
+        <a:font script="Armn" typeface="Arial"/>
+        <a:font script="Bugi" typeface="Leelawadee UI"/>
+        <a:font script="Bopo" typeface="Microsoft JhengHei"/>
+        <a:font script="Java" typeface="Javanese Text"/>
+        <a:font script="Lisu" typeface="Segoe UI"/>
+        <a:font script="Mymr" typeface="Myanmar Text"/>
+        <a:font script="Nkoo" typeface="Ebrima"/>
+        <a:font script="Olck" typeface="Nirmala UI"/>
+        <a:font script="Osma" typeface="Ebrima"/>
+        <a:font script="Phag" typeface="Phagspa"/>
+        <a:font script="Syrn" typeface="Estrangelo Edessa"/>
+        <a:font script="Syrj" typeface="Estrangelo Edessa"/>
+        <a:font script="Syre" typeface="Estrangelo Edessa"/>
+        <a:font script="Sora" typeface="Nirmala UI"/>
+        <a:font script="Tale" typeface="Microsoft Tai Le"/>
+        <a:font script="Talu" typeface="Microsoft New Tai Lue"/>
+        <a:font script="Tfng" typeface="Ebrima"/>
+      </a:minorFont>
+    </a:fontScheme>
+    <a:fmtScheme name="Office">
+      <a:fillStyleLst>
+        <a:solidFill>
+          <a:schemeClr val="phClr"/>
+        </a:solidFill>
+        <a:gradFill rotWithShape="1">
+          <a:gsLst>
+            <a:gs pos="0">
+              <a:schemeClr val="phClr">
+                <a:lumMod val="110000"/>
+                <a:satMod val="105000"/>
+                <a:tint val="67000"/>
+              </a:schemeClr>
+            </a:gs>
+            <a:gs pos="50000">
+              <a:schemeClr val="phClr">
+                <a:lumMod val="105000"/>
+                <a:satMod val="103000"/>
+                <a:tint val="73000"/>
+              </a:schemeClr>
+            </a:gs>
+            <a:gs pos="100000">
+              <a:schemeClr val="phClr">
+                <a:lumMod val="105000"/>
+                <a:satMod val="109000"/>
+                <a:tint val="81000"/>
+              </a:schemeClr>
+            </a:gs>
+          </a:gsLst>
+          <a:lin ang="5400000" scaled="0"/>
+        </a:gradFill>
+        <a:gradFill rotWithShape="1">
+          <a:gsLst>
+            <a:gs pos="0">
+              <a:schemeClr val="phClr">
+                <a:satMod val="103000"/>
+                <a:lumMod val="102000"/>
+                <a:tint val="94000"/>
+              </a:schemeClr>
+            </a:gs>
+            <a:gs pos="50000">
+              <a:schemeClr val="phClr">
+                <a:satMod val="110000"/>
+                <a:lumMod val="100000"/>
+                <a:shade val="100000"/>
+              </a:schemeClr>
+            </a:gs>
+            <a:gs pos="100000">
+              <a:schemeClr val="phClr">
+                <a:lumMod val="99000"/>
+                <a:satMod val="120000"/>
+                <a:shade val="78000"/>
+              </a:schemeClr>
+            </a:gs>
+          </a:gsLst>
+          <a:lin ang="5400000" scaled="0"/>
+        </a:gradFill>
+      </a:fillStyleLst>
+      <a:lnStyleLst>
+        <a:ln w="12700" cap="flat" cmpd="sng" algn="ctr">
+          <a:solidFill>
+            <a:schemeClr val="phClr"/>
+          </a:solidFill>
+          <a:prstDash val="solid"/>
+          <a:miter lim="800000"/>
+        </a:ln>
+        <a:ln w="19050" cap="flat" cmpd="sng" algn="ctr">
+          <a:solidFill>
+            <a:schemeClr val="phClr"/>
+          </a:solidFill>
+          <a:prstDash val="solid"/>
+          <a:miter lim="800000"/>
+        </a:ln>
+        <a:ln w="25400" cap="flat" cmpd="sng" algn="ctr">
+          <a:solidFill>
+            <a:schemeClr val="phClr"/>
+          </a:solidFill>
+          <a:prstDash val="solid"/>
+          <a:miter lim="800000"/>
+        </a:ln>
+      </a:lnStyleLst>
+      <a:effectStyleLst>
+        <a:effectStyle>
+          <a:effectLst/>
+        </a:effectStyle>
+        <a:effectStyle>
+          <a:effectLst/>
+        </a:effectStyle>
+        <a:effectStyle>
+          <a:effectLst>
+            <a:outerShdw blurRad="57150" dist="19050" dir="5400000" algn="ctr" rotWithShape="0">
+              <a:srgbClr val="000000">
+                <a:alpha val="63000"/>
+              </a:srgbClr>
+            </a:outerShdw>
+          </a:effectLst>
+        </a:effectStyle>
+      </a:effectStyleLst>
+      <a:bgFillStyleLst>
+        <a:solidFill>
+          <a:schemeClr val="phClr"/>
+        </a:solidFill>
+        <a:solidFill>
+          <a:schemeClr val="phClr">
+            <a:tint val="95000"/>
+            <a:satMod val="170000"/>
+          </a:schemeClr>
+        </a:solidFill>
+        <a:gradFill rotWithShape="1">
+          <a:gsLst>
+            <a:gs pos="0">
+              <a:schemeClr val="phClr">
+                <a:tint val="93000"/>
+                <a:satMod val="150000"/>
+                <a:shade val="98000"/>
+                <a:lumMod val="102000"/>
+              </a:schemeClr>
+            </a:gs>
+            <a:gs pos="50000">
+              <a:schemeClr val="phClr">
+                <a:tint val="98000"/>
+                <a:satMod val="130000"/>
+                <a:shade val="90000"/>
+                <a:lumMod val="103000"/>
+              </a:schemeClr>
+            </a:gs>
+            <a:gs pos="100000">
+              <a:schemeClr val="phClr">
+                <a:shade val="63000"/>
+                <a:satMod val="120000"/>
+              </a:schemeClr>
+            </a:gs>
+          </a:gsLst>
+          <a:lin ang="5400000" scaled="0"/>
+        </a:gradFill>
+      </a:bgFillStyleLst>
+    </a:fmtScheme>
+  </a:themeElements>
+  <a:objectDefaults>
+    <a:lnDef>
+      <a:spPr/>
+      <a:bodyPr/>
+      <a:lstStyle/>
+      <a:style>
+        <a:lnRef idx="2">
+          <a:schemeClr val="accent1"/>
+        </a:lnRef>
+        <a:fillRef idx="0">
+          <a:schemeClr val="accent1"/>
+        </a:fillRef>
+        <a:effectRef idx="1">
+          <a:schemeClr val="accent1"/>
+        </a:effectRef>
+        <a:fontRef idx="minor">
+          <a:schemeClr val="tx1"/>
+        </a:fontRef>
+      </a:style>
+    </a:lnDef>
+  </a:objectDefaults>
+  <a:extraClrSchemeLst/>
+  <a:extLst>
+    <a:ext uri="{05A4C25C-085E-4340-85A3-A5531E510DB2}">
+      <thm15:themeFamily xmlns:thm15="http://schemas.microsoft.com/office/thememl/2012/main" name="Office Theme" id="{2E142A2C-CD16-42D6-873A-C26D2A0506FA}" vid="{1BDDFF52-6CD6-40A5-AB3C-68EB2F1E4D0A}"/>
+    </a:ext>
+  </a:extLst>
+</a:theme>
 </file>
</xml_diff>